<commit_message>
Fixing poster layout and graphs
</commit_message>
<xml_diff>
--- a/ReadZ_GCReW_Symposium_Poster_2026.pptx
+++ b/ReadZ_GCReW_Symposium_Poster_2026.pptx
@@ -135,7 +135,7 @@
 <file path=ppt/revisionInfo.xml><?xml version="1.0" encoding="utf-8"?>
 <p1510:revInfo xmlns:a="http://schemas.openxmlformats.org/drawingml/2006/main" xmlns:r="http://schemas.openxmlformats.org/officeDocument/2006/relationships" xmlns:p1510="http://schemas.microsoft.com/office/powerpoint/2015/10/main">
   <p1510:revLst>
-    <p1510:client id="{B82716F6-75B8-4E39-A6D4-7E66C823071B}" v="25" dt="2026-03-12T20:26:21.074"/>
+    <p1510:client id="{B82716F6-75B8-4E39-A6D4-7E66C823071B}" v="66" dt="2026-03-13T15:58:09.715"/>
   </p1510:revLst>
 </p1510:revInfo>
 </file>
@@ -145,18 +145,18 @@
   <pc:docChgLst>
     <pc:chgData name="Read, Zoe" userId="b08cd0fd-26d2-470b-8ec0-c6e6cb2a79bd" providerId="ADAL" clId="{5AEB2719-95A5-4ED2-9E0E-ED462BB10526}"/>
     <pc:docChg chg="undo custSel addSld delSld modSld">
-      <pc:chgData name="Read, Zoe" userId="b08cd0fd-26d2-470b-8ec0-c6e6cb2a79bd" providerId="ADAL" clId="{5AEB2719-95A5-4ED2-9E0E-ED462BB10526}" dt="2026-03-12T20:26:39.354" v="3596" actId="1076"/>
+      <pc:chgData name="Read, Zoe" userId="b08cd0fd-26d2-470b-8ec0-c6e6cb2a79bd" providerId="ADAL" clId="{5AEB2719-95A5-4ED2-9E0E-ED462BB10526}" dt="2026-03-13T16:03:05.847" v="5463" actId="1035"/>
       <pc:docMkLst>
         <pc:docMk/>
       </pc:docMkLst>
       <pc:sldChg chg="addSp delSp modSp mod modNotesTx">
-        <pc:chgData name="Read, Zoe" userId="b08cd0fd-26d2-470b-8ec0-c6e6cb2a79bd" providerId="ADAL" clId="{5AEB2719-95A5-4ED2-9E0E-ED462BB10526}" dt="2026-03-12T20:26:39.354" v="3596" actId="1076"/>
+        <pc:chgData name="Read, Zoe" userId="b08cd0fd-26d2-470b-8ec0-c6e6cb2a79bd" providerId="ADAL" clId="{5AEB2719-95A5-4ED2-9E0E-ED462BB10526}" dt="2026-03-13T16:03:05.847" v="5463" actId="1035"/>
         <pc:sldMkLst>
           <pc:docMk/>
           <pc:sldMk cId="2005456116" sldId="257"/>
         </pc:sldMkLst>
         <pc:spChg chg="mod">
-          <ac:chgData name="Read, Zoe" userId="b08cd0fd-26d2-470b-8ec0-c6e6cb2a79bd" providerId="ADAL" clId="{5AEB2719-95A5-4ED2-9E0E-ED462BB10526}" dt="2026-03-12T20:26:36.594" v="3595" actId="1076"/>
+          <ac:chgData name="Read, Zoe" userId="b08cd0fd-26d2-470b-8ec0-c6e6cb2a79bd" providerId="ADAL" clId="{5AEB2719-95A5-4ED2-9E0E-ED462BB10526}" dt="2026-03-13T14:12:22.411" v="3683" actId="1035"/>
           <ac:spMkLst>
             <pc:docMk/>
             <pc:sldMk cId="2005456116" sldId="257"/>
@@ -164,7 +164,7 @@
           </ac:spMkLst>
         </pc:spChg>
         <pc:spChg chg="mod">
-          <ac:chgData name="Read, Zoe" userId="b08cd0fd-26d2-470b-8ec0-c6e6cb2a79bd" providerId="ADAL" clId="{5AEB2719-95A5-4ED2-9E0E-ED462BB10526}" dt="2026-03-12T20:26:39.354" v="3596" actId="1076"/>
+          <ac:chgData name="Read, Zoe" userId="b08cd0fd-26d2-470b-8ec0-c6e6cb2a79bd" providerId="ADAL" clId="{5AEB2719-95A5-4ED2-9E0E-ED462BB10526}" dt="2026-03-13T14:13:07.872" v="3705"/>
           <ac:spMkLst>
             <pc:docMk/>
             <pc:sldMk cId="2005456116" sldId="257"/>
@@ -172,15 +172,15 @@
           </ac:spMkLst>
         </pc:spChg>
         <pc:spChg chg="add mod">
-          <ac:chgData name="Read, Zoe" userId="b08cd0fd-26d2-470b-8ec0-c6e6cb2a79bd" providerId="ADAL" clId="{5AEB2719-95A5-4ED2-9E0E-ED462BB10526}" dt="2026-03-12T20:26:21.074" v="3593" actId="1035"/>
+          <ac:chgData name="Read, Zoe" userId="b08cd0fd-26d2-470b-8ec0-c6e6cb2a79bd" providerId="ADAL" clId="{5AEB2719-95A5-4ED2-9E0E-ED462BB10526}" dt="2026-03-13T15:50:37.852" v="5095" actId="1036"/>
           <ac:spMkLst>
             <pc:docMk/>
             <pc:sldMk cId="2005456116" sldId="257"/>
             <ac:spMk id="5" creationId="{611D73CC-38EE-87A4-659B-7AFB71426A3B}"/>
           </ac:spMkLst>
         </pc:spChg>
-        <pc:spChg chg="add mod">
-          <ac:chgData name="Read, Zoe" userId="b08cd0fd-26d2-470b-8ec0-c6e6cb2a79bd" providerId="ADAL" clId="{5AEB2719-95A5-4ED2-9E0E-ED462BB10526}" dt="2026-03-12T20:26:21.074" v="3593" actId="1035"/>
+        <pc:spChg chg="add mod ord">
+          <ac:chgData name="Read, Zoe" userId="b08cd0fd-26d2-470b-8ec0-c6e6cb2a79bd" providerId="ADAL" clId="{5AEB2719-95A5-4ED2-9E0E-ED462BB10526}" dt="2026-03-13T15:23:26.809" v="5040" actId="1036"/>
           <ac:spMkLst>
             <pc:docMk/>
             <pc:sldMk cId="2005456116" sldId="257"/>
@@ -196,7 +196,7 @@
           </ac:spMkLst>
         </pc:spChg>
         <pc:spChg chg="mod">
-          <ac:chgData name="Read, Zoe" userId="b08cd0fd-26d2-470b-8ec0-c6e6cb2a79bd" providerId="ADAL" clId="{5AEB2719-95A5-4ED2-9E0E-ED462BB10526}" dt="2026-03-12T20:26:21.074" v="3593" actId="1035"/>
+          <ac:chgData name="Read, Zoe" userId="b08cd0fd-26d2-470b-8ec0-c6e6cb2a79bd" providerId="ADAL" clId="{5AEB2719-95A5-4ED2-9E0E-ED462BB10526}" dt="2026-03-13T15:56:17.329" v="5363" actId="1036"/>
           <ac:spMkLst>
             <pc:docMk/>
             <pc:sldMk cId="2005456116" sldId="257"/>
@@ -204,7 +204,7 @@
           </ac:spMkLst>
         </pc:spChg>
         <pc:spChg chg="mod">
-          <ac:chgData name="Read, Zoe" userId="b08cd0fd-26d2-470b-8ec0-c6e6cb2a79bd" providerId="ADAL" clId="{5AEB2719-95A5-4ED2-9E0E-ED462BB10526}" dt="2026-03-12T20:16:02.170" v="3521" actId="1076"/>
+          <ac:chgData name="Read, Zoe" userId="b08cd0fd-26d2-470b-8ec0-c6e6cb2a79bd" providerId="ADAL" clId="{5AEB2719-95A5-4ED2-9E0E-ED462BB10526}" dt="2026-03-13T15:50:15.459" v="5087" actId="1036"/>
           <ac:spMkLst>
             <pc:docMk/>
             <pc:sldMk cId="2005456116" sldId="257"/>
@@ -212,7 +212,7 @@
           </ac:spMkLst>
         </pc:spChg>
         <pc:spChg chg="mod">
-          <ac:chgData name="Read, Zoe" userId="b08cd0fd-26d2-470b-8ec0-c6e6cb2a79bd" providerId="ADAL" clId="{5AEB2719-95A5-4ED2-9E0E-ED462BB10526}" dt="2026-03-12T20:16:02.170" v="3521" actId="1076"/>
+          <ac:chgData name="Read, Zoe" userId="b08cd0fd-26d2-470b-8ec0-c6e6cb2a79bd" providerId="ADAL" clId="{5AEB2719-95A5-4ED2-9E0E-ED462BB10526}" dt="2026-03-13T15:50:15.459" v="5087" actId="1036"/>
           <ac:spMkLst>
             <pc:docMk/>
             <pc:sldMk cId="2005456116" sldId="257"/>
@@ -220,7 +220,7 @@
           </ac:spMkLst>
         </pc:spChg>
         <pc:spChg chg="mod">
-          <ac:chgData name="Read, Zoe" userId="b08cd0fd-26d2-470b-8ec0-c6e6cb2a79bd" providerId="ADAL" clId="{5AEB2719-95A5-4ED2-9E0E-ED462BB10526}" dt="2026-03-12T20:16:02.170" v="3521" actId="1076"/>
+          <ac:chgData name="Read, Zoe" userId="b08cd0fd-26d2-470b-8ec0-c6e6cb2a79bd" providerId="ADAL" clId="{5AEB2719-95A5-4ED2-9E0E-ED462BB10526}" dt="2026-03-13T15:50:15.459" v="5087" actId="1036"/>
           <ac:spMkLst>
             <pc:docMk/>
             <pc:sldMk cId="2005456116" sldId="257"/>
@@ -228,7 +228,7 @@
           </ac:spMkLst>
         </pc:spChg>
         <pc:spChg chg="mod">
-          <ac:chgData name="Read, Zoe" userId="b08cd0fd-26d2-470b-8ec0-c6e6cb2a79bd" providerId="ADAL" clId="{5AEB2719-95A5-4ED2-9E0E-ED462BB10526}" dt="2026-03-12T20:16:02.170" v="3521" actId="1076"/>
+          <ac:chgData name="Read, Zoe" userId="b08cd0fd-26d2-470b-8ec0-c6e6cb2a79bd" providerId="ADAL" clId="{5AEB2719-95A5-4ED2-9E0E-ED462BB10526}" dt="2026-03-13T15:50:15.459" v="5087" actId="1036"/>
           <ac:spMkLst>
             <pc:docMk/>
             <pc:sldMk cId="2005456116" sldId="257"/>
@@ -236,7 +236,7 @@
           </ac:spMkLst>
         </pc:spChg>
         <pc:spChg chg="mod">
-          <ac:chgData name="Read, Zoe" userId="b08cd0fd-26d2-470b-8ec0-c6e6cb2a79bd" providerId="ADAL" clId="{5AEB2719-95A5-4ED2-9E0E-ED462BB10526}" dt="2026-03-12T20:26:21.074" v="3593" actId="1035"/>
+          <ac:chgData name="Read, Zoe" userId="b08cd0fd-26d2-470b-8ec0-c6e6cb2a79bd" providerId="ADAL" clId="{5AEB2719-95A5-4ED2-9E0E-ED462BB10526}" dt="2026-03-13T15:50:15.459" v="5087" actId="1036"/>
           <ac:spMkLst>
             <pc:docMk/>
             <pc:sldMk cId="2005456116" sldId="257"/>
@@ -244,7 +244,7 @@
           </ac:spMkLst>
         </pc:spChg>
         <pc:spChg chg="mod">
-          <ac:chgData name="Read, Zoe" userId="b08cd0fd-26d2-470b-8ec0-c6e6cb2a79bd" providerId="ADAL" clId="{5AEB2719-95A5-4ED2-9E0E-ED462BB10526}" dt="2026-03-12T20:26:21.074" v="3593" actId="1035"/>
+          <ac:chgData name="Read, Zoe" userId="b08cd0fd-26d2-470b-8ec0-c6e6cb2a79bd" providerId="ADAL" clId="{5AEB2719-95A5-4ED2-9E0E-ED462BB10526}" dt="2026-03-13T15:50:15.459" v="5087" actId="1036"/>
           <ac:spMkLst>
             <pc:docMk/>
             <pc:sldMk cId="2005456116" sldId="257"/>
@@ -252,7 +252,7 @@
           </ac:spMkLst>
         </pc:spChg>
         <pc:spChg chg="mod">
-          <ac:chgData name="Read, Zoe" userId="b08cd0fd-26d2-470b-8ec0-c6e6cb2a79bd" providerId="ADAL" clId="{5AEB2719-95A5-4ED2-9E0E-ED462BB10526}" dt="2026-03-12T20:16:02.170" v="3521" actId="1076"/>
+          <ac:chgData name="Read, Zoe" userId="b08cd0fd-26d2-470b-8ec0-c6e6cb2a79bd" providerId="ADAL" clId="{5AEB2719-95A5-4ED2-9E0E-ED462BB10526}" dt="2026-03-13T15:50:15.459" v="5087" actId="1036"/>
           <ac:spMkLst>
             <pc:docMk/>
             <pc:sldMk cId="2005456116" sldId="257"/>
@@ -276,7 +276,7 @@
           </ac:spMkLst>
         </pc:spChg>
         <pc:spChg chg="mod">
-          <ac:chgData name="Read, Zoe" userId="b08cd0fd-26d2-470b-8ec0-c6e6cb2a79bd" providerId="ADAL" clId="{5AEB2719-95A5-4ED2-9E0E-ED462BB10526}" dt="2026-03-12T20:26:21.074" v="3593" actId="1035"/>
+          <ac:chgData name="Read, Zoe" userId="b08cd0fd-26d2-470b-8ec0-c6e6cb2a79bd" providerId="ADAL" clId="{5AEB2719-95A5-4ED2-9E0E-ED462BB10526}" dt="2026-03-13T15:50:15.459" v="5087" actId="1036"/>
           <ac:spMkLst>
             <pc:docMk/>
             <pc:sldMk cId="2005456116" sldId="257"/>
@@ -284,7 +284,7 @@
           </ac:spMkLst>
         </pc:spChg>
         <pc:spChg chg="mod">
-          <ac:chgData name="Read, Zoe" userId="b08cd0fd-26d2-470b-8ec0-c6e6cb2a79bd" providerId="ADAL" clId="{5AEB2719-95A5-4ED2-9E0E-ED462BB10526}" dt="2026-03-12T20:26:21.074" v="3593" actId="1035"/>
+          <ac:chgData name="Read, Zoe" userId="b08cd0fd-26d2-470b-8ec0-c6e6cb2a79bd" providerId="ADAL" clId="{5AEB2719-95A5-4ED2-9E0E-ED462BB10526}" dt="2026-03-13T15:50:15.459" v="5087" actId="1036"/>
           <ac:spMkLst>
             <pc:docMk/>
             <pc:sldMk cId="2005456116" sldId="257"/>
@@ -292,7 +292,7 @@
           </ac:spMkLst>
         </pc:spChg>
         <pc:spChg chg="mod">
-          <ac:chgData name="Read, Zoe" userId="b08cd0fd-26d2-470b-8ec0-c6e6cb2a79bd" providerId="ADAL" clId="{5AEB2719-95A5-4ED2-9E0E-ED462BB10526}" dt="2026-03-12T20:16:02.170" v="3521" actId="1076"/>
+          <ac:chgData name="Read, Zoe" userId="b08cd0fd-26d2-470b-8ec0-c6e6cb2a79bd" providerId="ADAL" clId="{5AEB2719-95A5-4ED2-9E0E-ED462BB10526}" dt="2026-03-13T15:50:15.459" v="5087" actId="1036"/>
           <ac:spMkLst>
             <pc:docMk/>
             <pc:sldMk cId="2005456116" sldId="257"/>
@@ -300,7 +300,7 @@
           </ac:spMkLst>
         </pc:spChg>
         <pc:spChg chg="add mod">
-          <ac:chgData name="Read, Zoe" userId="b08cd0fd-26d2-470b-8ec0-c6e6cb2a79bd" providerId="ADAL" clId="{5AEB2719-95A5-4ED2-9E0E-ED462BB10526}" dt="2026-03-12T20:15:08.333" v="3512" actId="20577"/>
+          <ac:chgData name="Read, Zoe" userId="b08cd0fd-26d2-470b-8ec0-c6e6cb2a79bd" providerId="ADAL" clId="{5AEB2719-95A5-4ED2-9E0E-ED462BB10526}" dt="2026-03-13T15:23:06.072" v="5035" actId="255"/>
           <ac:spMkLst>
             <pc:docMk/>
             <pc:sldMk cId="2005456116" sldId="257"/>
@@ -308,7 +308,7 @@
           </ac:spMkLst>
         </pc:spChg>
         <pc:spChg chg="add mod">
-          <ac:chgData name="Read, Zoe" userId="b08cd0fd-26d2-470b-8ec0-c6e6cb2a79bd" providerId="ADAL" clId="{5AEB2719-95A5-4ED2-9E0E-ED462BB10526}" dt="2026-03-12T20:16:16.234" v="3524" actId="1076"/>
+          <ac:chgData name="Read, Zoe" userId="b08cd0fd-26d2-470b-8ec0-c6e6cb2a79bd" providerId="ADAL" clId="{5AEB2719-95A5-4ED2-9E0E-ED462BB10526}" dt="2026-03-13T15:20:46.824" v="5011" actId="113"/>
           <ac:spMkLst>
             <pc:docMk/>
             <pc:sldMk cId="2005456116" sldId="257"/>
@@ -316,7 +316,7 @@
           </ac:spMkLst>
         </pc:spChg>
         <pc:spChg chg="add mod">
-          <ac:chgData name="Read, Zoe" userId="b08cd0fd-26d2-470b-8ec0-c6e6cb2a79bd" providerId="ADAL" clId="{5AEB2719-95A5-4ED2-9E0E-ED462BB10526}" dt="2026-03-12T20:16:28.154" v="3529" actId="1076"/>
+          <ac:chgData name="Read, Zoe" userId="b08cd0fd-26d2-470b-8ec0-c6e6cb2a79bd" providerId="ADAL" clId="{5AEB2719-95A5-4ED2-9E0E-ED462BB10526}" dt="2026-03-13T16:03:03.034" v="5459" actId="14100"/>
           <ac:spMkLst>
             <pc:docMk/>
             <pc:sldMk cId="2005456116" sldId="257"/>
@@ -324,11 +324,19 @@
           </ac:spMkLst>
         </pc:spChg>
         <pc:spChg chg="mod">
-          <ac:chgData name="Read, Zoe" userId="b08cd0fd-26d2-470b-8ec0-c6e6cb2a79bd" providerId="ADAL" clId="{5AEB2719-95A5-4ED2-9E0E-ED462BB10526}" dt="2026-03-12T20:26:21.074" v="3593" actId="1035"/>
+          <ac:chgData name="Read, Zoe" userId="b08cd0fd-26d2-470b-8ec0-c6e6cb2a79bd" providerId="ADAL" clId="{5AEB2719-95A5-4ED2-9E0E-ED462BB10526}" dt="2026-03-13T15:21:03.987" v="5014" actId="255"/>
           <ac:spMkLst>
             <pc:docMk/>
             <pc:sldMk cId="2005456116" sldId="257"/>
             <ac:spMk id="1046" creationId="{3D22E29A-542C-2707-EE87-D32E923FD26A}"/>
+          </ac:spMkLst>
+        </pc:spChg>
+        <pc:spChg chg="add mod">
+          <ac:chgData name="Read, Zoe" userId="b08cd0fd-26d2-470b-8ec0-c6e6cb2a79bd" providerId="ADAL" clId="{5AEB2719-95A5-4ED2-9E0E-ED462BB10526}" dt="2026-03-13T16:02:51.168" v="5458" actId="5793"/>
+          <ac:spMkLst>
+            <pc:docMk/>
+            <pc:sldMk cId="2005456116" sldId="257"/>
+            <ac:spMk id="1106" creationId="{990614C8-403D-9EED-A601-7B130D60F6F4}"/>
           </ac:spMkLst>
         </pc:spChg>
         <pc:grpChg chg="del">
@@ -347,36 +355,60 @@
             <ac:graphicFrameMk id="20" creationId="{6EE1AE5B-A26D-71DD-8EF3-D283BC117F1C}"/>
           </ac:graphicFrameMkLst>
         </pc:graphicFrameChg>
-        <pc:picChg chg="add mod modCrop">
-          <ac:chgData name="Read, Zoe" userId="b08cd0fd-26d2-470b-8ec0-c6e6cb2a79bd" providerId="ADAL" clId="{5AEB2719-95A5-4ED2-9E0E-ED462BB10526}" dt="2026-03-12T20:10:12.242" v="3170" actId="1076"/>
+        <pc:picChg chg="add del mod">
+          <ac:chgData name="Read, Zoe" userId="b08cd0fd-26d2-470b-8ec0-c6e6cb2a79bd" providerId="ADAL" clId="{5AEB2719-95A5-4ED2-9E0E-ED462BB10526}" dt="2026-03-13T14:36:32.963" v="3889" actId="478"/>
+          <ac:picMkLst>
+            <pc:docMk/>
+            <pc:sldMk cId="2005456116" sldId="257"/>
+            <ac:picMk id="6" creationId="{E193A4F9-DEAF-C6DE-2623-1C1E36DBB696}"/>
+          </ac:picMkLst>
+        </pc:picChg>
+        <pc:picChg chg="add del mod modCrop">
+          <ac:chgData name="Read, Zoe" userId="b08cd0fd-26d2-470b-8ec0-c6e6cb2a79bd" providerId="ADAL" clId="{5AEB2719-95A5-4ED2-9E0E-ED462BB10526}" dt="2026-03-13T14:35:54.830" v="3882" actId="478"/>
           <ac:picMkLst>
             <pc:docMk/>
             <pc:sldMk cId="2005456116" sldId="257"/>
             <ac:picMk id="9" creationId="{09EDF015-AC84-7DA3-BD5A-225267C491D7}"/>
           </ac:picMkLst>
         </pc:picChg>
+        <pc:picChg chg="add del mod">
+          <ac:chgData name="Read, Zoe" userId="b08cd0fd-26d2-470b-8ec0-c6e6cb2a79bd" providerId="ADAL" clId="{5AEB2719-95A5-4ED2-9E0E-ED462BB10526}" dt="2026-03-13T14:37:42.624" v="3894" actId="478"/>
+          <ac:picMkLst>
+            <pc:docMk/>
+            <pc:sldMk cId="2005456116" sldId="257"/>
+            <ac:picMk id="10" creationId="{87488FFA-0267-8CB3-3D6F-2F08271CB032}"/>
+          </ac:picMkLst>
+        </pc:picChg>
         <pc:picChg chg="add mod ord modCrop">
-          <ac:chgData name="Read, Zoe" userId="b08cd0fd-26d2-470b-8ec0-c6e6cb2a79bd" providerId="ADAL" clId="{5AEB2719-95A5-4ED2-9E0E-ED462BB10526}" dt="2026-03-12T20:15:13.625" v="3513" actId="1076"/>
+          <ac:chgData name="Read, Zoe" userId="b08cd0fd-26d2-470b-8ec0-c6e6cb2a79bd" providerId="ADAL" clId="{5AEB2719-95A5-4ED2-9E0E-ED462BB10526}" dt="2026-03-13T15:05:28.661" v="4916" actId="1076"/>
           <ac:picMkLst>
             <pc:docMk/>
             <pc:sldMk cId="2005456116" sldId="257"/>
             <ac:picMk id="11" creationId="{0144416F-2A82-F7CC-0427-8A36932666F6}"/>
           </ac:picMkLst>
         </pc:picChg>
-        <pc:picChg chg="add mod">
-          <ac:chgData name="Read, Zoe" userId="b08cd0fd-26d2-470b-8ec0-c6e6cb2a79bd" providerId="ADAL" clId="{5AEB2719-95A5-4ED2-9E0E-ED462BB10526}" dt="2026-03-12T20:16:30.754" v="3531" actId="1076"/>
+        <pc:picChg chg="add del mod">
+          <ac:chgData name="Read, Zoe" userId="b08cd0fd-26d2-470b-8ec0-c6e6cb2a79bd" providerId="ADAL" clId="{5AEB2719-95A5-4ED2-9E0E-ED462BB10526}" dt="2026-03-13T15:26:55.493" v="5045" actId="478"/>
           <ac:picMkLst>
             <pc:docMk/>
             <pc:sldMk cId="2005456116" sldId="257"/>
             <ac:picMk id="14" creationId="{37395166-1C97-2974-4774-B9647BFFD3B0}"/>
           </ac:picMkLst>
         </pc:picChg>
-        <pc:picChg chg="add mod ord modCrop">
-          <ac:chgData name="Read, Zoe" userId="b08cd0fd-26d2-470b-8ec0-c6e6cb2a79bd" providerId="ADAL" clId="{5AEB2719-95A5-4ED2-9E0E-ED462BB10526}" dt="2026-03-12T20:16:20.411" v="3526" actId="1076"/>
+        <pc:picChg chg="add del mod ord modCrop">
+          <ac:chgData name="Read, Zoe" userId="b08cd0fd-26d2-470b-8ec0-c6e6cb2a79bd" providerId="ADAL" clId="{5AEB2719-95A5-4ED2-9E0E-ED462BB10526}" dt="2026-03-13T15:13:14.944" v="4945" actId="478"/>
           <ac:picMkLst>
             <pc:docMk/>
             <pc:sldMk cId="2005456116" sldId="257"/>
             <ac:picMk id="15" creationId="{6F1E99EB-549B-E9F4-C4C6-CCFBCE759AD8}"/>
+          </ac:picMkLst>
+        </pc:picChg>
+        <pc:picChg chg="add del mod">
+          <ac:chgData name="Read, Zoe" userId="b08cd0fd-26d2-470b-8ec0-c6e6cb2a79bd" providerId="ADAL" clId="{5AEB2719-95A5-4ED2-9E0E-ED462BB10526}" dt="2026-03-13T14:58:09.041" v="4859" actId="478"/>
+          <ac:picMkLst>
+            <pc:docMk/>
+            <pc:sldMk cId="2005456116" sldId="257"/>
+            <ac:picMk id="19" creationId="{4A548E57-4FEC-FC9E-37C8-9C6818770C12}"/>
           </ac:picMkLst>
         </pc:picChg>
         <pc:picChg chg="del mod">
@@ -395,16 +427,232 @@
             <ac:picMk id="24" creationId="{04440FAB-EE3F-FD41-C5C0-9224F3ADC6B1}"/>
           </ac:picMkLst>
         </pc:picChg>
-        <pc:picChg chg="add mod modCrop">
-          <ac:chgData name="Read, Zoe" userId="b08cd0fd-26d2-470b-8ec0-c6e6cb2a79bd" providerId="ADAL" clId="{5AEB2719-95A5-4ED2-9E0E-ED462BB10526}" dt="2026-03-12T20:16:18.962" v="3525" actId="1076"/>
+        <pc:picChg chg="add del mod">
+          <ac:chgData name="Read, Zoe" userId="b08cd0fd-26d2-470b-8ec0-c6e6cb2a79bd" providerId="ADAL" clId="{5AEB2719-95A5-4ED2-9E0E-ED462BB10526}" dt="2026-03-13T15:01:01.939" v="4868" actId="478"/>
+          <ac:picMkLst>
+            <pc:docMk/>
+            <pc:sldMk cId="2005456116" sldId="257"/>
+            <ac:picMk id="24" creationId="{3F0569DE-707F-D9F1-1D75-6E1DDB13B5E4}"/>
+          </ac:picMkLst>
+        </pc:picChg>
+        <pc:picChg chg="add del mod ord">
+          <ac:chgData name="Read, Zoe" userId="b08cd0fd-26d2-470b-8ec0-c6e6cb2a79bd" providerId="ADAL" clId="{5AEB2719-95A5-4ED2-9E0E-ED462BB10526}" dt="2026-03-13T15:01:53.310" v="4884" actId="478"/>
+          <ac:picMkLst>
+            <pc:docMk/>
+            <pc:sldMk cId="2005456116" sldId="257"/>
+            <ac:picMk id="1038" creationId="{79B545FE-4759-2D41-AC8C-49367F5FD302}"/>
+          </ac:picMkLst>
+        </pc:picChg>
+        <pc:picChg chg="add del mod">
+          <ac:chgData name="Read, Zoe" userId="b08cd0fd-26d2-470b-8ec0-c6e6cb2a79bd" providerId="ADAL" clId="{5AEB2719-95A5-4ED2-9E0E-ED462BB10526}" dt="2026-03-13T15:02:36.270" v="4894" actId="478"/>
+          <ac:picMkLst>
+            <pc:docMk/>
+            <pc:sldMk cId="2005456116" sldId="257"/>
+            <ac:picMk id="1041" creationId="{C6F1CF14-BF24-F636-555B-EE0412FF8575}"/>
+          </ac:picMkLst>
+        </pc:picChg>
+        <pc:picChg chg="add del mod modCrop">
+          <ac:chgData name="Read, Zoe" userId="b08cd0fd-26d2-470b-8ec0-c6e6cb2a79bd" providerId="ADAL" clId="{5AEB2719-95A5-4ED2-9E0E-ED462BB10526}" dt="2026-03-13T15:13:14.944" v="4945" actId="478"/>
           <ac:picMkLst>
             <pc:docMk/>
             <pc:sldMk cId="2005456116" sldId="257"/>
             <ac:picMk id="1042" creationId="{04363E67-54FD-37B3-65BB-A8173A952E9D}"/>
           </ac:picMkLst>
         </pc:picChg>
+        <pc:picChg chg="add del mod">
+          <ac:chgData name="Read, Zoe" userId="b08cd0fd-26d2-470b-8ec0-c6e6cb2a79bd" providerId="ADAL" clId="{5AEB2719-95A5-4ED2-9E0E-ED462BB10526}" dt="2026-03-13T15:06:17.977" v="4922" actId="478"/>
+          <ac:picMkLst>
+            <pc:docMk/>
+            <pc:sldMk cId="2005456116" sldId="257"/>
+            <ac:picMk id="1048" creationId="{3A2666A1-2DC7-950A-723E-6840B5BC5392}"/>
+          </ac:picMkLst>
+        </pc:picChg>
+        <pc:picChg chg="add del mod">
+          <ac:chgData name="Read, Zoe" userId="b08cd0fd-26d2-470b-8ec0-c6e6cb2a79bd" providerId="ADAL" clId="{5AEB2719-95A5-4ED2-9E0E-ED462BB10526}" dt="2026-03-13T15:06:58.060" v="4929" actId="478"/>
+          <ac:picMkLst>
+            <pc:docMk/>
+            <pc:sldMk cId="2005456116" sldId="257"/>
+            <ac:picMk id="1059" creationId="{EB3694CB-2E69-2599-592D-A9902BAD3ADD}"/>
+          </ac:picMkLst>
+        </pc:picChg>
+        <pc:picChg chg="add del mod">
+          <ac:chgData name="Read, Zoe" userId="b08cd0fd-26d2-470b-8ec0-c6e6cb2a79bd" providerId="ADAL" clId="{5AEB2719-95A5-4ED2-9E0E-ED462BB10526}" dt="2026-03-13T15:07:38.327" v="4937" actId="478"/>
+          <ac:picMkLst>
+            <pc:docMk/>
+            <pc:sldMk cId="2005456116" sldId="257"/>
+            <ac:picMk id="1061" creationId="{5C64DEE6-3355-98B2-AC38-10A3DD327236}"/>
+          </ac:picMkLst>
+        </pc:picChg>
+        <pc:picChg chg="add del mod">
+          <ac:chgData name="Read, Zoe" userId="b08cd0fd-26d2-470b-8ec0-c6e6cb2a79bd" providerId="ADAL" clId="{5AEB2719-95A5-4ED2-9E0E-ED462BB10526}" dt="2026-03-13T15:08:12.270" v="4943" actId="478"/>
+          <ac:picMkLst>
+            <pc:docMk/>
+            <pc:sldMk cId="2005456116" sldId="257"/>
+            <ac:picMk id="1063" creationId="{AC1EC631-C193-3A00-6730-F1F2DABABD96}"/>
+          </ac:picMkLst>
+        </pc:picChg>
+        <pc:picChg chg="add del mod">
+          <ac:chgData name="Read, Zoe" userId="b08cd0fd-26d2-470b-8ec0-c6e6cb2a79bd" providerId="ADAL" clId="{5AEB2719-95A5-4ED2-9E0E-ED462BB10526}" dt="2026-03-13T15:22:30.164" v="5023" actId="478"/>
+          <ac:picMkLst>
+            <pc:docMk/>
+            <pc:sldMk cId="2005456116" sldId="257"/>
+            <ac:picMk id="1065" creationId="{D9220666-D88E-9558-B956-D1D5B159C76E}"/>
+          </ac:picMkLst>
+        </pc:picChg>
+        <pc:picChg chg="add del mod">
+          <ac:chgData name="Read, Zoe" userId="b08cd0fd-26d2-470b-8ec0-c6e6cb2a79bd" providerId="ADAL" clId="{5AEB2719-95A5-4ED2-9E0E-ED462BB10526}" dt="2026-03-13T15:14:14.848" v="4949" actId="478"/>
+          <ac:picMkLst>
+            <pc:docMk/>
+            <pc:sldMk cId="2005456116" sldId="257"/>
+            <ac:picMk id="1067" creationId="{2E554507-40AB-39F1-06F7-5ACA98D452FD}"/>
+          </ac:picMkLst>
+        </pc:picChg>
+        <pc:picChg chg="add del mod">
+          <ac:chgData name="Read, Zoe" userId="b08cd0fd-26d2-470b-8ec0-c6e6cb2a79bd" providerId="ADAL" clId="{5AEB2719-95A5-4ED2-9E0E-ED462BB10526}" dt="2026-03-13T15:14:29.167" v="4954" actId="478"/>
+          <ac:picMkLst>
+            <pc:docMk/>
+            <pc:sldMk cId="2005456116" sldId="257"/>
+            <ac:picMk id="1069" creationId="{8D91DBDB-9E9E-52CB-55AD-9A637EFC0709}"/>
+          </ac:picMkLst>
+        </pc:picChg>
+        <pc:picChg chg="add del mod">
+          <ac:chgData name="Read, Zoe" userId="b08cd0fd-26d2-470b-8ec0-c6e6cb2a79bd" providerId="ADAL" clId="{5AEB2719-95A5-4ED2-9E0E-ED462BB10526}" dt="2026-03-13T15:15:01.560" v="4958" actId="478"/>
+          <ac:picMkLst>
+            <pc:docMk/>
+            <pc:sldMk cId="2005456116" sldId="257"/>
+            <ac:picMk id="1071" creationId="{FEABA2EA-EFA6-54BC-2013-B77804E53F02}"/>
+          </ac:picMkLst>
+        </pc:picChg>
+        <pc:picChg chg="add del mod">
+          <ac:chgData name="Read, Zoe" userId="b08cd0fd-26d2-470b-8ec0-c6e6cb2a79bd" providerId="ADAL" clId="{5AEB2719-95A5-4ED2-9E0E-ED462BB10526}" dt="2026-03-13T15:15:41.221" v="4963" actId="478"/>
+          <ac:picMkLst>
+            <pc:docMk/>
+            <pc:sldMk cId="2005456116" sldId="257"/>
+            <ac:picMk id="1073" creationId="{5466ADED-34D8-BA58-93D9-9F5AE1DBBC21}"/>
+          </ac:picMkLst>
+        </pc:picChg>
+        <pc:picChg chg="add del mod">
+          <ac:chgData name="Read, Zoe" userId="b08cd0fd-26d2-470b-8ec0-c6e6cb2a79bd" providerId="ADAL" clId="{5AEB2719-95A5-4ED2-9E0E-ED462BB10526}" dt="2026-03-13T15:16:18.449" v="4968" actId="478"/>
+          <ac:picMkLst>
+            <pc:docMk/>
+            <pc:sldMk cId="2005456116" sldId="257"/>
+            <ac:picMk id="1075" creationId="{AAEC5A0E-A8A7-5F3D-FF7E-D5A1310DC25F}"/>
+          </ac:picMkLst>
+        </pc:picChg>
+        <pc:picChg chg="add del mod">
+          <ac:chgData name="Read, Zoe" userId="b08cd0fd-26d2-470b-8ec0-c6e6cb2a79bd" providerId="ADAL" clId="{5AEB2719-95A5-4ED2-9E0E-ED462BB10526}" dt="2026-03-13T15:16:58.206" v="4975" actId="478"/>
+          <ac:picMkLst>
+            <pc:docMk/>
+            <pc:sldMk cId="2005456116" sldId="257"/>
+            <ac:picMk id="1077" creationId="{FFBEF150-4996-ACCF-2FF8-42C26451A7FE}"/>
+          </ac:picMkLst>
+        </pc:picChg>
+        <pc:picChg chg="add del mod ord">
+          <ac:chgData name="Read, Zoe" userId="b08cd0fd-26d2-470b-8ec0-c6e6cb2a79bd" providerId="ADAL" clId="{5AEB2719-95A5-4ED2-9E0E-ED462BB10526}" dt="2026-03-13T15:20:09.550" v="4992" actId="478"/>
+          <ac:picMkLst>
+            <pc:docMk/>
+            <pc:sldMk cId="2005456116" sldId="257"/>
+            <ac:picMk id="1079" creationId="{E89868C9-5DDE-C444-4252-B8FA393EF2CE}"/>
+          </ac:picMkLst>
+        </pc:picChg>
+        <pc:picChg chg="add mod ord">
+          <ac:chgData name="Read, Zoe" userId="b08cd0fd-26d2-470b-8ec0-c6e6cb2a79bd" providerId="ADAL" clId="{5AEB2719-95A5-4ED2-9E0E-ED462BB10526}" dt="2026-03-13T15:23:17.079" v="5036" actId="1076"/>
+          <ac:picMkLst>
+            <pc:docMk/>
+            <pc:sldMk cId="2005456116" sldId="257"/>
+            <ac:picMk id="1081" creationId="{E751C4E4-E854-FE7E-1EF9-268DA1A23024}"/>
+          </ac:picMkLst>
+        </pc:picChg>
+        <pc:picChg chg="add del mod">
+          <ac:chgData name="Read, Zoe" userId="b08cd0fd-26d2-470b-8ec0-c6e6cb2a79bd" providerId="ADAL" clId="{5AEB2719-95A5-4ED2-9E0E-ED462BB10526}" dt="2026-03-13T15:22:37.877" v="5027" actId="478"/>
+          <ac:picMkLst>
+            <pc:docMk/>
+            <pc:sldMk cId="2005456116" sldId="257"/>
+            <ac:picMk id="1083" creationId="{79DA7F69-4E83-B1E5-DFEA-930123DA7F46}"/>
+          </ac:picMkLst>
+        </pc:picChg>
+        <pc:picChg chg="add mod">
+          <ac:chgData name="Read, Zoe" userId="b08cd0fd-26d2-470b-8ec0-c6e6cb2a79bd" providerId="ADAL" clId="{5AEB2719-95A5-4ED2-9E0E-ED462BB10526}" dt="2026-03-13T15:23:32.914" v="5041" actId="1076"/>
+          <ac:picMkLst>
+            <pc:docMk/>
+            <pc:sldMk cId="2005456116" sldId="257"/>
+            <ac:picMk id="1085" creationId="{9E2D53CD-2078-3011-EB8F-F1979C9B3B22}"/>
+          </ac:picMkLst>
+        </pc:picChg>
+        <pc:picChg chg="add del mod">
+          <ac:chgData name="Read, Zoe" userId="b08cd0fd-26d2-470b-8ec0-c6e6cb2a79bd" providerId="ADAL" clId="{5AEB2719-95A5-4ED2-9E0E-ED462BB10526}" dt="2026-03-13T15:27:09.698" v="5050" actId="478"/>
+          <ac:picMkLst>
+            <pc:docMk/>
+            <pc:sldMk cId="2005456116" sldId="257"/>
+            <ac:picMk id="1088" creationId="{6780A67C-EA16-F57D-656A-1D4EE2D0B56B}"/>
+          </ac:picMkLst>
+        </pc:picChg>
+        <pc:picChg chg="add del mod">
+          <ac:chgData name="Read, Zoe" userId="b08cd0fd-26d2-470b-8ec0-c6e6cb2a79bd" providerId="ADAL" clId="{5AEB2719-95A5-4ED2-9E0E-ED462BB10526}" dt="2026-03-13T15:27:37.034" v="5056" actId="478"/>
+          <ac:picMkLst>
+            <pc:docMk/>
+            <pc:sldMk cId="2005456116" sldId="257"/>
+            <ac:picMk id="1090" creationId="{22F59BC5-2C35-DDF1-6E10-AC204BAEB7DC}"/>
+          </ac:picMkLst>
+        </pc:picChg>
+        <pc:picChg chg="add del mod">
+          <ac:chgData name="Read, Zoe" userId="b08cd0fd-26d2-470b-8ec0-c6e6cb2a79bd" providerId="ADAL" clId="{5AEB2719-95A5-4ED2-9E0E-ED462BB10526}" dt="2026-03-13T15:28:10.572" v="5061" actId="478"/>
+          <ac:picMkLst>
+            <pc:docMk/>
+            <pc:sldMk cId="2005456116" sldId="257"/>
+            <ac:picMk id="1092" creationId="{B289EE1B-058F-1CF1-4DE6-B6EEE7938A9B}"/>
+          </ac:picMkLst>
+        </pc:picChg>
+        <pc:picChg chg="add del mod">
+          <ac:chgData name="Read, Zoe" userId="b08cd0fd-26d2-470b-8ec0-c6e6cb2a79bd" providerId="ADAL" clId="{5AEB2719-95A5-4ED2-9E0E-ED462BB10526}" dt="2026-03-13T15:29:43.633" v="5069" actId="478"/>
+          <ac:picMkLst>
+            <pc:docMk/>
+            <pc:sldMk cId="2005456116" sldId="257"/>
+            <ac:picMk id="1094" creationId="{F50E4DC2-8AE0-9280-8B55-572851BC47EC}"/>
+          </ac:picMkLst>
+        </pc:picChg>
+        <pc:picChg chg="add del mod">
+          <ac:chgData name="Read, Zoe" userId="b08cd0fd-26d2-470b-8ec0-c6e6cb2a79bd" providerId="ADAL" clId="{5AEB2719-95A5-4ED2-9E0E-ED462BB10526}" dt="2026-03-13T15:30:15.570" v="5071" actId="478"/>
+          <ac:picMkLst>
+            <pc:docMk/>
+            <pc:sldMk cId="2005456116" sldId="257"/>
+            <ac:picMk id="1096" creationId="{19A9F59A-6905-0461-921F-53D44D6FE9B4}"/>
+          </ac:picMkLst>
+        </pc:picChg>
+        <pc:picChg chg="add del mod">
+          <ac:chgData name="Read, Zoe" userId="b08cd0fd-26d2-470b-8ec0-c6e6cb2a79bd" providerId="ADAL" clId="{5AEB2719-95A5-4ED2-9E0E-ED462BB10526}" dt="2026-03-13T15:31:42.114" v="5079" actId="478"/>
+          <ac:picMkLst>
+            <pc:docMk/>
+            <pc:sldMk cId="2005456116" sldId="257"/>
+            <ac:picMk id="1098" creationId="{371F0427-7C9D-A089-1550-355CC41A1B47}"/>
+          </ac:picMkLst>
+        </pc:picChg>
+        <pc:picChg chg="add del mod">
+          <ac:chgData name="Read, Zoe" userId="b08cd0fd-26d2-470b-8ec0-c6e6cb2a79bd" providerId="ADAL" clId="{5AEB2719-95A5-4ED2-9E0E-ED462BB10526}" dt="2026-03-13T15:54:01.795" v="5096" actId="478"/>
+          <ac:picMkLst>
+            <pc:docMk/>
+            <pc:sldMk cId="2005456116" sldId="257"/>
+            <ac:picMk id="1100" creationId="{A43F5C94-F21D-A325-C5D6-3A47C4C3B61F}"/>
+          </ac:picMkLst>
+        </pc:picChg>
+        <pc:picChg chg="add del mod">
+          <ac:chgData name="Read, Zoe" userId="b08cd0fd-26d2-470b-8ec0-c6e6cb2a79bd" providerId="ADAL" clId="{5AEB2719-95A5-4ED2-9E0E-ED462BB10526}" dt="2026-03-13T15:57:59.527" v="5369" actId="478"/>
+          <ac:picMkLst>
+            <pc:docMk/>
+            <pc:sldMk cId="2005456116" sldId="257"/>
+            <ac:picMk id="1102" creationId="{409410D1-8C61-C5F2-2ED0-8AE9EB772068}"/>
+          </ac:picMkLst>
+        </pc:picChg>
+        <pc:picChg chg="add mod">
+          <ac:chgData name="Read, Zoe" userId="b08cd0fd-26d2-470b-8ec0-c6e6cb2a79bd" providerId="ADAL" clId="{5AEB2719-95A5-4ED2-9E0E-ED462BB10526}" dt="2026-03-13T16:03:05.847" v="5463" actId="1035"/>
+          <ac:picMkLst>
+            <pc:docMk/>
+            <pc:sldMk cId="2005456116" sldId="257"/>
+            <ac:picMk id="1104" creationId="{BB487FD2-0D02-18A0-8E65-73832FF97000}"/>
+          </ac:picMkLst>
+        </pc:picChg>
         <pc:cxnChg chg="add mod ord">
-          <ac:chgData name="Read, Zoe" userId="b08cd0fd-26d2-470b-8ec0-c6e6cb2a79bd" providerId="ADAL" clId="{5AEB2719-95A5-4ED2-9E0E-ED462BB10526}" dt="2026-03-12T20:16:25.990" v="3528" actId="166"/>
+          <ac:chgData name="Read, Zoe" userId="b08cd0fd-26d2-470b-8ec0-c6e6cb2a79bd" providerId="ADAL" clId="{5AEB2719-95A5-4ED2-9E0E-ED462BB10526}" dt="2026-03-13T15:23:44.503" v="5042" actId="14100"/>
           <ac:cxnSpMkLst>
             <pc:docMk/>
             <pc:sldMk cId="2005456116" sldId="257"/>
@@ -412,7 +660,7 @@
           </ac:cxnSpMkLst>
         </pc:cxnChg>
         <pc:cxnChg chg="mod">
-          <ac:chgData name="Read, Zoe" userId="b08cd0fd-26d2-470b-8ec0-c6e6cb2a79bd" providerId="ADAL" clId="{5AEB2719-95A5-4ED2-9E0E-ED462BB10526}" dt="2026-03-12T19:11:58.622" v="2856" actId="1035"/>
+          <ac:chgData name="Read, Zoe" userId="b08cd0fd-26d2-470b-8ec0-c6e6cb2a79bd" providerId="ADAL" clId="{5AEB2719-95A5-4ED2-9E0E-ED462BB10526}" dt="2026-03-13T15:03:40.670" v="4904" actId="1036"/>
           <ac:cxnSpMkLst>
             <pc:docMk/>
             <pc:sldMk cId="2005456116" sldId="257"/>
@@ -420,7 +668,7 @@
           </ac:cxnSpMkLst>
         </pc:cxnChg>
         <pc:cxnChg chg="add mod ord">
-          <ac:chgData name="Read, Zoe" userId="b08cd0fd-26d2-470b-8ec0-c6e6cb2a79bd" providerId="ADAL" clId="{5AEB2719-95A5-4ED2-9E0E-ED462BB10526}" dt="2026-03-12T20:12:17.256" v="3359" actId="167"/>
+          <ac:chgData name="Read, Zoe" userId="b08cd0fd-26d2-470b-8ec0-c6e6cb2a79bd" providerId="ADAL" clId="{5AEB2719-95A5-4ED2-9E0E-ED462BB10526}" dt="2026-03-13T15:05:21.038" v="4913" actId="1076"/>
           <ac:cxnSpMkLst>
             <pc:docMk/>
             <pc:sldMk cId="2005456116" sldId="257"/>
@@ -428,7 +676,7 @@
           </ac:cxnSpMkLst>
         </pc:cxnChg>
         <pc:cxnChg chg="mod">
-          <ac:chgData name="Read, Zoe" userId="b08cd0fd-26d2-470b-8ec0-c6e6cb2a79bd" providerId="ADAL" clId="{5AEB2719-95A5-4ED2-9E0E-ED462BB10526}" dt="2026-03-12T20:10:23.305" v="3171" actId="1076"/>
+          <ac:chgData name="Read, Zoe" userId="b08cd0fd-26d2-470b-8ec0-c6e6cb2a79bd" providerId="ADAL" clId="{5AEB2719-95A5-4ED2-9E0E-ED462BB10526}" dt="2026-03-13T14:47:43.111" v="4643" actId="1035"/>
           <ac:cxnSpMkLst>
             <pc:docMk/>
             <pc:sldMk cId="2005456116" sldId="257"/>
@@ -436,7 +684,7 @@
           </ac:cxnSpMkLst>
         </pc:cxnChg>
         <pc:cxnChg chg="mod">
-          <ac:chgData name="Read, Zoe" userId="b08cd0fd-26d2-470b-8ec0-c6e6cb2a79bd" providerId="ADAL" clId="{5AEB2719-95A5-4ED2-9E0E-ED462BB10526}" dt="2026-03-12T19:12:02.854" v="2857" actId="14100"/>
+          <ac:chgData name="Read, Zoe" userId="b08cd0fd-26d2-470b-8ec0-c6e6cb2a79bd" providerId="ADAL" clId="{5AEB2719-95A5-4ED2-9E0E-ED462BB10526}" dt="2026-03-13T15:03:37.399" v="4902" actId="1036"/>
           <ac:cxnSpMkLst>
             <pc:docMk/>
             <pc:sldMk cId="2005456116" sldId="257"/>
@@ -444,55 +692,55 @@
           </ac:cxnSpMkLst>
         </pc:cxnChg>
         <pc:cxnChg chg="mod">
-          <ac:chgData name="Read, Zoe" userId="b08cd0fd-26d2-470b-8ec0-c6e6cb2a79bd" providerId="ADAL" clId="{5AEB2719-95A5-4ED2-9E0E-ED462BB10526}" dt="2026-03-12T20:16:16.234" v="3524" actId="1076"/>
+          <ac:chgData name="Read, Zoe" userId="b08cd0fd-26d2-470b-8ec0-c6e6cb2a79bd" providerId="ADAL" clId="{5AEB2719-95A5-4ED2-9E0E-ED462BB10526}" dt="2026-03-13T15:50:34.459" v="5094" actId="1035"/>
           <ac:cxnSpMkLst>
             <pc:docMk/>
             <pc:sldMk cId="2005456116" sldId="257"/>
             <ac:cxnSpMk id="1044" creationId="{8463A8F4-CE87-F09A-8258-6D6979B36D80}"/>
           </ac:cxnSpMkLst>
         </pc:cxnChg>
-        <pc:cxnChg chg="add mod ord">
-          <ac:chgData name="Read, Zoe" userId="b08cd0fd-26d2-470b-8ec0-c6e6cb2a79bd" providerId="ADAL" clId="{5AEB2719-95A5-4ED2-9E0E-ED462BB10526}" dt="2026-03-12T20:12:17.256" v="3359" actId="167"/>
+        <pc:cxnChg chg="add del mod ord">
+          <ac:chgData name="Read, Zoe" userId="b08cd0fd-26d2-470b-8ec0-c6e6cb2a79bd" providerId="ADAL" clId="{5AEB2719-95A5-4ED2-9E0E-ED462BB10526}" dt="2026-03-13T14:43:58.200" v="4435" actId="478"/>
           <ac:cxnSpMkLst>
             <pc:docMk/>
             <pc:sldMk cId="2005456116" sldId="257"/>
             <ac:cxnSpMk id="1045" creationId="{BB33F361-7DB9-04C2-C03A-778C0DF80E8F}"/>
           </ac:cxnSpMkLst>
         </pc:cxnChg>
-        <pc:cxnChg chg="add mod">
-          <ac:chgData name="Read, Zoe" userId="b08cd0fd-26d2-470b-8ec0-c6e6cb2a79bd" providerId="ADAL" clId="{5AEB2719-95A5-4ED2-9E0E-ED462BB10526}" dt="2026-03-12T20:10:36.867" v="3175" actId="1076"/>
+        <pc:cxnChg chg="add del mod">
+          <ac:chgData name="Read, Zoe" userId="b08cd0fd-26d2-470b-8ec0-c6e6cb2a79bd" providerId="ADAL" clId="{5AEB2719-95A5-4ED2-9E0E-ED462BB10526}" dt="2026-03-13T14:43:58.200" v="4435" actId="478"/>
           <ac:cxnSpMkLst>
             <pc:docMk/>
             <pc:sldMk cId="2005456116" sldId="257"/>
             <ac:cxnSpMk id="1047" creationId="{375CA06C-A251-4ED8-A38F-281C7D414E0B}"/>
           </ac:cxnSpMkLst>
         </pc:cxnChg>
-        <pc:cxnChg chg="add mod ord">
-          <ac:chgData name="Read, Zoe" userId="b08cd0fd-26d2-470b-8ec0-c6e6cb2a79bd" providerId="ADAL" clId="{5AEB2719-95A5-4ED2-9E0E-ED462BB10526}" dt="2026-03-12T20:12:17.256" v="3359" actId="167"/>
+        <pc:cxnChg chg="add del mod ord">
+          <ac:chgData name="Read, Zoe" userId="b08cd0fd-26d2-470b-8ec0-c6e6cb2a79bd" providerId="ADAL" clId="{5AEB2719-95A5-4ED2-9E0E-ED462BB10526}" dt="2026-03-13T14:43:58.200" v="4435" actId="478"/>
           <ac:cxnSpMkLst>
             <pc:docMk/>
             <pc:sldMk cId="2005456116" sldId="257"/>
             <ac:cxnSpMk id="1050" creationId="{D3DAFDEE-D9E5-1D68-8EB9-E51F04AB1645}"/>
           </ac:cxnSpMkLst>
         </pc:cxnChg>
-        <pc:cxnChg chg="add mod ord">
-          <ac:chgData name="Read, Zoe" userId="b08cd0fd-26d2-470b-8ec0-c6e6cb2a79bd" providerId="ADAL" clId="{5AEB2719-95A5-4ED2-9E0E-ED462BB10526}" dt="2026-03-12T20:12:17.256" v="3359" actId="167"/>
+        <pc:cxnChg chg="add del mod ord">
+          <ac:chgData name="Read, Zoe" userId="b08cd0fd-26d2-470b-8ec0-c6e6cb2a79bd" providerId="ADAL" clId="{5AEB2719-95A5-4ED2-9E0E-ED462BB10526}" dt="2026-03-13T14:43:58.200" v="4435" actId="478"/>
           <ac:cxnSpMkLst>
             <pc:docMk/>
             <pc:sldMk cId="2005456116" sldId="257"/>
             <ac:cxnSpMk id="1051" creationId="{F2AFA6AA-F2FA-7B6D-89B6-C18FBAE3FB74}"/>
           </ac:cxnSpMkLst>
         </pc:cxnChg>
-        <pc:cxnChg chg="add mod ord">
-          <ac:chgData name="Read, Zoe" userId="b08cd0fd-26d2-470b-8ec0-c6e6cb2a79bd" providerId="ADAL" clId="{5AEB2719-95A5-4ED2-9E0E-ED462BB10526}" dt="2026-03-12T20:12:17.256" v="3359" actId="167"/>
+        <pc:cxnChg chg="add del mod ord">
+          <ac:chgData name="Read, Zoe" userId="b08cd0fd-26d2-470b-8ec0-c6e6cb2a79bd" providerId="ADAL" clId="{5AEB2719-95A5-4ED2-9E0E-ED462BB10526}" dt="2026-03-13T14:43:58.200" v="4435" actId="478"/>
           <ac:cxnSpMkLst>
             <pc:docMk/>
             <pc:sldMk cId="2005456116" sldId="257"/>
             <ac:cxnSpMk id="1052" creationId="{9F2A7656-0EEE-7013-0DB8-ADC5FDA2A8B2}"/>
           </ac:cxnSpMkLst>
         </pc:cxnChg>
-        <pc:cxnChg chg="add mod ord">
-          <ac:chgData name="Read, Zoe" userId="b08cd0fd-26d2-470b-8ec0-c6e6cb2a79bd" providerId="ADAL" clId="{5AEB2719-95A5-4ED2-9E0E-ED462BB10526}" dt="2026-03-12T20:12:17.256" v="3359" actId="167"/>
+        <pc:cxnChg chg="add del mod ord">
+          <ac:chgData name="Read, Zoe" userId="b08cd0fd-26d2-470b-8ec0-c6e6cb2a79bd" providerId="ADAL" clId="{5AEB2719-95A5-4ED2-9E0E-ED462BB10526}" dt="2026-03-13T14:43:58.200" v="4435" actId="478"/>
           <ac:cxnSpMkLst>
             <pc:docMk/>
             <pc:sldMk cId="2005456116" sldId="257"/>
@@ -507,32 +755,32 @@
             <ac:cxnSpMk id="1054" creationId="{B4545213-9D78-5A7D-F0ED-7247C7E86F0A}"/>
           </ac:cxnSpMkLst>
         </pc:cxnChg>
-        <pc:cxnChg chg="add mod ord">
-          <ac:chgData name="Read, Zoe" userId="b08cd0fd-26d2-470b-8ec0-c6e6cb2a79bd" providerId="ADAL" clId="{5AEB2719-95A5-4ED2-9E0E-ED462BB10526}" dt="2026-03-12T20:12:17.256" v="3359" actId="167"/>
+        <pc:cxnChg chg="add del mod ord">
+          <ac:chgData name="Read, Zoe" userId="b08cd0fd-26d2-470b-8ec0-c6e6cb2a79bd" providerId="ADAL" clId="{5AEB2719-95A5-4ED2-9E0E-ED462BB10526}" dt="2026-03-13T14:43:58.200" v="4435" actId="478"/>
           <ac:cxnSpMkLst>
             <pc:docMk/>
             <pc:sldMk cId="2005456116" sldId="257"/>
             <ac:cxnSpMk id="1055" creationId="{EAF13472-2A54-A942-9989-189633D8FC45}"/>
           </ac:cxnSpMkLst>
         </pc:cxnChg>
-        <pc:cxnChg chg="add mod">
-          <ac:chgData name="Read, Zoe" userId="b08cd0fd-26d2-470b-8ec0-c6e6cb2a79bd" providerId="ADAL" clId="{5AEB2719-95A5-4ED2-9E0E-ED462BB10526}" dt="2026-03-12T19:06:52.126" v="2440" actId="1076"/>
+        <pc:cxnChg chg="add del mod">
+          <ac:chgData name="Read, Zoe" userId="b08cd0fd-26d2-470b-8ec0-c6e6cb2a79bd" providerId="ADAL" clId="{5AEB2719-95A5-4ED2-9E0E-ED462BB10526}" dt="2026-03-13T14:43:58.200" v="4435" actId="478"/>
           <ac:cxnSpMkLst>
             <pc:docMk/>
             <pc:sldMk cId="2005456116" sldId="257"/>
             <ac:cxnSpMk id="1056" creationId="{97023478-EBF1-C0B2-4640-43B6062C44A4}"/>
           </ac:cxnSpMkLst>
         </pc:cxnChg>
-        <pc:cxnChg chg="add mod">
-          <ac:chgData name="Read, Zoe" userId="b08cd0fd-26d2-470b-8ec0-c6e6cb2a79bd" providerId="ADAL" clId="{5AEB2719-95A5-4ED2-9E0E-ED462BB10526}" dt="2026-03-12T19:06:52.126" v="2440" actId="1076"/>
+        <pc:cxnChg chg="add del mod">
+          <ac:chgData name="Read, Zoe" userId="b08cd0fd-26d2-470b-8ec0-c6e6cb2a79bd" providerId="ADAL" clId="{5AEB2719-95A5-4ED2-9E0E-ED462BB10526}" dt="2026-03-13T14:43:58.200" v="4435" actId="478"/>
           <ac:cxnSpMkLst>
             <pc:docMk/>
             <pc:sldMk cId="2005456116" sldId="257"/>
             <ac:cxnSpMk id="1057" creationId="{EABAA8CD-3573-D737-5C52-07AF46DD77DB}"/>
           </ac:cxnSpMkLst>
         </pc:cxnChg>
-        <pc:cxnChg chg="add mod">
-          <ac:chgData name="Read, Zoe" userId="b08cd0fd-26d2-470b-8ec0-c6e6cb2a79bd" providerId="ADAL" clId="{5AEB2719-95A5-4ED2-9E0E-ED462BB10526}" dt="2026-03-10T20:31:43.640" v="2357" actId="693"/>
+        <pc:cxnChg chg="add del mod">
+          <ac:chgData name="Read, Zoe" userId="b08cd0fd-26d2-470b-8ec0-c6e6cb2a79bd" providerId="ADAL" clId="{5AEB2719-95A5-4ED2-9E0E-ED462BB10526}" dt="2026-03-13T14:43:58.200" v="4435" actId="478"/>
           <ac:cxnSpMkLst>
             <pc:docMk/>
             <pc:sldMk cId="2005456116" sldId="257"/>
@@ -554,11 +802,11 @@
 
 <file path=ppt/comments/modernComment_101_7788D4F4.xml><?xml version="1.0" encoding="utf-8"?>
 <p188:cmLst xmlns:a="http://schemas.openxmlformats.org/drawingml/2006/main" xmlns:r="http://schemas.openxmlformats.org/officeDocument/2006/relationships" xmlns:p188="http://schemas.microsoft.com/office/powerpoint/2018/8/main">
-  <p188:cm id="{C554005E-3DFA-4299-9DD0-B44794E496C1}" authorId="{50137B73-C207-1407-898B-797CE70D2312}" created="2026-03-06T17:25:40.921">
+  <p188:cm id="{B8A07343-8EBD-4063-9515-C0EDE7CA19F0}" authorId="{50137B73-C207-1407-898B-797CE70D2312}" created="2026-03-13T14:20:44.092">
     <ac:deMkLst xmlns:ac="http://schemas.microsoft.com/office/drawing/2013/main/command">
       <pc:docMk xmlns:pc="http://schemas.microsoft.com/office/powerpoint/2013/main/command"/>
       <pc:sldMk xmlns:pc="http://schemas.microsoft.com/office/powerpoint/2013/main/command" cId="2005456116" sldId="257"/>
-      <ac:picMk id="10" creationId="{0A86C89A-5889-65B9-1137-F480341B9783}"/>
+      <ac:picMk id="9" creationId="{09EDF015-AC84-7DA3-BD5A-225267C491D7}"/>
     </ac:deMkLst>
     <p188:txBody>
       <a:bodyPr/>
@@ -566,16 +814,16 @@
       <a:p>
         <a:r>
           <a:rPr lang="en-US"/>
-          <a:t>Add a title that includes: “Fig 1. SO4 values across sites and zones. N samples = ?” and maybe have the Sites and Zones written out here. </a:t>
+          <a:t>Print the anova table into a csv for Steph to look at</a:t>
         </a:r>
       </a:p>
     </p188:txBody>
   </p188:cm>
-  <p188:cm id="{D8865092-41B9-4A7A-8291-CC012781D643}" authorId="{50137B73-C207-1407-898B-797CE70D2312}" created="2026-03-06T17:31:19.747">
+  <p188:cm id="{F7D370C0-1A77-42D9-8499-1F9C74E5F229}" authorId="{50137B73-C207-1407-898B-797CE70D2312}" created="2026-03-13T16:00:05.398">
     <ac:deMkLst xmlns:ac="http://schemas.microsoft.com/office/drawing/2013/main/command">
       <pc:docMk xmlns:pc="http://schemas.microsoft.com/office/powerpoint/2013/main/command"/>
       <pc:sldMk xmlns:pc="http://schemas.microsoft.com/office/powerpoint/2013/main/command" cId="2005456116" sldId="257"/>
-      <ac:picMk id="13" creationId="{6D65798C-DAB9-914B-7ECA-E6D17BBC9E45}"/>
+      <ac:picMk id="1104" creationId="{BB487FD2-0D02-18A0-8E65-73832FF97000}"/>
     </ac:deMkLst>
     <p188:txBody>
       <a:bodyPr/>
@@ -583,7 +831,7 @@
       <a:p>
         <a:r>
           <a:rPr lang="en-US"/>
-          <a:t>Switch the depth to the y-axis and sulfate to the y-axis and color by zone</a:t>
+          <a:t>I should try to add the values and units to the x-axes of these graphs</a:t>
         </a:r>
       </a:p>
     </p188:txBody>
@@ -673,7 +921,7 @@
           <a:p>
             <a:fld id="{0407BD97-90D8-3541-9414-B17D17D02539}" type="datetimeFigureOut">
               <a:rPr lang="en-US" smtClean="0"/>
-              <a:t>3/12/2026</a:t>
+              <a:t>3/13/2026</a:t>
             </a:fld>
             <a:endParaRPr lang="en-US"/>
           </a:p>
@@ -989,45 +1237,34 @@
           <a:bodyPr/>
           <a:lstStyle/>
           <a:p>
-            <a:r>
-              <a:rPr lang="en-US" sz="1800" b="1" dirty="0"/>
-              <a:t>Who do I add to credits? </a:t>
+            <a:pPr marL="285750" indent="-285750">
+              <a:buFontTx/>
+              <a:buChar char="-"/>
+            </a:pPr>
+            <a:r>
+              <a:rPr lang="en-US" baseline="0" dirty="0"/>
+              <a:t>Make sure all plots are the same font size</a:t>
             </a:r>
           </a:p>
           <a:p>
-            <a:endParaRPr lang="en-US" sz="1800" b="1" dirty="0"/>
+            <a:pPr marL="285750" indent="-285750">
+              <a:buFontTx/>
+              <a:buChar char="-"/>
+            </a:pPr>
+            <a:r>
+              <a:rPr lang="en-US" baseline="0" dirty="0"/>
+              <a:t>-Color env variables plot by depth? Check which depth sensors I used (10 cm ones?) Or color by site? </a:t>
+            </a:r>
           </a:p>
           <a:p>
-            <a:r>
-              <a:rPr lang="en-US" sz="1800" b="1" dirty="0"/>
-              <a:t>, </a:t>
-            </a:r>
-            <a:r>
-              <a:rPr lang="en-US" sz="1800" dirty="0"/>
-              <a:t>Stephanie J. Wilson, Pat Megonigal, Alice Stearns, Evan Phillips, Ben Bond-Lamberty</a:t>
-            </a:r>
-          </a:p>
-          <a:p>
-            <a:r>
-              <a:rPr lang="en-US" sz="1600" baseline="30000" dirty="0"/>
-              <a:t>1</a:t>
-            </a:r>
-            <a:r>
-              <a:rPr lang="en-US" sz="1600" dirty="0"/>
-              <a:t>Smithsonian Environmental Research Center, Maryland, USA, </a:t>
-            </a:r>
-            <a:r>
-              <a:rPr lang="en-US" sz="1600" baseline="30000" dirty="0"/>
-              <a:t>2</a:t>
-            </a:r>
-            <a:r>
-              <a:rPr lang="en-US" sz="1600" dirty="0"/>
-              <a:t>Pacific Northwest National Laboratory</a:t>
-            </a:r>
-            <a:endParaRPr lang="en-US" dirty="0"/>
-          </a:p>
-          <a:p>
-            <a:endParaRPr lang="en-US" baseline="0" dirty="0"/>
+            <a:pPr marL="285750" indent="-285750">
+              <a:buFontTx/>
+              <a:buChar char="-"/>
+            </a:pPr>
+            <a:r>
+              <a:rPr lang="en-US" baseline="0" dirty="0"/>
+              <a:t>- If have time, could try adding stacked x-axis with month and year below it </a:t>
+            </a:r>
           </a:p>
         </p:txBody>
       </p:sp>
@@ -2272,10 +2509,10 @@
       </p:grpSpPr>
       <p:pic>
         <p:nvPicPr>
-          <p:cNvPr id="11" name="Picture 10" descr="A screenshot of a graph&#10;&#10;AI-generated content may be incorrect.">
+          <p:cNvPr id="1081" name="Picture 1080" descr="A chart of different colored boxes&#10;&#10;AI-generated content may be incorrect.">
             <a:extLst>
               <a:ext uri="{FF2B5EF4-FFF2-40B4-BE49-F238E27FC236}">
-                <a16:creationId xmlns:a16="http://schemas.microsoft.com/office/drawing/2014/main" id="{0144416F-2A82-F7CC-0427-8A36932666F6}"/>
+                <a16:creationId xmlns:a16="http://schemas.microsoft.com/office/drawing/2014/main" id="{E751C4E4-E854-FE7E-1EF9-268DA1A23024}"/>
               </a:ext>
             </a:extLst>
           </p:cNvPr>
@@ -2292,6 +2529,42 @@
               </a:ext>
             </a:extLst>
           </a:blip>
+          <a:stretch>
+            <a:fillRect/>
+          </a:stretch>
+        </p:blipFill>
+        <p:spPr>
+          <a:xfrm>
+            <a:off x="440597" y="18530902"/>
+            <a:ext cx="16459233" cy="6400813"/>
+          </a:xfrm>
+          <a:prstGeom prst="rect">
+            <a:avLst/>
+          </a:prstGeom>
+        </p:spPr>
+      </p:pic>
+      <p:pic>
+        <p:nvPicPr>
+          <p:cNvPr id="11" name="Picture 10" descr="A screenshot of a graph&#10;&#10;AI-generated content may be incorrect.">
+            <a:extLst>
+              <a:ext uri="{FF2B5EF4-FFF2-40B4-BE49-F238E27FC236}">
+                <a16:creationId xmlns:a16="http://schemas.microsoft.com/office/drawing/2014/main" id="{0144416F-2A82-F7CC-0427-8A36932666F6}"/>
+              </a:ext>
+            </a:extLst>
+          </p:cNvPr>
+          <p:cNvPicPr>
+            <a:picLocks noChangeAspect="1"/>
+          </p:cNvPicPr>
+          <p:nvPr/>
+        </p:nvPicPr>
+        <p:blipFill>
+          <a:blip r:embed="rId5">
+            <a:extLst>
+              <a:ext uri="{28A0092B-C50C-407E-A947-70E740481C1C}">
+                <a14:useLocalDpi xmlns:a14="http://schemas.microsoft.com/office/drawing/2010/main" val="0"/>
+              </a:ext>
+            </a:extLst>
+          </a:blip>
           <a:srcRect r="4104"/>
           <a:stretch>
             <a:fillRect/>
@@ -2299,8 +2572,8 @@
         </p:blipFill>
         <p:spPr>
           <a:xfrm>
-            <a:off x="17554806" y="16902663"/>
-            <a:ext cx="16232726" cy="10156496"/>
+            <a:off x="17722867" y="18667011"/>
+            <a:ext cx="16135719" cy="10095800"/>
           </a:xfrm>
           <a:prstGeom prst="rect">
             <a:avLst/>
@@ -2323,7 +2596,7 @@
         </p:nvCxnSpPr>
         <p:spPr>
           <a:xfrm>
-            <a:off x="18193524" y="27475279"/>
+            <a:off x="18238506" y="29047276"/>
             <a:ext cx="15099634" cy="0"/>
           </a:xfrm>
           <a:prstGeom prst="line">
@@ -2350,494 +2623,6 @@
           </a:fontRef>
         </p:style>
       </p:cxnSp>
-      <p:cxnSp>
-        <p:nvCxnSpPr>
-          <p:cNvPr id="1045" name="Straight Connector 1044">
-            <a:extLst>
-              <a:ext uri="{FF2B5EF4-FFF2-40B4-BE49-F238E27FC236}">
-                <a16:creationId xmlns:a16="http://schemas.microsoft.com/office/drawing/2014/main" id="{BB33F361-7DB9-04C2-C03A-778C0DF80E8F}"/>
-              </a:ext>
-            </a:extLst>
-          </p:cNvPr>
-          <p:cNvCxnSpPr>
-            <a:cxnSpLocks/>
-          </p:cNvCxnSpPr>
-          <p:nvPr/>
-        </p:nvCxnSpPr>
-        <p:spPr>
-          <a:xfrm flipV="1">
-            <a:off x="20334390" y="21104778"/>
-            <a:ext cx="0" cy="165469"/>
-          </a:xfrm>
-          <a:prstGeom prst="line">
-            <a:avLst/>
-          </a:prstGeom>
-          <a:ln w="19050">
-            <a:prstDash val="lgDash"/>
-          </a:ln>
-        </p:spPr>
-        <p:style>
-          <a:lnRef idx="1">
-            <a:schemeClr val="dk1"/>
-          </a:lnRef>
-          <a:fillRef idx="0">
-            <a:schemeClr val="dk1"/>
-          </a:fillRef>
-          <a:effectRef idx="0">
-            <a:schemeClr val="dk1"/>
-          </a:effectRef>
-          <a:fontRef idx="minor">
-            <a:schemeClr val="tx1"/>
-          </a:fontRef>
-        </p:style>
-      </p:cxnSp>
-      <p:cxnSp>
-        <p:nvCxnSpPr>
-          <p:cNvPr id="1047" name="Straight Connector 1046">
-            <a:extLst>
-              <a:ext uri="{FF2B5EF4-FFF2-40B4-BE49-F238E27FC236}">
-                <a16:creationId xmlns:a16="http://schemas.microsoft.com/office/drawing/2014/main" id="{375CA06C-A251-4ED8-A38F-281C7D414E0B}"/>
-              </a:ext>
-            </a:extLst>
-          </p:cNvPr>
-          <p:cNvCxnSpPr>
-            <a:cxnSpLocks/>
-          </p:cNvCxnSpPr>
-          <p:nvPr/>
-        </p:nvCxnSpPr>
-        <p:spPr>
-          <a:xfrm flipV="1">
-            <a:off x="23687190" y="21104777"/>
-            <a:ext cx="0" cy="165469"/>
-          </a:xfrm>
-          <a:prstGeom prst="line">
-            <a:avLst/>
-          </a:prstGeom>
-          <a:ln w="19050">
-            <a:prstDash val="lgDash"/>
-          </a:ln>
-        </p:spPr>
-        <p:style>
-          <a:lnRef idx="1">
-            <a:schemeClr val="dk1"/>
-          </a:lnRef>
-          <a:fillRef idx="0">
-            <a:schemeClr val="dk1"/>
-          </a:fillRef>
-          <a:effectRef idx="0">
-            <a:schemeClr val="dk1"/>
-          </a:effectRef>
-          <a:fontRef idx="minor">
-            <a:schemeClr val="tx1"/>
-          </a:fontRef>
-        </p:style>
-      </p:cxnSp>
-      <p:cxnSp>
-        <p:nvCxnSpPr>
-          <p:cNvPr id="1050" name="Straight Connector 1049">
-            <a:extLst>
-              <a:ext uri="{FF2B5EF4-FFF2-40B4-BE49-F238E27FC236}">
-                <a16:creationId xmlns:a16="http://schemas.microsoft.com/office/drawing/2014/main" id="{D3DAFDEE-D9E5-1D68-8EB9-E51F04AB1645}"/>
-              </a:ext>
-            </a:extLst>
-          </p:cNvPr>
-          <p:cNvCxnSpPr>
-            <a:cxnSpLocks/>
-          </p:cNvCxnSpPr>
-          <p:nvPr/>
-        </p:nvCxnSpPr>
-        <p:spPr>
-          <a:xfrm flipV="1">
-            <a:off x="27725790" y="21104777"/>
-            <a:ext cx="0" cy="165469"/>
-          </a:xfrm>
-          <a:prstGeom prst="line">
-            <a:avLst/>
-          </a:prstGeom>
-          <a:ln w="19050">
-            <a:prstDash val="lgDash"/>
-          </a:ln>
-        </p:spPr>
-        <p:style>
-          <a:lnRef idx="1">
-            <a:schemeClr val="dk1"/>
-          </a:lnRef>
-          <a:fillRef idx="0">
-            <a:schemeClr val="dk1"/>
-          </a:fillRef>
-          <a:effectRef idx="0">
-            <a:schemeClr val="dk1"/>
-          </a:effectRef>
-          <a:fontRef idx="minor">
-            <a:schemeClr val="tx1"/>
-          </a:fontRef>
-        </p:style>
-      </p:cxnSp>
-      <p:cxnSp>
-        <p:nvCxnSpPr>
-          <p:cNvPr id="1051" name="Straight Connector 1050">
-            <a:extLst>
-              <a:ext uri="{FF2B5EF4-FFF2-40B4-BE49-F238E27FC236}">
-                <a16:creationId xmlns:a16="http://schemas.microsoft.com/office/drawing/2014/main" id="{F2AFA6AA-F2FA-7B6D-89B6-C18FBAE3FB74}"/>
-              </a:ext>
-            </a:extLst>
-          </p:cNvPr>
-          <p:cNvCxnSpPr>
-            <a:cxnSpLocks/>
-          </p:cNvCxnSpPr>
-          <p:nvPr/>
-        </p:nvCxnSpPr>
-        <p:spPr>
-          <a:xfrm flipV="1">
-            <a:off x="30545190" y="21104777"/>
-            <a:ext cx="0" cy="165469"/>
-          </a:xfrm>
-          <a:prstGeom prst="line">
-            <a:avLst/>
-          </a:prstGeom>
-          <a:ln w="19050">
-            <a:prstDash val="lgDash"/>
-          </a:ln>
-        </p:spPr>
-        <p:style>
-          <a:lnRef idx="1">
-            <a:schemeClr val="dk1"/>
-          </a:lnRef>
-          <a:fillRef idx="0">
-            <a:schemeClr val="dk1"/>
-          </a:fillRef>
-          <a:effectRef idx="0">
-            <a:schemeClr val="dk1"/>
-          </a:effectRef>
-          <a:fontRef idx="minor">
-            <a:schemeClr val="tx1"/>
-          </a:fontRef>
-        </p:style>
-      </p:cxnSp>
-      <p:cxnSp>
-        <p:nvCxnSpPr>
-          <p:cNvPr id="1052" name="Straight Connector 1051">
-            <a:extLst>
-              <a:ext uri="{FF2B5EF4-FFF2-40B4-BE49-F238E27FC236}">
-                <a16:creationId xmlns:a16="http://schemas.microsoft.com/office/drawing/2014/main" id="{9F2A7656-0EEE-7013-0DB8-ADC5FDA2A8B2}"/>
-              </a:ext>
-            </a:extLst>
-          </p:cNvPr>
-          <p:cNvCxnSpPr>
-            <a:cxnSpLocks/>
-          </p:cNvCxnSpPr>
-          <p:nvPr/>
-        </p:nvCxnSpPr>
-        <p:spPr>
-          <a:xfrm flipV="1">
-            <a:off x="32221590" y="21104777"/>
-            <a:ext cx="0" cy="165469"/>
-          </a:xfrm>
-          <a:prstGeom prst="line">
-            <a:avLst/>
-          </a:prstGeom>
-          <a:ln w="19050">
-            <a:prstDash val="lgDash"/>
-          </a:ln>
-        </p:spPr>
-        <p:style>
-          <a:lnRef idx="1">
-            <a:schemeClr val="dk1"/>
-          </a:lnRef>
-          <a:fillRef idx="0">
-            <a:schemeClr val="dk1"/>
-          </a:fillRef>
-          <a:effectRef idx="0">
-            <a:schemeClr val="dk1"/>
-          </a:effectRef>
-          <a:fontRef idx="minor">
-            <a:schemeClr val="tx1"/>
-          </a:fontRef>
-        </p:style>
-      </p:cxnSp>
-      <p:cxnSp>
-        <p:nvCxnSpPr>
-          <p:cNvPr id="1053" name="Straight Connector 1052">
-            <a:extLst>
-              <a:ext uri="{FF2B5EF4-FFF2-40B4-BE49-F238E27FC236}">
-                <a16:creationId xmlns:a16="http://schemas.microsoft.com/office/drawing/2014/main" id="{45B61E4A-833A-BA3F-9B21-F25237F7E669}"/>
-              </a:ext>
-            </a:extLst>
-          </p:cNvPr>
-          <p:cNvCxnSpPr>
-            <a:cxnSpLocks/>
-          </p:cNvCxnSpPr>
-          <p:nvPr/>
-        </p:nvCxnSpPr>
-        <p:spPr>
-          <a:xfrm flipV="1">
-            <a:off x="19572390" y="26086816"/>
-            <a:ext cx="0" cy="165469"/>
-          </a:xfrm>
-          <a:prstGeom prst="line">
-            <a:avLst/>
-          </a:prstGeom>
-          <a:ln w="19050">
-            <a:prstDash val="lgDash"/>
-          </a:ln>
-        </p:spPr>
-        <p:style>
-          <a:lnRef idx="1">
-            <a:schemeClr val="dk1"/>
-          </a:lnRef>
-          <a:fillRef idx="0">
-            <a:schemeClr val="dk1"/>
-          </a:fillRef>
-          <a:effectRef idx="0">
-            <a:schemeClr val="dk1"/>
-          </a:effectRef>
-          <a:fontRef idx="minor">
-            <a:schemeClr val="tx1"/>
-          </a:fontRef>
-        </p:style>
-      </p:cxnSp>
-      <p:cxnSp>
-        <p:nvCxnSpPr>
-          <p:cNvPr id="1054" name="Straight Connector 1053">
-            <a:extLst>
-              <a:ext uri="{FF2B5EF4-FFF2-40B4-BE49-F238E27FC236}">
-                <a16:creationId xmlns:a16="http://schemas.microsoft.com/office/drawing/2014/main" id="{B4545213-9D78-5A7D-F0ED-7247C7E86F0A}"/>
-              </a:ext>
-            </a:extLst>
-          </p:cNvPr>
-          <p:cNvCxnSpPr>
-            <a:cxnSpLocks/>
-          </p:cNvCxnSpPr>
-          <p:nvPr/>
-        </p:nvCxnSpPr>
-        <p:spPr>
-          <a:xfrm flipV="1">
-            <a:off x="22467990" y="26086816"/>
-            <a:ext cx="0" cy="165469"/>
-          </a:xfrm>
-          <a:prstGeom prst="line">
-            <a:avLst/>
-          </a:prstGeom>
-          <a:ln w="19050">
-            <a:prstDash val="lgDash"/>
-          </a:ln>
-        </p:spPr>
-        <p:style>
-          <a:lnRef idx="1">
-            <a:schemeClr val="dk1"/>
-          </a:lnRef>
-          <a:fillRef idx="0">
-            <a:schemeClr val="dk1"/>
-          </a:fillRef>
-          <a:effectRef idx="0">
-            <a:schemeClr val="dk1"/>
-          </a:effectRef>
-          <a:fontRef idx="minor">
-            <a:schemeClr val="tx1"/>
-          </a:fontRef>
-        </p:style>
-      </p:cxnSp>
-      <p:cxnSp>
-        <p:nvCxnSpPr>
-          <p:cNvPr id="1055" name="Straight Connector 1054">
-            <a:extLst>
-              <a:ext uri="{FF2B5EF4-FFF2-40B4-BE49-F238E27FC236}">
-                <a16:creationId xmlns:a16="http://schemas.microsoft.com/office/drawing/2014/main" id="{EAF13472-2A54-A942-9989-189633D8FC45}"/>
-              </a:ext>
-            </a:extLst>
-          </p:cNvPr>
-          <p:cNvCxnSpPr>
-            <a:cxnSpLocks/>
-          </p:cNvCxnSpPr>
-          <p:nvPr/>
-        </p:nvCxnSpPr>
-        <p:spPr>
-          <a:xfrm flipV="1">
-            <a:off x="23839590" y="26086816"/>
-            <a:ext cx="0" cy="165469"/>
-          </a:xfrm>
-          <a:prstGeom prst="line">
-            <a:avLst/>
-          </a:prstGeom>
-          <a:ln w="19050">
-            <a:prstDash val="lgDash"/>
-          </a:ln>
-        </p:spPr>
-        <p:style>
-          <a:lnRef idx="1">
-            <a:schemeClr val="dk1"/>
-          </a:lnRef>
-          <a:fillRef idx="0">
-            <a:schemeClr val="dk1"/>
-          </a:fillRef>
-          <a:effectRef idx="0">
-            <a:schemeClr val="dk1"/>
-          </a:effectRef>
-          <a:fontRef idx="minor">
-            <a:schemeClr val="tx1"/>
-          </a:fontRef>
-        </p:style>
-      </p:cxnSp>
-      <p:cxnSp>
-        <p:nvCxnSpPr>
-          <p:cNvPr id="1056" name="Straight Connector 1055">
-            <a:extLst>
-              <a:ext uri="{FF2B5EF4-FFF2-40B4-BE49-F238E27FC236}">
-                <a16:creationId xmlns:a16="http://schemas.microsoft.com/office/drawing/2014/main" id="{97023478-EBF1-C0B2-4640-43B6062C44A4}"/>
-              </a:ext>
-            </a:extLst>
-          </p:cNvPr>
-          <p:cNvCxnSpPr>
-            <a:cxnSpLocks/>
-          </p:cNvCxnSpPr>
-          <p:nvPr/>
-        </p:nvCxnSpPr>
-        <p:spPr>
-          <a:xfrm flipV="1">
-            <a:off x="27878190" y="26007090"/>
-            <a:ext cx="0" cy="165469"/>
-          </a:xfrm>
-          <a:prstGeom prst="line">
-            <a:avLst/>
-          </a:prstGeom>
-          <a:ln w="19050">
-            <a:prstDash val="lgDash"/>
-          </a:ln>
-        </p:spPr>
-        <p:style>
-          <a:lnRef idx="1">
-            <a:schemeClr val="dk1"/>
-          </a:lnRef>
-          <a:fillRef idx="0">
-            <a:schemeClr val="dk1"/>
-          </a:fillRef>
-          <a:effectRef idx="0">
-            <a:schemeClr val="dk1"/>
-          </a:effectRef>
-          <a:fontRef idx="minor">
-            <a:schemeClr val="tx1"/>
-          </a:fontRef>
-        </p:style>
-      </p:cxnSp>
-      <p:cxnSp>
-        <p:nvCxnSpPr>
-          <p:cNvPr id="1057" name="Straight Connector 1056">
-            <a:extLst>
-              <a:ext uri="{FF2B5EF4-FFF2-40B4-BE49-F238E27FC236}">
-                <a16:creationId xmlns:a16="http://schemas.microsoft.com/office/drawing/2014/main" id="{EABAA8CD-3573-D737-5C52-07AF46DD77DB}"/>
-              </a:ext>
-            </a:extLst>
-          </p:cNvPr>
-          <p:cNvCxnSpPr>
-            <a:cxnSpLocks/>
-          </p:cNvCxnSpPr>
-          <p:nvPr/>
-        </p:nvCxnSpPr>
-        <p:spPr>
-          <a:xfrm flipV="1">
-            <a:off x="30697590" y="26007090"/>
-            <a:ext cx="0" cy="165469"/>
-          </a:xfrm>
-          <a:prstGeom prst="line">
-            <a:avLst/>
-          </a:prstGeom>
-          <a:ln w="19050">
-            <a:prstDash val="lgDash"/>
-          </a:ln>
-        </p:spPr>
-        <p:style>
-          <a:lnRef idx="1">
-            <a:schemeClr val="dk1"/>
-          </a:lnRef>
-          <a:fillRef idx="0">
-            <a:schemeClr val="dk1"/>
-          </a:fillRef>
-          <a:effectRef idx="0">
-            <a:schemeClr val="dk1"/>
-          </a:effectRef>
-          <a:fontRef idx="minor">
-            <a:schemeClr val="tx1"/>
-          </a:fontRef>
-        </p:style>
-      </p:cxnSp>
-      <p:cxnSp>
-        <p:nvCxnSpPr>
-          <p:cNvPr id="1058" name="Straight Connector 1057">
-            <a:extLst>
-              <a:ext uri="{FF2B5EF4-FFF2-40B4-BE49-F238E27FC236}">
-                <a16:creationId xmlns:a16="http://schemas.microsoft.com/office/drawing/2014/main" id="{60C150C5-AE9C-3C24-36BA-5DE7D6481E18}"/>
-              </a:ext>
-            </a:extLst>
-          </p:cNvPr>
-          <p:cNvCxnSpPr>
-            <a:cxnSpLocks/>
-          </p:cNvCxnSpPr>
-          <p:nvPr/>
-        </p:nvCxnSpPr>
-        <p:spPr>
-          <a:xfrm flipV="1">
-            <a:off x="32145390" y="26007090"/>
-            <a:ext cx="0" cy="165469"/>
-          </a:xfrm>
-          <a:prstGeom prst="line">
-            <a:avLst/>
-          </a:prstGeom>
-          <a:ln w="19050">
-            <a:prstDash val="lgDash"/>
-          </a:ln>
-        </p:spPr>
-        <p:style>
-          <a:lnRef idx="1">
-            <a:schemeClr val="dk1"/>
-          </a:lnRef>
-          <a:fillRef idx="0">
-            <a:schemeClr val="dk1"/>
-          </a:fillRef>
-          <a:effectRef idx="0">
-            <a:schemeClr val="dk1"/>
-          </a:effectRef>
-          <a:fontRef idx="minor">
-            <a:schemeClr val="tx1"/>
-          </a:fontRef>
-        </p:style>
-      </p:cxnSp>
-      <p:pic>
-        <p:nvPicPr>
-          <p:cNvPr id="15" name="Picture 14" descr="A graph of different colored lines&#10;&#10;AI-generated content may be incorrect.">
-            <a:extLst>
-              <a:ext uri="{FF2B5EF4-FFF2-40B4-BE49-F238E27FC236}">
-                <a16:creationId xmlns:a16="http://schemas.microsoft.com/office/drawing/2014/main" id="{6F1E99EB-549B-E9F4-C4C6-CCFBCE759AD8}"/>
-              </a:ext>
-            </a:extLst>
-          </p:cNvPr>
-          <p:cNvPicPr>
-            <a:picLocks noChangeAspect="1"/>
-          </p:cNvPicPr>
-          <p:nvPr/>
-        </p:nvPicPr>
-        <p:blipFill>
-          <a:blip r:embed="rId5">
-            <a:extLst>
-              <a:ext uri="{28A0092B-C50C-407E-A947-70E740481C1C}">
-                <a14:useLocalDpi xmlns:a14="http://schemas.microsoft.com/office/drawing/2010/main" val="0"/>
-              </a:ext>
-            </a:extLst>
-          </a:blip>
-          <a:srcRect l="88306" t="32174" b="33648"/>
-          <a:stretch>
-            <a:fillRect/>
-          </a:stretch>
-        </p:blipFill>
-        <p:spPr>
-          <a:xfrm>
-            <a:off x="14585669" y="19739617"/>
-            <a:ext cx="2452944" cy="2389927"/>
-          </a:xfrm>
-          <a:prstGeom prst="rect">
-            <a:avLst/>
-          </a:prstGeom>
-        </p:spPr>
-      </p:pic>
       <p:sp>
         <p:nvSpPr>
           <p:cNvPr id="2" name="Title 1">
@@ -2856,7 +2641,7 @@
         </p:nvSpPr>
         <p:spPr>
           <a:xfrm>
-            <a:off x="837036" y="978053"/>
+            <a:off x="837036" y="777081"/>
             <a:ext cx="26832555" cy="2580299"/>
           </a:xfrm>
         </p:spPr>
@@ -2891,8 +2676,8 @@
         </p:nvSpPr>
         <p:spPr>
           <a:xfrm>
-            <a:off x="897042" y="3488618"/>
-            <a:ext cx="31415565" cy="1076230"/>
+            <a:off x="837036" y="3238453"/>
+            <a:ext cx="31415565" cy="1247708"/>
           </a:xfrm>
         </p:spPr>
         <p:txBody>
@@ -2905,9 +2690,30 @@
             </a:r>
             <a:r>
               <a:rPr lang="en-US" sz="3600" dirty="0"/>
-              <a:t>Smithsonian Environmental Research Center, Maryland, USA</a:t>
-            </a:r>
-            <a:endParaRPr lang="en-US" dirty="0"/>
+              <a:t>Stephanie J. Wilson, Alice Stearns, Evan Phillips, Nathan Chin, Pat Megonigal, Ben Bond-Lamberty, </a:t>
+            </a:r>
+            <a:r>
+              <a:rPr lang="en-US" sz="3600" b="1" dirty="0"/>
+              <a:t>and COMPASS team </a:t>
+            </a:r>
+          </a:p>
+          <a:p>
+            <a:r>
+              <a:rPr lang="en-US" sz="3600" baseline="30000" dirty="0"/>
+              <a:t>1</a:t>
+            </a:r>
+            <a:r>
+              <a:rPr lang="en-US" sz="3600" dirty="0"/>
+              <a:t>Smithsonian Environmental Research Center, Maryland, USA, </a:t>
+            </a:r>
+            <a:r>
+              <a:rPr lang="en-US" sz="3600" baseline="30000" dirty="0"/>
+              <a:t>2</a:t>
+            </a:r>
+            <a:r>
+              <a:rPr lang="en-US" sz="3600" dirty="0"/>
+              <a:t>Pacific Northwest National Laboratory</a:t>
+            </a:r>
           </a:p>
         </p:txBody>
       </p:sp>
@@ -2927,8 +2733,8 @@
         </p:nvSpPr>
         <p:spPr>
           <a:xfrm>
-            <a:off x="778417" y="4668837"/>
-            <a:ext cx="16381197" cy="2712495"/>
+            <a:off x="778417" y="4846740"/>
+            <a:ext cx="16381197" cy="3778941"/>
           </a:xfrm>
           <a:prstGeom prst="rect">
             <a:avLst/>
@@ -3139,7 +2945,71 @@
                 <a:latin typeface="Arial" panose="020B0604020202020204" pitchFamily="34" charset="0"/>
                 <a:cs typeface="Arial" panose="020B0604020202020204" pitchFamily="34" charset="0"/>
               </a:rPr>
-              <a:t>Porewater sampling from 2022-2025  </a:t>
+              <a:t>Porewater sampling from 2022-2025 </a:t>
+            </a:r>
+            <a:r>
+              <a:rPr lang="en-US" sz="2800" dirty="0">
+                <a:latin typeface="Arial" panose="020B0604020202020204" pitchFamily="34" charset="0"/>
+                <a:cs typeface="Arial" panose="020B0604020202020204" pitchFamily="34" charset="0"/>
+                <a:sym typeface="Wingdings" panose="05000000000000000000" pitchFamily="2" charset="2"/>
+              </a:rPr>
+              <a:t> </a:t>
+            </a:r>
+            <a:r>
+              <a:rPr lang="en-US" sz="2800" dirty="0">
+                <a:latin typeface="Arial" panose="020B0604020202020204" pitchFamily="34" charset="0"/>
+                <a:cs typeface="Arial" panose="020B0604020202020204" pitchFamily="34" charset="0"/>
+              </a:rPr>
+              <a:t>Analyzed for DIC, DOC, Total Alkalinity, CDOM, H</a:t>
+            </a:r>
+            <a:r>
+              <a:rPr lang="en-US" sz="2800" baseline="-25000" dirty="0">
+                <a:latin typeface="Arial" panose="020B0604020202020204" pitchFamily="34" charset="0"/>
+                <a:cs typeface="Arial" panose="020B0604020202020204" pitchFamily="34" charset="0"/>
+              </a:rPr>
+              <a:t>2</a:t>
+            </a:r>
+            <a:r>
+              <a:rPr lang="en-US" sz="2800" dirty="0">
+                <a:latin typeface="Arial" panose="020B0604020202020204" pitchFamily="34" charset="0"/>
+                <a:cs typeface="Arial" panose="020B0604020202020204" pitchFamily="34" charset="0"/>
+              </a:rPr>
+              <a:t>S, Cl</a:t>
+            </a:r>
+            <a:r>
+              <a:rPr lang="en-US" sz="2800" baseline="30000" dirty="0">
+                <a:latin typeface="Arial" panose="020B0604020202020204" pitchFamily="34" charset="0"/>
+                <a:cs typeface="Arial" panose="020B0604020202020204" pitchFamily="34" charset="0"/>
+              </a:rPr>
+              <a:t>-</a:t>
+            </a:r>
+            <a:r>
+              <a:rPr lang="en-US" sz="2800" dirty="0">
+                <a:latin typeface="Arial" panose="020B0604020202020204" pitchFamily="34" charset="0"/>
+                <a:cs typeface="Arial" panose="020B0604020202020204" pitchFamily="34" charset="0"/>
+              </a:rPr>
+              <a:t>, Nutrients, and </a:t>
+            </a:r>
+            <a:r>
+              <a:rPr lang="en-US" sz="2800" b="1" dirty="0">
+                <a:latin typeface="Arial" panose="020B0604020202020204" pitchFamily="34" charset="0"/>
+                <a:cs typeface="Arial" panose="020B0604020202020204" pitchFamily="34" charset="0"/>
+              </a:rPr>
+              <a:t>SO</a:t>
+            </a:r>
+            <a:r>
+              <a:rPr lang="en-US" sz="2800" b="1" baseline="-25000" dirty="0">
+                <a:latin typeface="Arial" panose="020B0604020202020204" pitchFamily="34" charset="0"/>
+                <a:cs typeface="Arial" panose="020B0604020202020204" pitchFamily="34" charset="0"/>
+              </a:rPr>
+              <a:t>4</a:t>
+            </a:r>
+            <a:r>
+              <a:rPr lang="en-US" sz="2800" b="1" baseline="30000" dirty="0">
+                <a:latin typeface="Arial" panose="020B0604020202020204" pitchFamily="34" charset="0"/>
+                <a:cs typeface="Arial" panose="020B0604020202020204" pitchFamily="34" charset="0"/>
+              </a:rPr>
+              <a:t>2-</a:t>
             </a:r>
           </a:p>
           <a:p>
@@ -3148,65 +3018,13 @@
               <a:buChar char="•"/>
             </a:pPr>
             <a:r>
-              <a:rPr lang="en-US" sz="2800" dirty="0">
-                <a:latin typeface="Arial" panose="020B0604020202020204" pitchFamily="34" charset="0"/>
-                <a:cs typeface="Arial" panose="020B0604020202020204" pitchFamily="34" charset="0"/>
-              </a:rPr>
-              <a:t>Analyzed for DIC, DOC, Total Alkalinity, CDOM, H</a:t>
-            </a:r>
-            <a:r>
-              <a:rPr lang="en-US" sz="2800" baseline="-25000" dirty="0">
-                <a:latin typeface="Arial" panose="020B0604020202020204" pitchFamily="34" charset="0"/>
-                <a:cs typeface="Arial" panose="020B0604020202020204" pitchFamily="34" charset="0"/>
-              </a:rPr>
-              <a:t>2</a:t>
-            </a:r>
-            <a:r>
-              <a:rPr lang="en-US" sz="2800" dirty="0">
-                <a:latin typeface="Arial" panose="020B0604020202020204" pitchFamily="34" charset="0"/>
-                <a:cs typeface="Arial" panose="020B0604020202020204" pitchFamily="34" charset="0"/>
-              </a:rPr>
-              <a:t>S, Cl</a:t>
-            </a:r>
-            <a:r>
-              <a:rPr lang="en-US" sz="2800" baseline="30000" dirty="0">
-                <a:latin typeface="Arial" panose="020B0604020202020204" pitchFamily="34" charset="0"/>
-                <a:cs typeface="Arial" panose="020B0604020202020204" pitchFamily="34" charset="0"/>
-              </a:rPr>
-              <a:t>-</a:t>
-            </a:r>
-            <a:r>
-              <a:rPr lang="en-US" sz="2800" dirty="0">
-                <a:latin typeface="Arial" panose="020B0604020202020204" pitchFamily="34" charset="0"/>
-                <a:cs typeface="Arial" panose="020B0604020202020204" pitchFamily="34" charset="0"/>
-              </a:rPr>
-              <a:t>, Nutrients, and </a:t>
-            </a:r>
-            <a:r>
-              <a:rPr lang="en-US" sz="2800" b="1" dirty="0">
-                <a:latin typeface="Arial" panose="020B0604020202020204" pitchFamily="34" charset="0"/>
-                <a:cs typeface="Arial" panose="020B0604020202020204" pitchFamily="34" charset="0"/>
-              </a:rPr>
-              <a:t>SO</a:t>
-            </a:r>
-            <a:r>
-              <a:rPr lang="en-US" sz="2800" b="1" baseline="-25000" dirty="0">
-                <a:latin typeface="Arial" panose="020B0604020202020204" pitchFamily="34" charset="0"/>
-                <a:cs typeface="Arial" panose="020B0604020202020204" pitchFamily="34" charset="0"/>
-              </a:rPr>
-              <a:t>4</a:t>
-            </a:r>
-            <a:r>
-              <a:rPr lang="en-US" sz="2800" b="1" baseline="30000" dirty="0">
-                <a:latin typeface="Arial" panose="020B0604020202020204" pitchFamily="34" charset="0"/>
-                <a:cs typeface="Arial" panose="020B0604020202020204" pitchFamily="34" charset="0"/>
-              </a:rPr>
-              <a:t>2-</a:t>
-            </a:r>
-            <a:endParaRPr lang="en-US" sz="2800" dirty="0">
-              <a:latin typeface="Arial" panose="020B0604020202020204" pitchFamily="34" charset="0"/>
-              <a:cs typeface="Arial" panose="020B0604020202020204" pitchFamily="34" charset="0"/>
-            </a:endParaRPr>
+              <a:rPr lang="en-US" sz="2800" dirty="0" err="1"/>
+              <a:t>Aquatroll</a:t>
+            </a:r>
+            <a:r>
+              <a:rPr lang="en-US" sz="2800" dirty="0"/>
+              <a:t> AQ600 sensors deployed in the field, collecting continuous ground and soil water and salinity values</a:t>
+            </a:r>
           </a:p>
           <a:p>
             <a:endParaRPr lang="en-US" sz="2800" dirty="0"/>
@@ -3227,7 +3045,7 @@
         </p:nvCxnSpPr>
         <p:spPr>
           <a:xfrm>
-            <a:off x="685800" y="4605517"/>
+            <a:off x="685800" y="4739481"/>
             <a:ext cx="33375600" cy="0"/>
           </a:xfrm>
           <a:prstGeom prst="line">
@@ -3270,7 +3088,7 @@
         </p:nvCxnSpPr>
         <p:spPr>
           <a:xfrm>
-            <a:off x="18199250" y="14540452"/>
+            <a:off x="18067079" y="16169481"/>
             <a:ext cx="15862150" cy="0"/>
           </a:xfrm>
           <a:prstGeom prst="line">
@@ -3313,7 +3131,7 @@
         </p:nvCxnSpPr>
         <p:spPr>
           <a:xfrm>
-            <a:off x="17373600" y="4879335"/>
+            <a:off x="17385664" y="5073039"/>
             <a:ext cx="0" cy="26641242"/>
           </a:xfrm>
           <a:prstGeom prst="line">
@@ -3356,7 +3174,7 @@
         </p:nvCxnSpPr>
         <p:spPr>
           <a:xfrm>
-            <a:off x="742675" y="15233361"/>
+            <a:off x="742675" y="15483681"/>
             <a:ext cx="15862150" cy="0"/>
           </a:xfrm>
           <a:prstGeom prst="line">
@@ -3399,7 +3217,7 @@
         </p:nvSpPr>
         <p:spPr>
           <a:xfrm>
-            <a:off x="18348557" y="14944725"/>
+            <a:off x="18450205" y="16504674"/>
             <a:ext cx="15095898" cy="2097650"/>
           </a:xfrm>
           <a:prstGeom prst="rect">
@@ -3558,7 +3376,7 @@
               <a:t>Seasonal variation</a:t>
             </a:r>
             <a:r>
-              <a:rPr lang="en-US" b="1" dirty="0"/>
+              <a:rPr lang="en-US" sz="3600" b="1" dirty="0"/>
               <a:t> </a:t>
             </a:r>
           </a:p>
@@ -3568,7 +3386,7 @@
               <a:buChar char="•"/>
             </a:pPr>
             <a:r>
-              <a:rPr lang="en-US" dirty="0"/>
+              <a:rPr lang="en-US" sz="2800" dirty="0"/>
               <a:t>Sulfate tends to increase throughout the year and decrease at the start of a new year. </a:t>
             </a:r>
           </a:p>
@@ -3578,239 +3396,20 @@
               <a:buChar char="•"/>
             </a:pPr>
             <a:r>
-              <a:rPr lang="en-US" dirty="0"/>
+              <a:rPr lang="en-US" sz="2800" dirty="0"/>
               <a:t>Sulfate appears to be increasing over time at the </a:t>
             </a:r>
             <a:r>
-              <a:rPr lang="en-US" dirty="0" err="1"/>
+              <a:rPr lang="en-US" sz="2800" dirty="0" err="1"/>
               <a:t>GCReW</a:t>
             </a:r>
             <a:r>
-              <a:rPr lang="en-US" dirty="0"/>
+              <a:rPr lang="en-US" sz="2800" dirty="0"/>
               <a:t> site. </a:t>
             </a:r>
           </a:p>
           <a:p>
             <a:endParaRPr lang="en-US" dirty="0"/>
-          </a:p>
-        </p:txBody>
-      </p:sp>
-      <p:sp>
-        <p:nvSpPr>
-          <p:cNvPr id="7" name="Text Placeholder 3">
-            <a:extLst>
-              <a:ext uri="{FF2B5EF4-FFF2-40B4-BE49-F238E27FC236}">
-                <a16:creationId xmlns:a16="http://schemas.microsoft.com/office/drawing/2014/main" id="{B580F8D7-E067-282C-0BEF-1FA899DCFD3B}"/>
-              </a:ext>
-            </a:extLst>
-          </p:cNvPr>
-          <p:cNvSpPr txBox="1">
-            <a:spLocks/>
-          </p:cNvSpPr>
-          <p:nvPr/>
-        </p:nvSpPr>
-        <p:spPr>
-          <a:xfrm>
-            <a:off x="18269342" y="4879335"/>
-            <a:ext cx="15095898" cy="2511262"/>
-          </a:xfrm>
-          <a:prstGeom prst="rect">
-            <a:avLst/>
-          </a:prstGeom>
-          <a:ln>
-            <a:noFill/>
-          </a:ln>
-        </p:spPr>
-        <p:txBody>
-          <a:bodyPr/>
-          <a:lstStyle>
-            <a:lvl1pPr marL="0" indent="0" algn="l" defTabSz="1654622" rtl="0" eaLnBrk="1" latinLnBrk="0" hangingPunct="1">
-              <a:spcBef>
-                <a:spcPct val="20000"/>
-              </a:spcBef>
-              <a:buFont typeface="Arial" pitchFamily="34" charset="0"/>
-              <a:buNone/>
-              <a:defRPr lang="en-US" sz="2850" kern="1200" dirty="0">
-                <a:solidFill>
-                  <a:schemeClr val="tx1"/>
-                </a:solidFill>
-                <a:latin typeface="Arial" panose="020B0604020202020204" pitchFamily="34" charset="0"/>
-                <a:ea typeface="+mn-ea"/>
-                <a:cs typeface="Arial" panose="020B0604020202020204" pitchFamily="34" charset="0"/>
-              </a:defRPr>
-            </a:lvl1pPr>
-            <a:lvl2pPr marL="1344381" indent="-517070" algn="l" defTabSz="1654622" rtl="0" eaLnBrk="1" latinLnBrk="0" hangingPunct="1">
-              <a:spcBef>
-                <a:spcPct val="20000"/>
-              </a:spcBef>
-              <a:buFont typeface="Arial" pitchFamily="34" charset="0"/>
-              <a:buChar char="–"/>
-              <a:defRPr sz="5067" kern="1200">
-                <a:solidFill>
-                  <a:schemeClr val="tx1"/>
-                </a:solidFill>
-                <a:latin typeface="+mn-lt"/>
-                <a:ea typeface="+mn-ea"/>
-                <a:cs typeface="+mn-cs"/>
-              </a:defRPr>
-            </a:lvl2pPr>
-            <a:lvl3pPr marL="2068278" indent="-413656" algn="l" defTabSz="1654622" rtl="0" eaLnBrk="1" latinLnBrk="0" hangingPunct="1">
-              <a:spcBef>
-                <a:spcPct val="20000"/>
-              </a:spcBef>
-              <a:buFont typeface="Arial" pitchFamily="34" charset="0"/>
-              <a:buChar char="•"/>
-              <a:defRPr sz="4328" kern="1200">
-                <a:solidFill>
-                  <a:schemeClr val="tx1"/>
-                </a:solidFill>
-                <a:latin typeface="+mn-lt"/>
-                <a:ea typeface="+mn-ea"/>
-                <a:cs typeface="+mn-cs"/>
-              </a:defRPr>
-            </a:lvl3pPr>
-            <a:lvl4pPr marL="2895590" indent="-413656" algn="l" defTabSz="1654622" rtl="0" eaLnBrk="1" latinLnBrk="0" hangingPunct="1">
-              <a:spcBef>
-                <a:spcPct val="20000"/>
-              </a:spcBef>
-              <a:buFont typeface="Arial" pitchFamily="34" charset="0"/>
-              <a:buChar char="–"/>
-              <a:defRPr sz="3695" kern="1200">
-                <a:solidFill>
-                  <a:schemeClr val="tx1"/>
-                </a:solidFill>
-                <a:latin typeface="+mn-lt"/>
-                <a:ea typeface="+mn-ea"/>
-                <a:cs typeface="+mn-cs"/>
-              </a:defRPr>
-            </a:lvl4pPr>
-            <a:lvl5pPr marL="3722900" indent="-413656" algn="l" defTabSz="1654622" rtl="0" eaLnBrk="1" latinLnBrk="0" hangingPunct="1">
-              <a:spcBef>
-                <a:spcPct val="20000"/>
-              </a:spcBef>
-              <a:buFont typeface="Arial" pitchFamily="34" charset="0"/>
-              <a:buChar char="»"/>
-              <a:defRPr sz="3695" kern="1200">
-                <a:solidFill>
-                  <a:schemeClr val="tx1"/>
-                </a:solidFill>
-                <a:latin typeface="+mn-lt"/>
-                <a:ea typeface="+mn-ea"/>
-                <a:cs typeface="+mn-cs"/>
-              </a:defRPr>
-            </a:lvl5pPr>
-            <a:lvl6pPr marL="4550212" indent="-413656" algn="l" defTabSz="1654622" rtl="0" eaLnBrk="1" latinLnBrk="0" hangingPunct="1">
-              <a:spcBef>
-                <a:spcPct val="20000"/>
-              </a:spcBef>
-              <a:buFont typeface="Arial" pitchFamily="34" charset="0"/>
-              <a:buChar char="•"/>
-              <a:defRPr sz="3695" kern="1200">
-                <a:solidFill>
-                  <a:schemeClr val="tx1"/>
-                </a:solidFill>
-                <a:latin typeface="+mn-lt"/>
-                <a:ea typeface="+mn-ea"/>
-                <a:cs typeface="+mn-cs"/>
-              </a:defRPr>
-            </a:lvl6pPr>
-            <a:lvl7pPr marL="5377522" indent="-413656" algn="l" defTabSz="1654622" rtl="0" eaLnBrk="1" latinLnBrk="0" hangingPunct="1">
-              <a:spcBef>
-                <a:spcPct val="20000"/>
-              </a:spcBef>
-              <a:buFont typeface="Arial" pitchFamily="34" charset="0"/>
-              <a:buChar char="•"/>
-              <a:defRPr sz="3695" kern="1200">
-                <a:solidFill>
-                  <a:schemeClr val="tx1"/>
-                </a:solidFill>
-                <a:latin typeface="+mn-lt"/>
-                <a:ea typeface="+mn-ea"/>
-                <a:cs typeface="+mn-cs"/>
-              </a:defRPr>
-            </a:lvl7pPr>
-            <a:lvl8pPr marL="6204835" indent="-413656" algn="l" defTabSz="1654622" rtl="0" eaLnBrk="1" latinLnBrk="0" hangingPunct="1">
-              <a:spcBef>
-                <a:spcPct val="20000"/>
-              </a:spcBef>
-              <a:buFont typeface="Arial" pitchFamily="34" charset="0"/>
-              <a:buChar char="•"/>
-              <a:defRPr sz="3695" kern="1200">
-                <a:solidFill>
-                  <a:schemeClr val="tx1"/>
-                </a:solidFill>
-                <a:latin typeface="+mn-lt"/>
-                <a:ea typeface="+mn-ea"/>
-                <a:cs typeface="+mn-cs"/>
-              </a:defRPr>
-            </a:lvl8pPr>
-            <a:lvl9pPr marL="7032146" indent="-413656" algn="l" defTabSz="1654622" rtl="0" eaLnBrk="1" latinLnBrk="0" hangingPunct="1">
-              <a:spcBef>
-                <a:spcPct val="20000"/>
-              </a:spcBef>
-              <a:buFont typeface="Arial" pitchFamily="34" charset="0"/>
-              <a:buChar char="•"/>
-              <a:defRPr sz="3695" kern="1200">
-                <a:solidFill>
-                  <a:schemeClr val="tx1"/>
-                </a:solidFill>
-                <a:latin typeface="+mn-lt"/>
-                <a:ea typeface="+mn-ea"/>
-                <a:cs typeface="+mn-cs"/>
-              </a:defRPr>
-            </a:lvl9pPr>
-          </a:lstStyle>
-          <a:p>
-            <a:r>
-              <a:rPr lang="en-US" sz="3600" b="1" dirty="0">
-                <a:solidFill>
-                  <a:srgbClr val="75BFE2"/>
-                </a:solidFill>
-              </a:rPr>
-              <a:t>Depth</a:t>
-            </a:r>
-            <a:endParaRPr lang="en-US" dirty="0"/>
-          </a:p>
-          <a:p>
-            <a:pPr marL="688975" lvl="1" indent="-457200">
-              <a:buFont typeface="Arial" panose="020B0604020202020204" pitchFamily="34" charset="0"/>
-              <a:buChar char="•"/>
-            </a:pPr>
-            <a:r>
-              <a:rPr lang="en-US" sz="3200" dirty="0">
-                <a:latin typeface="Arial" panose="020B0604020202020204" pitchFamily="34" charset="0"/>
-                <a:cs typeface="Arial" panose="020B0604020202020204" pitchFamily="34" charset="0"/>
-              </a:rPr>
-              <a:t>Porewater was sampled at three depths: 10, 20, and 45 cm</a:t>
-            </a:r>
-          </a:p>
-          <a:p>
-            <a:pPr marL="688975" lvl="1" indent="-457200">
-              <a:buFont typeface="Arial" panose="020B0604020202020204" pitchFamily="34" charset="0"/>
-              <a:buChar char="•"/>
-            </a:pPr>
-            <a:r>
-              <a:rPr lang="en-US" sz="3200" dirty="0">
-                <a:latin typeface="Arial" panose="020B0604020202020204" pitchFamily="34" charset="0"/>
-                <a:cs typeface="Arial" panose="020B0604020202020204" pitchFamily="34" charset="0"/>
-              </a:rPr>
-              <a:t>Sulfate concentration changes by depth, but this effect varies across site and zone. For example, sulfate is much lower at the 45 cm depth at the </a:t>
-            </a:r>
-            <a:r>
-              <a:rPr lang="en-US" sz="3200" dirty="0" err="1">
-                <a:latin typeface="Arial" panose="020B0604020202020204" pitchFamily="34" charset="0"/>
-                <a:cs typeface="Arial" panose="020B0604020202020204" pitchFamily="34" charset="0"/>
-              </a:rPr>
-              <a:t>Moneystump</a:t>
-            </a:r>
-            <a:r>
-              <a:rPr lang="en-US" sz="3200" dirty="0">
-                <a:latin typeface="Arial" panose="020B0604020202020204" pitchFamily="34" charset="0"/>
-                <a:cs typeface="Arial" panose="020B0604020202020204" pitchFamily="34" charset="0"/>
-              </a:rPr>
-              <a:t> Wetland Zone compared to other depths; however, sulfate is consistent across depths at Goodwin. </a:t>
-            </a:r>
-            <a:endParaRPr lang="en-US" sz="3200" dirty="0"/>
           </a:p>
         </p:txBody>
       </p:sp>
@@ -3828,7 +3427,7 @@
         </p:nvSpPr>
         <p:spPr>
           <a:xfrm>
-            <a:off x="933921" y="12399147"/>
+            <a:off x="1035122" y="12638236"/>
             <a:ext cx="15738541" cy="2693045"/>
           </a:xfrm>
           <a:prstGeom prst="rect">
@@ -3909,7 +3508,7 @@
               </a:spcAft>
             </a:pPr>
             <a:r>
-              <a:rPr lang="en-US" sz="2800" b="0" i="0" u="none" strike="noStrike" dirty="0">
+              <a:rPr lang="en-US" sz="2800" b="1" i="0" u="none" strike="noStrike" dirty="0">
                 <a:solidFill>
                   <a:srgbClr val="000000"/>
                 </a:solidFill>
@@ -3917,20 +3516,9 @@
                 <a:latin typeface="Arial" panose="020B0604020202020204" pitchFamily="34" charset="0"/>
                 <a:cs typeface="Arial" panose="020B0604020202020204" pitchFamily="34" charset="0"/>
               </a:rPr>
-              <a:t>1) the </a:t>
-            </a:r>
-            <a:r>
-              <a:rPr lang="en-US" sz="2800" b="1" i="0" u="none" strike="noStrike" dirty="0">
-                <a:solidFill>
-                  <a:srgbClr val="000000"/>
-                </a:solidFill>
-                <a:effectLst/>
-                <a:latin typeface="Arial" panose="020B0604020202020204" pitchFamily="34" charset="0"/>
-                <a:cs typeface="Arial" panose="020B0604020202020204" pitchFamily="34" charset="0"/>
-              </a:rPr>
-              <a:t>depth and duration of soil saturation </a:t>
-            </a:r>
-            <a:endParaRPr lang="en-US" sz="2800" b="0" dirty="0">
+              <a:t>1) the depth and duration of soil saturation </a:t>
+            </a:r>
+            <a:endParaRPr lang="en-US" sz="2800" b="1" dirty="0">
               <a:effectLst/>
               <a:latin typeface="Arial" panose="020B0604020202020204" pitchFamily="34" charset="0"/>
               <a:cs typeface="Arial" panose="020B0604020202020204" pitchFamily="34" charset="0"/>
@@ -3946,7 +3534,7 @@
               </a:spcAft>
             </a:pPr>
             <a:r>
-              <a:rPr lang="en-US" sz="2800" b="0" i="0" u="none" strike="noStrike" dirty="0">
+              <a:rPr lang="en-US" sz="2800" b="1" i="0" u="none" strike="noStrike" dirty="0">
                 <a:solidFill>
                   <a:srgbClr val="000000"/>
                 </a:solidFill>
@@ -3954,18 +3542,7 @@
                 <a:latin typeface="Arial" panose="020B0604020202020204" pitchFamily="34" charset="0"/>
                 <a:cs typeface="Arial" panose="020B0604020202020204" pitchFamily="34" charset="0"/>
               </a:rPr>
-              <a:t>2) the abundance of </a:t>
-            </a:r>
-            <a:r>
-              <a:rPr lang="en-US" sz="2800" b="1" i="0" u="none" strike="noStrike" dirty="0">
-                <a:solidFill>
-                  <a:srgbClr val="000000"/>
-                </a:solidFill>
-                <a:effectLst/>
-                <a:latin typeface="Arial" panose="020B0604020202020204" pitchFamily="34" charset="0"/>
-                <a:cs typeface="Arial" panose="020B0604020202020204" pitchFamily="34" charset="0"/>
-              </a:rPr>
-              <a:t>redox-sensitive elements</a:t>
+              <a:t>2) the abundance of redox-sensitive elements</a:t>
             </a:r>
           </a:p>
           <a:p>
@@ -4009,43 +3586,6 @@
           </a:p>
         </p:txBody>
       </p:sp>
-      <p:pic>
-        <p:nvPicPr>
-          <p:cNvPr id="9" name="Picture 8" descr="A graph of different types of lines&#10;&#10;AI-generated content may be incorrect.">
-            <a:extLst>
-              <a:ext uri="{FF2B5EF4-FFF2-40B4-BE49-F238E27FC236}">
-                <a16:creationId xmlns:a16="http://schemas.microsoft.com/office/drawing/2014/main" id="{09EDF015-AC84-7DA3-BD5A-225267C491D7}"/>
-              </a:ext>
-            </a:extLst>
-          </p:cNvPr>
-          <p:cNvPicPr>
-            <a:picLocks noChangeAspect="1"/>
-          </p:cNvPicPr>
-          <p:nvPr/>
-        </p:nvPicPr>
-        <p:blipFill>
-          <a:blip r:embed="rId6">
-            <a:extLst>
-              <a:ext uri="{28A0092B-C50C-407E-A947-70E740481C1C}">
-                <a14:useLocalDpi xmlns:a14="http://schemas.microsoft.com/office/drawing/2010/main" val="0"/>
-              </a:ext>
-            </a:extLst>
-          </a:blip>
-          <a:srcRect t="3900"/>
-          <a:stretch>
-            <a:fillRect/>
-          </a:stretch>
-        </p:blipFill>
-        <p:spPr>
-          <a:xfrm>
-            <a:off x="19206043" y="8261037"/>
-            <a:ext cx="13068565" cy="6279415"/>
-          </a:xfrm>
-          <a:prstGeom prst="rect">
-            <a:avLst/>
-          </a:prstGeom>
-        </p:spPr>
-      </p:pic>
       <p:grpSp>
         <p:nvGrpSpPr>
           <p:cNvPr id="16" name="Group 15">
@@ -4060,7 +3600,7 @@
         </p:nvGrpSpPr>
         <p:grpSpPr>
           <a:xfrm>
-            <a:off x="1412690" y="4404611"/>
+            <a:off x="1185837" y="4996902"/>
             <a:ext cx="14975825" cy="7819779"/>
             <a:chOff x="-4093975" y="10585278"/>
             <a:chExt cx="15389819" cy="7038010"/>
@@ -5265,7 +4805,7 @@
                   <p:nvPr/>
                 </p:nvPicPr>
                 <p:blipFill rotWithShape="1">
-                  <a:blip r:embed="rId7">
+                  <a:blip r:embed="rId6">
                     <a:extLst>
                       <a:ext uri="{28A0092B-C50C-407E-A947-70E740481C1C}">
                         <a14:useLocalDpi xmlns:a14="http://schemas.microsoft.com/office/drawing/2010/main" val="0"/>
@@ -5315,7 +4855,7 @@
                   <p:nvPr/>
                 </p:nvPicPr>
                 <p:blipFill rotWithShape="1">
-                  <a:blip r:embed="rId8" cstate="print">
+                  <a:blip r:embed="rId7" cstate="print">
                     <a:extLst>
                       <a:ext uri="{28A0092B-C50C-407E-A947-70E740481C1C}">
                         <a14:useLocalDpi xmlns:a14="http://schemas.microsoft.com/office/drawing/2010/main" val="0"/>
@@ -5771,8 +5311,8 @@
         </p:nvSpPr>
         <p:spPr>
           <a:xfrm>
-            <a:off x="18624523" y="27832532"/>
-            <a:ext cx="14861984" cy="3400317"/>
+            <a:off x="18166504" y="29396420"/>
+            <a:ext cx="14861984" cy="2752090"/>
           </a:xfrm>
           <a:prstGeom prst="rect">
             <a:avLst/>
@@ -5929,7 +5469,7 @@
               </a:rPr>
               <a:t>Take-home messages</a:t>
             </a:r>
-            <a:endParaRPr lang="en-US" b="1" dirty="0"/>
+            <a:endParaRPr lang="en-US" sz="3600" b="1" dirty="0"/>
           </a:p>
           <a:p>
             <a:pPr marL="457200" indent="-457200">
@@ -5937,8 +5477,8 @@
               <a:buChar char="•"/>
             </a:pPr>
             <a:r>
-              <a:rPr lang="en-US" dirty="0"/>
-              <a:t>Porewater sulfate varies predictably across sites and zones, increasing from the upland forest to the wetland. </a:t>
+              <a:rPr lang="en-US" sz="2800" dirty="0"/>
+              <a:t>Sulfate, a redox-sensitive element, was affected by soil saturation and depth, although this effect varies across the TAI. </a:t>
             </a:r>
           </a:p>
           <a:p>
@@ -5947,46 +5487,9 @@
               <a:buChar char="•"/>
             </a:pPr>
             <a:r>
-              <a:rPr lang="en-US" dirty="0"/>
-              <a:t>Porewater sulfate is moderated by salinity, water level/content, and electrical conductivity. </a:t>
-            </a:r>
-          </a:p>
-          <a:p>
-            <a:pPr marL="457200" indent="-457200">
-              <a:buFont typeface="Arial" pitchFamily="34" charset="0"/>
-              <a:buChar char="•"/>
-            </a:pPr>
-            <a:r>
-              <a:rPr lang="en-US" dirty="0"/>
-              <a:t>Sulfate varies less predictably across depths, as this effect varies by site and zone. </a:t>
-            </a:r>
-          </a:p>
-          <a:p>
-            <a:pPr marL="457200" indent="-457200">
-              <a:buFont typeface="Arial" pitchFamily="34" charset="0"/>
-              <a:buChar char="•"/>
-            </a:pPr>
-            <a:r>
-              <a:rPr lang="en-US" dirty="0"/>
-              <a:t>Sulfate increases throughout the season, and at one site, increases across years. </a:t>
-            </a:r>
-          </a:p>
-          <a:p>
-            <a:pPr marL="457200" indent="-457200">
-              <a:buFont typeface="Arial" pitchFamily="34" charset="0"/>
-              <a:buChar char="•"/>
-            </a:pPr>
-            <a:endParaRPr lang="en-US" dirty="0"/>
-          </a:p>
-          <a:p>
-            <a:pPr marL="457200" indent="-457200">
-              <a:buFont typeface="Arial" pitchFamily="34" charset="0"/>
-              <a:buChar char="•"/>
-            </a:pPr>
-            <a:endParaRPr lang="en-US" dirty="0"/>
-          </a:p>
-          <a:p>
-            <a:endParaRPr lang="en-US" dirty="0"/>
+              <a:rPr lang="en-US" sz="2800" dirty="0"/>
+              <a:t>In the future, we can examine the sulfate-depth relationship to determine if there are patterns that explain its variability across sites and zones. </a:t>
+            </a:r>
           </a:p>
         </p:txBody>
       </p:sp>
@@ -6006,7 +5509,7 @@
         </p:nvSpPr>
         <p:spPr>
           <a:xfrm>
-            <a:off x="1242798" y="15436171"/>
+            <a:off x="1270093" y="15559881"/>
             <a:ext cx="15429360" cy="8155030"/>
           </a:xfrm>
           <a:prstGeom prst="rect">
@@ -6172,23 +5675,19 @@
             </a:pPr>
             <a:r>
               <a:rPr lang="en-US" sz="2800" dirty="0"/>
-              <a:t>Porewater was analyzed for </a:t>
-            </a:r>
-            <a:r>
-              <a:rPr lang="en-US" sz="2800" b="1" dirty="0"/>
-              <a:t>SO</a:t>
-            </a:r>
-            <a:r>
-              <a:rPr lang="en-US" sz="2800" b="1" baseline="-25000" dirty="0"/>
+              <a:t>Porewater was analyzed for Sulfate (SO</a:t>
+            </a:r>
+            <a:r>
+              <a:rPr lang="en-US" sz="2800" baseline="-25000" dirty="0"/>
               <a:t>4</a:t>
             </a:r>
             <a:r>
-              <a:rPr lang="en-US" sz="2800" b="1" baseline="30000" dirty="0"/>
+              <a:rPr lang="en-US" sz="2800" baseline="30000" dirty="0"/>
               <a:t>2-</a:t>
             </a:r>
             <a:r>
               <a:rPr lang="en-US" sz="2800" dirty="0"/>
-              <a:t> in 2,293 samples</a:t>
+              <a:t>) in 2,293 samples</a:t>
             </a:r>
           </a:p>
           <a:p>
@@ -6253,79 +5752,6 @@
           </a:p>
         </p:txBody>
       </p:sp>
-      <p:pic>
-        <p:nvPicPr>
-          <p:cNvPr id="1042" name="Picture 1041" descr="A graph of different colored squares&#10;&#10;AI-generated content may be incorrect.">
-            <a:extLst>
-              <a:ext uri="{FF2B5EF4-FFF2-40B4-BE49-F238E27FC236}">
-                <a16:creationId xmlns:a16="http://schemas.microsoft.com/office/drawing/2014/main" id="{04363E67-54FD-37B3-65BB-A8173A952E9D}"/>
-              </a:ext>
-            </a:extLst>
-          </p:cNvPr>
-          <p:cNvPicPr>
-            <a:picLocks noChangeAspect="1"/>
-          </p:cNvPicPr>
-          <p:nvPr/>
-        </p:nvPicPr>
-        <p:blipFill>
-          <a:blip r:embed="rId9">
-            <a:extLst>
-              <a:ext uri="{28A0092B-C50C-407E-A947-70E740481C1C}">
-                <a14:useLocalDpi xmlns:a14="http://schemas.microsoft.com/office/drawing/2010/main" val="0"/>
-              </a:ext>
-            </a:extLst>
-          </a:blip>
-          <a:srcRect t="4399"/>
-          <a:stretch>
-            <a:fillRect/>
-          </a:stretch>
-        </p:blipFill>
-        <p:spPr>
-          <a:xfrm>
-            <a:off x="2677555" y="18193266"/>
-            <a:ext cx="11541659" cy="6620362"/>
-          </a:xfrm>
-          <a:prstGeom prst="rect">
-            <a:avLst/>
-          </a:prstGeom>
-        </p:spPr>
-      </p:pic>
-      <p:pic>
-        <p:nvPicPr>
-          <p:cNvPr id="14" name="Picture 13" descr="A graph of water level and value&#10;&#10;AI-generated content may be incorrect.">
-            <a:extLst>
-              <a:ext uri="{FF2B5EF4-FFF2-40B4-BE49-F238E27FC236}">
-                <a16:creationId xmlns:a16="http://schemas.microsoft.com/office/drawing/2014/main" id="{37395166-1C97-2974-4774-B9647BFFD3B0}"/>
-              </a:ext>
-            </a:extLst>
-          </p:cNvPr>
-          <p:cNvPicPr>
-            <a:picLocks noChangeAspect="1"/>
-          </p:cNvPicPr>
-          <p:nvPr/>
-        </p:nvPicPr>
-        <p:blipFill>
-          <a:blip r:embed="rId10">
-            <a:extLst>
-              <a:ext uri="{28A0092B-C50C-407E-A947-70E740481C1C}">
-                <a14:useLocalDpi xmlns:a14="http://schemas.microsoft.com/office/drawing/2010/main" val="0"/>
-              </a:ext>
-            </a:extLst>
-          </a:blip>
-          <a:stretch>
-            <a:fillRect/>
-          </a:stretch>
-        </p:blipFill>
-        <p:spPr>
-          <a:xfrm>
-            <a:off x="1454042" y="26789484"/>
-            <a:ext cx="13716027" cy="5486411"/>
-          </a:xfrm>
-          <a:prstGeom prst="rect">
-            <a:avLst/>
-          </a:prstGeom>
-        </p:spPr>
-      </p:pic>
       <p:sp>
         <p:nvSpPr>
           <p:cNvPr id="1035" name="Text Placeholder 3">
@@ -6342,8 +5768,8 @@
         </p:nvSpPr>
         <p:spPr>
           <a:xfrm>
-            <a:off x="981439" y="24958265"/>
-            <a:ext cx="15095898" cy="2097650"/>
+            <a:off x="18029138" y="4968081"/>
+            <a:ext cx="15939643" cy="2996291"/>
           </a:xfrm>
           <a:prstGeom prst="rect">
             <a:avLst/>
@@ -6508,12 +5934,224 @@
               <a:buChar char="•"/>
             </a:pPr>
             <a:r>
-              <a:rPr lang="en-US" dirty="0"/>
+              <a:rPr lang="en-US" sz="2800" dirty="0"/>
               <a:t>Sulfate increases with increasing groundwater salinity, groundwater water level, soil electrical conductivity, and soil volumetric water content. </a:t>
             </a:r>
           </a:p>
           <a:p>
-            <a:endParaRPr lang="en-US" dirty="0"/>
+            <a:pPr marL="457200" indent="-457200">
+              <a:buFont typeface="Arial" pitchFamily="34" charset="0"/>
+              <a:buChar char="•"/>
+            </a:pPr>
+            <a:r>
+              <a:rPr lang="en-US" sz="2800" dirty="0"/>
+              <a:t>Sulfate at all depths increase with soil electrical conductivity and soil volumetric water content, which were measured at 10 cm, indicating that similar processes may be occurring at all depths. </a:t>
+            </a:r>
+          </a:p>
+        </p:txBody>
+      </p:sp>
+      <p:sp>
+        <p:nvSpPr>
+          <p:cNvPr id="7" name="Text Placeholder 3">
+            <a:extLst>
+              <a:ext uri="{FF2B5EF4-FFF2-40B4-BE49-F238E27FC236}">
+                <a16:creationId xmlns:a16="http://schemas.microsoft.com/office/drawing/2014/main" id="{B580F8D7-E067-282C-0BEF-1FA899DCFD3B}"/>
+              </a:ext>
+            </a:extLst>
+          </p:cNvPr>
+          <p:cNvSpPr txBox="1">
+            <a:spLocks/>
+          </p:cNvSpPr>
+          <p:nvPr/>
+        </p:nvSpPr>
+        <p:spPr>
+          <a:xfrm>
+            <a:off x="888614" y="24794643"/>
+            <a:ext cx="15095898" cy="2423838"/>
+          </a:xfrm>
+          <a:prstGeom prst="rect">
+            <a:avLst/>
+          </a:prstGeom>
+          <a:ln>
+            <a:noFill/>
+          </a:ln>
+        </p:spPr>
+        <p:txBody>
+          <a:bodyPr/>
+          <a:lstStyle>
+            <a:lvl1pPr marL="0" indent="0" algn="l" defTabSz="1654622" rtl="0" eaLnBrk="1" latinLnBrk="0" hangingPunct="1">
+              <a:spcBef>
+                <a:spcPct val="20000"/>
+              </a:spcBef>
+              <a:buFont typeface="Arial" pitchFamily="34" charset="0"/>
+              <a:buNone/>
+              <a:defRPr lang="en-US" sz="2850" kern="1200" dirty="0">
+                <a:solidFill>
+                  <a:schemeClr val="tx1"/>
+                </a:solidFill>
+                <a:latin typeface="Arial" panose="020B0604020202020204" pitchFamily="34" charset="0"/>
+                <a:ea typeface="+mn-ea"/>
+                <a:cs typeface="Arial" panose="020B0604020202020204" pitchFamily="34" charset="0"/>
+              </a:defRPr>
+            </a:lvl1pPr>
+            <a:lvl2pPr marL="1344381" indent="-517070" algn="l" defTabSz="1654622" rtl="0" eaLnBrk="1" latinLnBrk="0" hangingPunct="1">
+              <a:spcBef>
+                <a:spcPct val="20000"/>
+              </a:spcBef>
+              <a:buFont typeface="Arial" pitchFamily="34" charset="0"/>
+              <a:buChar char="–"/>
+              <a:defRPr sz="5067" kern="1200">
+                <a:solidFill>
+                  <a:schemeClr val="tx1"/>
+                </a:solidFill>
+                <a:latin typeface="+mn-lt"/>
+                <a:ea typeface="+mn-ea"/>
+                <a:cs typeface="+mn-cs"/>
+              </a:defRPr>
+            </a:lvl2pPr>
+            <a:lvl3pPr marL="2068278" indent="-413656" algn="l" defTabSz="1654622" rtl="0" eaLnBrk="1" latinLnBrk="0" hangingPunct="1">
+              <a:spcBef>
+                <a:spcPct val="20000"/>
+              </a:spcBef>
+              <a:buFont typeface="Arial" pitchFamily="34" charset="0"/>
+              <a:buChar char="•"/>
+              <a:defRPr sz="4328" kern="1200">
+                <a:solidFill>
+                  <a:schemeClr val="tx1"/>
+                </a:solidFill>
+                <a:latin typeface="+mn-lt"/>
+                <a:ea typeface="+mn-ea"/>
+                <a:cs typeface="+mn-cs"/>
+              </a:defRPr>
+            </a:lvl3pPr>
+            <a:lvl4pPr marL="2895590" indent="-413656" algn="l" defTabSz="1654622" rtl="0" eaLnBrk="1" latinLnBrk="0" hangingPunct="1">
+              <a:spcBef>
+                <a:spcPct val="20000"/>
+              </a:spcBef>
+              <a:buFont typeface="Arial" pitchFamily="34" charset="0"/>
+              <a:buChar char="–"/>
+              <a:defRPr sz="3695" kern="1200">
+                <a:solidFill>
+                  <a:schemeClr val="tx1"/>
+                </a:solidFill>
+                <a:latin typeface="+mn-lt"/>
+                <a:ea typeface="+mn-ea"/>
+                <a:cs typeface="+mn-cs"/>
+              </a:defRPr>
+            </a:lvl4pPr>
+            <a:lvl5pPr marL="3722900" indent="-413656" algn="l" defTabSz="1654622" rtl="0" eaLnBrk="1" latinLnBrk="0" hangingPunct="1">
+              <a:spcBef>
+                <a:spcPct val="20000"/>
+              </a:spcBef>
+              <a:buFont typeface="Arial" pitchFamily="34" charset="0"/>
+              <a:buChar char="»"/>
+              <a:defRPr sz="3695" kern="1200">
+                <a:solidFill>
+                  <a:schemeClr val="tx1"/>
+                </a:solidFill>
+                <a:latin typeface="+mn-lt"/>
+                <a:ea typeface="+mn-ea"/>
+                <a:cs typeface="+mn-cs"/>
+              </a:defRPr>
+            </a:lvl5pPr>
+            <a:lvl6pPr marL="4550212" indent="-413656" algn="l" defTabSz="1654622" rtl="0" eaLnBrk="1" latinLnBrk="0" hangingPunct="1">
+              <a:spcBef>
+                <a:spcPct val="20000"/>
+              </a:spcBef>
+              <a:buFont typeface="Arial" pitchFamily="34" charset="0"/>
+              <a:buChar char="•"/>
+              <a:defRPr sz="3695" kern="1200">
+                <a:solidFill>
+                  <a:schemeClr val="tx1"/>
+                </a:solidFill>
+                <a:latin typeface="+mn-lt"/>
+                <a:ea typeface="+mn-ea"/>
+                <a:cs typeface="+mn-cs"/>
+              </a:defRPr>
+            </a:lvl6pPr>
+            <a:lvl7pPr marL="5377522" indent="-413656" algn="l" defTabSz="1654622" rtl="0" eaLnBrk="1" latinLnBrk="0" hangingPunct="1">
+              <a:spcBef>
+                <a:spcPct val="20000"/>
+              </a:spcBef>
+              <a:buFont typeface="Arial" pitchFamily="34" charset="0"/>
+              <a:buChar char="•"/>
+              <a:defRPr sz="3695" kern="1200">
+                <a:solidFill>
+                  <a:schemeClr val="tx1"/>
+                </a:solidFill>
+                <a:latin typeface="+mn-lt"/>
+                <a:ea typeface="+mn-ea"/>
+                <a:cs typeface="+mn-cs"/>
+              </a:defRPr>
+            </a:lvl7pPr>
+            <a:lvl8pPr marL="6204835" indent="-413656" algn="l" defTabSz="1654622" rtl="0" eaLnBrk="1" latinLnBrk="0" hangingPunct="1">
+              <a:spcBef>
+                <a:spcPct val="20000"/>
+              </a:spcBef>
+              <a:buFont typeface="Arial" pitchFamily="34" charset="0"/>
+              <a:buChar char="•"/>
+              <a:defRPr sz="3695" kern="1200">
+                <a:solidFill>
+                  <a:schemeClr val="tx1"/>
+                </a:solidFill>
+                <a:latin typeface="+mn-lt"/>
+                <a:ea typeface="+mn-ea"/>
+                <a:cs typeface="+mn-cs"/>
+              </a:defRPr>
+            </a:lvl8pPr>
+            <a:lvl9pPr marL="7032146" indent="-413656" algn="l" defTabSz="1654622" rtl="0" eaLnBrk="1" latinLnBrk="0" hangingPunct="1">
+              <a:spcBef>
+                <a:spcPct val="20000"/>
+              </a:spcBef>
+              <a:buFont typeface="Arial" pitchFamily="34" charset="0"/>
+              <a:buChar char="•"/>
+              <a:defRPr sz="3695" kern="1200">
+                <a:solidFill>
+                  <a:schemeClr val="tx1"/>
+                </a:solidFill>
+                <a:latin typeface="+mn-lt"/>
+                <a:ea typeface="+mn-ea"/>
+                <a:cs typeface="+mn-cs"/>
+              </a:defRPr>
+            </a:lvl9pPr>
+          </a:lstStyle>
+          <a:p>
+            <a:r>
+              <a:rPr lang="en-US" sz="3600" b="1" dirty="0">
+                <a:solidFill>
+                  <a:srgbClr val="75BFE2"/>
+                </a:solidFill>
+              </a:rPr>
+              <a:t>Depth</a:t>
+            </a:r>
+            <a:endParaRPr lang="en-US" sz="3600" dirty="0"/>
+          </a:p>
+          <a:p>
+            <a:pPr marL="688975" lvl="1" indent="-457200">
+              <a:buFont typeface="Arial" panose="020B0604020202020204" pitchFamily="34" charset="0"/>
+              <a:buChar char="•"/>
+            </a:pPr>
+            <a:r>
+              <a:rPr lang="en-US" sz="2800" dirty="0">
+                <a:latin typeface="Arial" panose="020B0604020202020204" pitchFamily="34" charset="0"/>
+                <a:cs typeface="Arial" panose="020B0604020202020204" pitchFamily="34" charset="0"/>
+              </a:rPr>
+              <a:t>Porewater was sampled at three depths: 10, 20, and 45 cm</a:t>
+            </a:r>
+          </a:p>
+          <a:p>
+            <a:pPr marL="688975" lvl="1" indent="-457200">
+              <a:buFont typeface="Arial" panose="020B0604020202020204" pitchFamily="34" charset="0"/>
+              <a:buChar char="•"/>
+            </a:pPr>
+            <a:r>
+              <a:rPr lang="en-US" sz="2800" dirty="0">
+                <a:latin typeface="Arial" panose="020B0604020202020204" pitchFamily="34" charset="0"/>
+                <a:cs typeface="Arial" panose="020B0604020202020204" pitchFamily="34" charset="0"/>
+              </a:rPr>
+              <a:t>Sulfate concentration changes by depth, but this effect varies across site and zone. </a:t>
+            </a:r>
+            <a:endParaRPr lang="en-US" sz="2800" dirty="0"/>
           </a:p>
         </p:txBody>
       </p:sp>
@@ -6533,8 +6171,8 @@
         </p:nvCxnSpPr>
         <p:spPr>
           <a:xfrm>
-            <a:off x="863299" y="24744165"/>
-            <a:ext cx="15099634" cy="0"/>
+            <a:off x="884878" y="24703881"/>
+            <a:ext cx="15888785" cy="0"/>
           </a:xfrm>
           <a:prstGeom prst="line">
             <a:avLst/>
@@ -6560,6 +6198,113 @@
           </a:fontRef>
         </p:style>
       </p:cxnSp>
+      <p:pic>
+        <p:nvPicPr>
+          <p:cNvPr id="1085" name="Picture 1084" descr="A graph of different colored lines&#10;&#10;AI-generated content may be incorrect.">
+            <a:extLst>
+              <a:ext uri="{FF2B5EF4-FFF2-40B4-BE49-F238E27FC236}">
+                <a16:creationId xmlns:a16="http://schemas.microsoft.com/office/drawing/2014/main" id="{9E2D53CD-2078-3011-EB8F-F1979C9B3B22}"/>
+              </a:ext>
+            </a:extLst>
+          </p:cNvPr>
+          <p:cNvPicPr>
+            <a:picLocks noChangeAspect="1"/>
+          </p:cNvPicPr>
+          <p:nvPr/>
+        </p:nvPicPr>
+        <p:blipFill>
+          <a:blip r:embed="rId8">
+            <a:extLst>
+              <a:ext uri="{28A0092B-C50C-407E-A947-70E740481C1C}">
+                <a14:useLocalDpi xmlns:a14="http://schemas.microsoft.com/office/drawing/2010/main" val="0"/>
+              </a:ext>
+            </a:extLst>
+          </a:blip>
+          <a:stretch>
+            <a:fillRect/>
+          </a:stretch>
+        </p:blipFill>
+        <p:spPr>
+          <a:xfrm>
+            <a:off x="778559" y="26620977"/>
+            <a:ext cx="16459233" cy="5029210"/>
+          </a:xfrm>
+          <a:prstGeom prst="rect">
+            <a:avLst/>
+          </a:prstGeom>
+        </p:spPr>
+      </p:pic>
+      <p:pic>
+        <p:nvPicPr>
+          <p:cNvPr id="1104" name="Picture 1103" descr="A graph of water level and value&#10;&#10;AI-generated content may be incorrect.">
+            <a:extLst>
+              <a:ext uri="{FF2B5EF4-FFF2-40B4-BE49-F238E27FC236}">
+                <a16:creationId xmlns:a16="http://schemas.microsoft.com/office/drawing/2014/main" id="{BB487FD2-0D02-18A0-8E65-73832FF97000}"/>
+              </a:ext>
+            </a:extLst>
+          </p:cNvPr>
+          <p:cNvPicPr>
+            <a:picLocks noChangeAspect="1"/>
+          </p:cNvPicPr>
+          <p:nvPr/>
+        </p:nvPicPr>
+        <p:blipFill>
+          <a:blip r:embed="rId9">
+            <a:extLst>
+              <a:ext uri="{28A0092B-C50C-407E-A947-70E740481C1C}">
+                <a14:useLocalDpi xmlns:a14="http://schemas.microsoft.com/office/drawing/2010/main" val="0"/>
+              </a:ext>
+            </a:extLst>
+          </a:blip>
+          <a:stretch>
+            <a:fillRect/>
+          </a:stretch>
+        </p:blipFill>
+        <p:spPr>
+          <a:xfrm>
+            <a:off x="17716241" y="7635081"/>
+            <a:ext cx="16459233" cy="7315215"/>
+          </a:xfrm>
+          <a:prstGeom prst="rect">
+            <a:avLst/>
+          </a:prstGeom>
+        </p:spPr>
+      </p:pic>
+      <p:sp>
+        <p:nvSpPr>
+          <p:cNvPr id="1106" name="TextBox 1105">
+            <a:extLst>
+              <a:ext uri="{FF2B5EF4-FFF2-40B4-BE49-F238E27FC236}">
+                <a16:creationId xmlns:a16="http://schemas.microsoft.com/office/drawing/2014/main" id="{990614C8-403D-9EED-A601-7B130D60F6F4}"/>
+              </a:ext>
+            </a:extLst>
+          </p:cNvPr>
+          <p:cNvSpPr txBox="1"/>
+          <p:nvPr/>
+        </p:nvSpPr>
+        <p:spPr>
+          <a:xfrm>
+            <a:off x="17722867" y="14864430"/>
+            <a:ext cx="17443174" cy="954107"/>
+          </a:xfrm>
+          <a:prstGeom prst="rect">
+            <a:avLst/>
+          </a:prstGeom>
+          <a:noFill/>
+        </p:spPr>
+        <p:txBody>
+          <a:bodyPr wrap="square">
+            <a:spAutoFit/>
+          </a:bodyPr>
+          <a:lstStyle/>
+          <a:p>
+            <a:r>
+              <a:rPr lang="en-US" sz="2800" dirty="0"/>
+              <a:t>Groundwater Salinity measured in meters relative to the ground surface, where positive values indicate water levels above the ground surface. </a:t>
+            </a:r>
+          </a:p>
+        </p:txBody>
+      </p:sp>
     </p:spTree>
     <p:extLst>
       <p:ext uri="{BB962C8B-B14F-4D97-AF65-F5344CB8AC3E}">

</xml_diff>

<commit_message>
Exported table with wilcox_test results for depth difference by site and zone
</commit_message>
<xml_diff>
--- a/ReadZ_GCReW_Symposium_Poster_2026.pptx
+++ b/ReadZ_GCReW_Symposium_Poster_2026.pptx
@@ -135,7 +135,7 @@
 <file path=ppt/revisionInfo.xml><?xml version="1.0" encoding="utf-8"?>
 <p1510:revInfo xmlns:a="http://schemas.openxmlformats.org/drawingml/2006/main" xmlns:r="http://schemas.openxmlformats.org/officeDocument/2006/relationships" xmlns:p1510="http://schemas.microsoft.com/office/powerpoint/2015/10/main">
   <p1510:revLst>
-    <p1510:client id="{B82716F6-75B8-4E39-A6D4-7E66C823071B}" v="112" dt="2026-03-13T20:00:58.886"/>
+    <p1510:client id="{B82716F6-75B8-4E39-A6D4-7E66C823071B}" v="114" dt="2026-03-13T20:07:03.353"/>
   </p1510:revLst>
 </p1510:revInfo>
 </file>
@@ -145,12 +145,12 @@
   <pc:docChgLst>
     <pc:chgData name="Read, Zoe" userId="b08cd0fd-26d2-470b-8ec0-c6e6cb2a79bd" providerId="ADAL" clId="{5AEB2719-95A5-4ED2-9E0E-ED462BB10526}"/>
     <pc:docChg chg="undo custSel addSld delSld modSld modMainMaster">
-      <pc:chgData name="Read, Zoe" userId="b08cd0fd-26d2-470b-8ec0-c6e6cb2a79bd" providerId="ADAL" clId="{5AEB2719-95A5-4ED2-9E0E-ED462BB10526}" dt="2026-03-13T20:01:30.523" v="6420" actId="1036"/>
+      <pc:chgData name="Read, Zoe" userId="b08cd0fd-26d2-470b-8ec0-c6e6cb2a79bd" providerId="ADAL" clId="{5AEB2719-95A5-4ED2-9E0E-ED462BB10526}" dt="2026-03-13T20:07:33.645" v="6439" actId="1038"/>
       <pc:docMkLst>
         <pc:docMk/>
       </pc:docMkLst>
       <pc:sldChg chg="addSp delSp modSp mod modNotesTx">
-        <pc:chgData name="Read, Zoe" userId="b08cd0fd-26d2-470b-8ec0-c6e6cb2a79bd" providerId="ADAL" clId="{5AEB2719-95A5-4ED2-9E0E-ED462BB10526}" dt="2026-03-13T20:01:30.523" v="6420" actId="1036"/>
+        <pc:chgData name="Read, Zoe" userId="b08cd0fd-26d2-470b-8ec0-c6e6cb2a79bd" providerId="ADAL" clId="{5AEB2719-95A5-4ED2-9E0E-ED462BB10526}" dt="2026-03-13T20:07:33.645" v="6439" actId="1038"/>
         <pc:sldMkLst>
           <pc:docMk/>
           <pc:sldMk cId="2005456116" sldId="257"/>
@@ -363,6 +363,14 @@
             <ac:graphicFrameMk id="20" creationId="{6EE1AE5B-A26D-71DD-8EF3-D283BC117F1C}"/>
           </ac:graphicFrameMkLst>
         </pc:graphicFrameChg>
+        <pc:picChg chg="add mod ord">
+          <ac:chgData name="Read, Zoe" userId="b08cd0fd-26d2-470b-8ec0-c6e6cb2a79bd" providerId="ADAL" clId="{5AEB2719-95A5-4ED2-9E0E-ED462BB10526}" dt="2026-03-13T20:06:48.937" v="6428" actId="1035"/>
+          <ac:picMkLst>
+            <pc:docMk/>
+            <pc:sldMk cId="2005456116" sldId="257"/>
+            <ac:picMk id="6" creationId="{65D6C5CC-18B1-CDA4-E731-06FAAFE46261}"/>
+          </ac:picMkLst>
+        </pc:picChg>
         <pc:picChg chg="add del mod">
           <ac:chgData name="Read, Zoe" userId="b08cd0fd-26d2-470b-8ec0-c6e6cb2a79bd" providerId="ADAL" clId="{5AEB2719-95A5-4ED2-9E0E-ED462BB10526}" dt="2026-03-13T14:36:32.963" v="3889" actId="478"/>
           <ac:picMkLst>
@@ -379,6 +387,14 @@
             <ac:picMk id="9" creationId="{09EDF015-AC84-7DA3-BD5A-225267C491D7}"/>
           </ac:picMkLst>
         </pc:picChg>
+        <pc:picChg chg="add mod">
+          <ac:chgData name="Read, Zoe" userId="b08cd0fd-26d2-470b-8ec0-c6e6cb2a79bd" providerId="ADAL" clId="{5AEB2719-95A5-4ED2-9E0E-ED462BB10526}" dt="2026-03-13T20:07:06.893" v="6433" actId="1076"/>
+          <ac:picMkLst>
+            <pc:docMk/>
+            <pc:sldMk cId="2005456116" sldId="257"/>
+            <ac:picMk id="9" creationId="{85DA710A-FE9C-9F98-B2EB-359901B6FE67}"/>
+          </ac:picMkLst>
+        </pc:picChg>
         <pc:picChg chg="add del mod">
           <ac:chgData name="Read, Zoe" userId="b08cd0fd-26d2-470b-8ec0-c6e6cb2a79bd" providerId="ADAL" clId="{5AEB2719-95A5-4ED2-9E0E-ED462BB10526}" dt="2026-03-13T14:37:42.624" v="3894" actId="478"/>
           <ac:picMkLst>
@@ -563,8 +579,8 @@
             <ac:picMk id="1079" creationId="{E89868C9-5DDE-C444-4252-B8FA393EF2CE}"/>
           </ac:picMkLst>
         </pc:picChg>
-        <pc:picChg chg="add mod ord">
-          <ac:chgData name="Read, Zoe" userId="b08cd0fd-26d2-470b-8ec0-c6e6cb2a79bd" providerId="ADAL" clId="{5AEB2719-95A5-4ED2-9E0E-ED462BB10526}" dt="2026-03-13T15:23:17.079" v="5036" actId="1076"/>
+        <pc:picChg chg="add del mod ord">
+          <ac:chgData name="Read, Zoe" userId="b08cd0fd-26d2-470b-8ec0-c6e6cb2a79bd" providerId="ADAL" clId="{5AEB2719-95A5-4ED2-9E0E-ED462BB10526}" dt="2026-03-13T20:06:24.207" v="6421" actId="478"/>
           <ac:picMkLst>
             <pc:docMk/>
             <pc:sldMk cId="2005456116" sldId="257"/>
@@ -828,7 +844,7 @@
           </ac:picMkLst>
         </pc:picChg>
         <pc:picChg chg="add mod ord">
-          <ac:chgData name="Read, Zoe" userId="b08cd0fd-26d2-470b-8ec0-c6e6cb2a79bd" providerId="ADAL" clId="{5AEB2719-95A5-4ED2-9E0E-ED462BB10526}" dt="2026-03-13T19:37:32.640" v="6385" actId="1076"/>
+          <ac:chgData name="Read, Zoe" userId="b08cd0fd-26d2-470b-8ec0-c6e6cb2a79bd" providerId="ADAL" clId="{5AEB2719-95A5-4ED2-9E0E-ED462BB10526}" dt="2026-03-13T20:07:33.645" v="6439" actId="1038"/>
           <ac:picMkLst>
             <pc:docMk/>
             <pc:sldMk cId="2005456116" sldId="257"/>
@@ -843,8 +859,8 @@
             <ac:picMk id="1172" creationId="{39EE0B8F-02B0-BFBB-E24F-71F6667F34A8}"/>
           </ac:picMkLst>
         </pc:picChg>
-        <pc:picChg chg="add mod">
-          <ac:chgData name="Read, Zoe" userId="b08cd0fd-26d2-470b-8ec0-c6e6cb2a79bd" providerId="ADAL" clId="{5AEB2719-95A5-4ED2-9E0E-ED462BB10526}" dt="2026-03-13T20:01:02.508" v="6417" actId="1036"/>
+        <pc:picChg chg="add del mod">
+          <ac:chgData name="Read, Zoe" userId="b08cd0fd-26d2-470b-8ec0-c6e6cb2a79bd" providerId="ADAL" clId="{5AEB2719-95A5-4ED2-9E0E-ED462BB10526}" dt="2026-03-13T20:06:59.447" v="6429" actId="478"/>
           <ac:picMkLst>
             <pc:docMk/>
             <pc:sldMk cId="2005456116" sldId="257"/>
@@ -988,7 +1004,7 @@
           </ac:cxnSpMkLst>
         </pc:cxnChg>
         <pc:cxnChg chg="add mod">
-          <ac:chgData name="Read, Zoe" userId="b08cd0fd-26d2-470b-8ec0-c6e6cb2a79bd" providerId="ADAL" clId="{5AEB2719-95A5-4ED2-9E0E-ED462BB10526}" dt="2026-03-13T19:37:32.640" v="6385" actId="1076"/>
+          <ac:chgData name="Read, Zoe" userId="b08cd0fd-26d2-470b-8ec0-c6e6cb2a79bd" providerId="ADAL" clId="{5AEB2719-95A5-4ED2-9E0E-ED462BB10526}" dt="2026-03-13T20:07:33.645" v="6439" actId="1038"/>
           <ac:cxnSpMkLst>
             <pc:docMk/>
             <pc:sldMk cId="2005456116" sldId="257"/>
@@ -996,7 +1012,7 @@
           </ac:cxnSpMkLst>
         </pc:cxnChg>
         <pc:cxnChg chg="add mod">
-          <ac:chgData name="Read, Zoe" userId="b08cd0fd-26d2-470b-8ec0-c6e6cb2a79bd" providerId="ADAL" clId="{5AEB2719-95A5-4ED2-9E0E-ED462BB10526}" dt="2026-03-13T19:37:32.640" v="6385" actId="1076"/>
+          <ac:chgData name="Read, Zoe" userId="b08cd0fd-26d2-470b-8ec0-c6e6cb2a79bd" providerId="ADAL" clId="{5AEB2719-95A5-4ED2-9E0E-ED462BB10526}" dt="2026-03-13T20:07:33.645" v="6439" actId="1038"/>
           <ac:cxnSpMkLst>
             <pc:docMk/>
             <pc:sldMk cId="2005456116" sldId="257"/>
@@ -1004,7 +1020,7 @@
           </ac:cxnSpMkLst>
         </pc:cxnChg>
         <pc:cxnChg chg="add mod">
-          <ac:chgData name="Read, Zoe" userId="b08cd0fd-26d2-470b-8ec0-c6e6cb2a79bd" providerId="ADAL" clId="{5AEB2719-95A5-4ED2-9E0E-ED462BB10526}" dt="2026-03-13T19:37:32.640" v="6385" actId="1076"/>
+          <ac:chgData name="Read, Zoe" userId="b08cd0fd-26d2-470b-8ec0-c6e6cb2a79bd" providerId="ADAL" clId="{5AEB2719-95A5-4ED2-9E0E-ED462BB10526}" dt="2026-03-13T20:07:33.645" v="6439" actId="1038"/>
           <ac:cxnSpMkLst>
             <pc:docMk/>
             <pc:sldMk cId="2005456116" sldId="257"/>
@@ -1012,7 +1028,7 @@
           </ac:cxnSpMkLst>
         </pc:cxnChg>
         <pc:cxnChg chg="add mod">
-          <ac:chgData name="Read, Zoe" userId="b08cd0fd-26d2-470b-8ec0-c6e6cb2a79bd" providerId="ADAL" clId="{5AEB2719-95A5-4ED2-9E0E-ED462BB10526}" dt="2026-03-13T19:37:32.640" v="6385" actId="1076"/>
+          <ac:chgData name="Read, Zoe" userId="b08cd0fd-26d2-470b-8ec0-c6e6cb2a79bd" providerId="ADAL" clId="{5AEB2719-95A5-4ED2-9E0E-ED462BB10526}" dt="2026-03-13T20:07:33.645" v="6439" actId="1038"/>
           <ac:cxnSpMkLst>
             <pc:docMk/>
             <pc:sldMk cId="2005456116" sldId="257"/>
@@ -1028,7 +1044,7 @@
           </ac:cxnSpMkLst>
         </pc:cxnChg>
         <pc:cxnChg chg="add mod">
-          <ac:chgData name="Read, Zoe" userId="b08cd0fd-26d2-470b-8ec0-c6e6cb2a79bd" providerId="ADAL" clId="{5AEB2719-95A5-4ED2-9E0E-ED462BB10526}" dt="2026-03-13T19:37:32.640" v="6385" actId="1076"/>
+          <ac:chgData name="Read, Zoe" userId="b08cd0fd-26d2-470b-8ec0-c6e6cb2a79bd" providerId="ADAL" clId="{5AEB2719-95A5-4ED2-9E0E-ED462BB10526}" dt="2026-03-13T20:07:33.645" v="6439" actId="1038"/>
           <ac:cxnSpMkLst>
             <pc:docMk/>
             <pc:sldMk cId="2005456116" sldId="257"/>
@@ -1036,7 +1052,7 @@
           </ac:cxnSpMkLst>
         </pc:cxnChg>
         <pc:cxnChg chg="add mod">
-          <ac:chgData name="Read, Zoe" userId="b08cd0fd-26d2-470b-8ec0-c6e6cb2a79bd" providerId="ADAL" clId="{5AEB2719-95A5-4ED2-9E0E-ED462BB10526}" dt="2026-03-13T19:37:32.640" v="6385" actId="1076"/>
+          <ac:chgData name="Read, Zoe" userId="b08cd0fd-26d2-470b-8ec0-c6e6cb2a79bd" providerId="ADAL" clId="{5AEB2719-95A5-4ED2-9E0E-ED462BB10526}" dt="2026-03-13T20:07:33.645" v="6439" actId="1038"/>
           <ac:cxnSpMkLst>
             <pc:docMk/>
             <pc:sldMk cId="2005456116" sldId="257"/>
@@ -1044,7 +1060,7 @@
           </ac:cxnSpMkLst>
         </pc:cxnChg>
         <pc:cxnChg chg="add mod">
-          <ac:chgData name="Read, Zoe" userId="b08cd0fd-26d2-470b-8ec0-c6e6cb2a79bd" providerId="ADAL" clId="{5AEB2719-95A5-4ED2-9E0E-ED462BB10526}" dt="2026-03-13T19:37:32.640" v="6385" actId="1076"/>
+          <ac:chgData name="Read, Zoe" userId="b08cd0fd-26d2-470b-8ec0-c6e6cb2a79bd" providerId="ADAL" clId="{5AEB2719-95A5-4ED2-9E0E-ED462BB10526}" dt="2026-03-13T20:07:33.645" v="6439" actId="1038"/>
           <ac:cxnSpMkLst>
             <pc:docMk/>
             <pc:sldMk cId="2005456116" sldId="257"/>
@@ -1052,7 +1068,7 @@
           </ac:cxnSpMkLst>
         </pc:cxnChg>
         <pc:cxnChg chg="add mod">
-          <ac:chgData name="Read, Zoe" userId="b08cd0fd-26d2-470b-8ec0-c6e6cb2a79bd" providerId="ADAL" clId="{5AEB2719-95A5-4ED2-9E0E-ED462BB10526}" dt="2026-03-13T19:37:32.640" v="6385" actId="1076"/>
+          <ac:chgData name="Read, Zoe" userId="b08cd0fd-26d2-470b-8ec0-c6e6cb2a79bd" providerId="ADAL" clId="{5AEB2719-95A5-4ED2-9E0E-ED462BB10526}" dt="2026-03-13T20:07:33.645" v="6439" actId="1038"/>
           <ac:cxnSpMkLst>
             <pc:docMk/>
             <pc:sldMk cId="2005456116" sldId="257"/>
@@ -1068,7 +1084,7 @@
           </ac:cxnSpMkLst>
         </pc:cxnChg>
         <pc:cxnChg chg="add mod">
-          <ac:chgData name="Read, Zoe" userId="b08cd0fd-26d2-470b-8ec0-c6e6cb2a79bd" providerId="ADAL" clId="{5AEB2719-95A5-4ED2-9E0E-ED462BB10526}" dt="2026-03-13T19:26:15.300" v="6186" actId="1076"/>
+          <ac:chgData name="Read, Zoe" userId="b08cd0fd-26d2-470b-8ec0-c6e6cb2a79bd" providerId="ADAL" clId="{5AEB2719-95A5-4ED2-9E0E-ED462BB10526}" dt="2026-03-13T20:07:33.645" v="6439" actId="1038"/>
           <ac:cxnSpMkLst>
             <pc:docMk/>
             <pc:sldMk cId="2005456116" sldId="257"/>
@@ -2801,10 +2817,10 @@
       </p:grpSpPr>
       <p:pic>
         <p:nvPicPr>
-          <p:cNvPr id="1151" name="Picture 1150" descr="A graph of a number&#10;&#10;AI-generated content may be incorrect.">
+          <p:cNvPr id="6" name="Picture 5" descr="A chart of different colored boxes&#10;&#10;AI-generated content may be incorrect.">
             <a:extLst>
               <a:ext uri="{FF2B5EF4-FFF2-40B4-BE49-F238E27FC236}">
-                <a16:creationId xmlns:a16="http://schemas.microsoft.com/office/drawing/2014/main" id="{9270BAB1-911D-6871-CCA4-EC0A16BAE319}"/>
+                <a16:creationId xmlns:a16="http://schemas.microsoft.com/office/drawing/2014/main" id="{65D6C5CC-18B1-CDA4-E731-06FAAFE46261}"/>
               </a:ext>
             </a:extLst>
           </p:cNvPr>
@@ -2827,8 +2843,8 @@
         </p:blipFill>
         <p:spPr>
           <a:xfrm>
-            <a:off x="17385664" y="19484222"/>
-            <a:ext cx="16916434" cy="10058420"/>
+            <a:off x="501300" y="18455481"/>
+            <a:ext cx="16459233" cy="6400813"/>
           </a:xfrm>
           <a:prstGeom prst="rect">
             <a:avLst/>
@@ -2837,10 +2853,10 @@
       </p:pic>
       <p:pic>
         <p:nvPicPr>
-          <p:cNvPr id="1081" name="Picture 1080" descr="A chart of different colored boxes&#10;&#10;AI-generated content may be incorrect.">
+          <p:cNvPr id="1151" name="Picture 1150" descr="A graph of a number&#10;&#10;AI-generated content may be incorrect.">
             <a:extLst>
               <a:ext uri="{FF2B5EF4-FFF2-40B4-BE49-F238E27FC236}">
-                <a16:creationId xmlns:a16="http://schemas.microsoft.com/office/drawing/2014/main" id="{E751C4E4-E854-FE7E-1EF9-268DA1A23024}"/>
+                <a16:creationId xmlns:a16="http://schemas.microsoft.com/office/drawing/2014/main" id="{9270BAB1-911D-6871-CCA4-EC0A16BAE319}"/>
               </a:ext>
             </a:extLst>
           </p:cNvPr>
@@ -2863,8 +2879,8 @@
         </p:blipFill>
         <p:spPr>
           <a:xfrm>
-            <a:off x="440597" y="18530902"/>
-            <a:ext cx="16459233" cy="6400813"/>
+            <a:off x="17525966" y="19484222"/>
+            <a:ext cx="16916434" cy="10058420"/>
           </a:xfrm>
           <a:prstGeom prst="rect">
             <a:avLst/>
@@ -6559,7 +6575,7 @@
         </p:nvCxnSpPr>
         <p:spPr>
           <a:xfrm>
-            <a:off x="21259800" y="20296787"/>
+            <a:off x="21400102" y="20296787"/>
             <a:ext cx="0" cy="3161485"/>
           </a:xfrm>
           <a:prstGeom prst="line">
@@ -6603,7 +6619,7 @@
         </p:nvCxnSpPr>
         <p:spPr>
           <a:xfrm>
-            <a:off x="24460200" y="20337022"/>
+            <a:off x="24600502" y="20337022"/>
             <a:ext cx="0" cy="3161485"/>
           </a:xfrm>
           <a:prstGeom prst="line">
@@ -6647,7 +6663,7 @@
         </p:nvCxnSpPr>
         <p:spPr>
           <a:xfrm>
-            <a:off x="28575000" y="20337021"/>
+            <a:off x="28715302" y="20337021"/>
             <a:ext cx="0" cy="3161485"/>
           </a:xfrm>
           <a:prstGeom prst="line">
@@ -6691,7 +6707,7 @@
         </p:nvCxnSpPr>
         <p:spPr>
           <a:xfrm>
-            <a:off x="31165800" y="20337020"/>
+            <a:off x="31306102" y="20337020"/>
             <a:ext cx="0" cy="3161485"/>
           </a:xfrm>
           <a:prstGeom prst="line">
@@ -6735,7 +6751,7 @@
         </p:nvCxnSpPr>
         <p:spPr>
           <a:xfrm>
-            <a:off x="32842200" y="20337020"/>
+            <a:off x="32982502" y="20337020"/>
             <a:ext cx="0" cy="3161485"/>
           </a:xfrm>
           <a:prstGeom prst="line">
@@ -6779,7 +6795,7 @@
         </p:nvCxnSpPr>
         <p:spPr>
           <a:xfrm>
-            <a:off x="20574000" y="24906072"/>
+            <a:off x="20714302" y="24906072"/>
             <a:ext cx="0" cy="3200400"/>
           </a:xfrm>
           <a:prstGeom prst="line">
@@ -6823,7 +6839,7 @@
         </p:nvCxnSpPr>
         <p:spPr>
           <a:xfrm>
-            <a:off x="23317200" y="24906071"/>
+            <a:off x="23457502" y="24906071"/>
             <a:ext cx="0" cy="3200401"/>
           </a:xfrm>
           <a:prstGeom prst="line">
@@ -6867,7 +6883,7 @@
         </p:nvCxnSpPr>
         <p:spPr>
           <a:xfrm>
-            <a:off x="24688800" y="24906071"/>
+            <a:off x="24829102" y="24906071"/>
             <a:ext cx="0" cy="3200401"/>
           </a:xfrm>
           <a:prstGeom prst="line">
@@ -6911,7 +6927,7 @@
         </p:nvCxnSpPr>
         <p:spPr>
           <a:xfrm>
-            <a:off x="28651200" y="24906071"/>
+            <a:off x="28791502" y="24906071"/>
             <a:ext cx="0" cy="3200401"/>
           </a:xfrm>
           <a:prstGeom prst="line">
@@ -6955,7 +6971,7 @@
         </p:nvCxnSpPr>
         <p:spPr>
           <a:xfrm>
-            <a:off x="31394400" y="24906071"/>
+            <a:off x="31534702" y="24906071"/>
             <a:ext cx="0" cy="3200401"/>
           </a:xfrm>
           <a:prstGeom prst="line">
@@ -6999,7 +7015,7 @@
         </p:nvCxnSpPr>
         <p:spPr>
           <a:xfrm>
-            <a:off x="32766000" y="24906071"/>
+            <a:off x="32906302" y="24906071"/>
             <a:ext cx="0" cy="3200401"/>
           </a:xfrm>
           <a:prstGeom prst="line">
@@ -7029,10 +7045,10 @@
       </p:cxnSp>
       <p:pic>
         <p:nvPicPr>
-          <p:cNvPr id="1174" name="Picture 1173" descr="A graph of different types of water levels&#10;&#10;AI-generated content may be incorrect.">
+          <p:cNvPr id="9" name="Picture 8" descr="A graph of different types of water levels&#10;&#10;AI-generated content may be incorrect.">
             <a:extLst>
               <a:ext uri="{FF2B5EF4-FFF2-40B4-BE49-F238E27FC236}">
-                <a16:creationId xmlns:a16="http://schemas.microsoft.com/office/drawing/2014/main" id="{75BF8206-810D-06F7-F805-252C6EE25DD9}"/>
+                <a16:creationId xmlns:a16="http://schemas.microsoft.com/office/drawing/2014/main" id="{85DA710A-FE9C-9F98-B2EB-359901B6FE67}"/>
               </a:ext>
             </a:extLst>
           </p:cNvPr>
@@ -7055,7 +7071,7 @@
         </p:blipFill>
         <p:spPr>
           <a:xfrm>
-            <a:off x="17737870" y="8107663"/>
+            <a:off x="17737870" y="8163823"/>
             <a:ext cx="16459233" cy="8229616"/>
           </a:xfrm>
           <a:prstGeom prst="rect">

</xml_diff>

<commit_message>
Edited poster based on Steph's suggestions
</commit_message>
<xml_diff>
--- a/ReadZ_GCReW_Symposium_Poster_2026.pptx
+++ b/ReadZ_GCReW_Symposium_Poster_2026.pptx
@@ -129,13 +129,14 @@
 <file path=ppt/authors.xml><?xml version="1.0" encoding="utf-8"?>
 <p188:authorLst xmlns:a="http://schemas.openxmlformats.org/drawingml/2006/main" xmlns:r="http://schemas.openxmlformats.org/officeDocument/2006/relationships" xmlns:p188="http://schemas.microsoft.com/office/powerpoint/2018/8/main">
   <p188:author id="{50137B73-C207-1407-898B-797CE70D2312}" name="Read, Zoe" initials="ZR" userId="S::ReadZ@SI.EDU::b08cd0fd-26d2-470b-8ec0-c6e6cb2a79bd" providerId="AD"/>
+  <p188:author id="{231D7B86-FC17-2341-A59E-74856DBD8393}" name="Wilson, Stephanie" initials="SW" userId="S::WilsonSJ@SI.EDU::33b13f56-c44d-4ad2-b9ae-7375eaa74b12" providerId="AD"/>
 </p188:authorLst>
 </file>
 
 <file path=ppt/revisionInfo.xml><?xml version="1.0" encoding="utf-8"?>
 <p1510:revInfo xmlns:a="http://schemas.openxmlformats.org/drawingml/2006/main" xmlns:r="http://schemas.openxmlformats.org/officeDocument/2006/relationships" xmlns:p1510="http://schemas.microsoft.com/office/powerpoint/2015/10/main">
   <p1510:revLst>
-    <p1510:client id="{B82716F6-75B8-4E39-A6D4-7E66C823071B}" v="114" dt="2026-03-13T20:07:03.353"/>
+    <p1510:client id="{43AB8F2F-7ED7-4FE6-9983-ECD9988C75B8}" v="6" dt="2026-03-16T11:35:47.524"/>
   </p1510:revLst>
 </p1510:revInfo>
 </file>
@@ -145,12 +146,12 @@
   <pc:docChgLst>
     <pc:chgData name="Read, Zoe" userId="b08cd0fd-26d2-470b-8ec0-c6e6cb2a79bd" providerId="ADAL" clId="{5AEB2719-95A5-4ED2-9E0E-ED462BB10526}"/>
     <pc:docChg chg="undo custSel addSld delSld modSld modMainMaster">
-      <pc:chgData name="Read, Zoe" userId="b08cd0fd-26d2-470b-8ec0-c6e6cb2a79bd" providerId="ADAL" clId="{5AEB2719-95A5-4ED2-9E0E-ED462BB10526}" dt="2026-03-13T20:07:33.645" v="6439" actId="1038"/>
+      <pc:chgData name="Read, Zoe" userId="b08cd0fd-26d2-470b-8ec0-c6e6cb2a79bd" providerId="ADAL" clId="{5AEB2719-95A5-4ED2-9E0E-ED462BB10526}" dt="2026-03-16T11:36:02.334" v="6657" actId="1035"/>
       <pc:docMkLst>
         <pc:docMk/>
       </pc:docMkLst>
-      <pc:sldChg chg="addSp delSp modSp mod modNotesTx">
-        <pc:chgData name="Read, Zoe" userId="b08cd0fd-26d2-470b-8ec0-c6e6cb2a79bd" providerId="ADAL" clId="{5AEB2719-95A5-4ED2-9E0E-ED462BB10526}" dt="2026-03-13T20:07:33.645" v="6439" actId="1038"/>
+      <pc:sldChg chg="addSp delSp modSp mod modCm modNotesTx">
+        <pc:chgData name="Read, Zoe" userId="b08cd0fd-26d2-470b-8ec0-c6e6cb2a79bd" providerId="ADAL" clId="{5AEB2719-95A5-4ED2-9E0E-ED462BB10526}" dt="2026-03-16T11:36:02.334" v="6657" actId="1035"/>
         <pc:sldMkLst>
           <pc:docMk/>
           <pc:sldMk cId="2005456116" sldId="257"/>
@@ -164,7 +165,7 @@
           </ac:spMkLst>
         </pc:spChg>
         <pc:spChg chg="mod">
-          <ac:chgData name="Read, Zoe" userId="b08cd0fd-26d2-470b-8ec0-c6e6cb2a79bd" providerId="ADAL" clId="{5AEB2719-95A5-4ED2-9E0E-ED462BB10526}" dt="2026-03-13T20:00:59.077" v="6414" actId="21"/>
+          <ac:chgData name="Read, Zoe" userId="b08cd0fd-26d2-470b-8ec0-c6e6cb2a79bd" providerId="ADAL" clId="{5AEB2719-95A5-4ED2-9E0E-ED462BB10526}" dt="2026-03-16T11:22:42.938" v="6443" actId="20577"/>
           <ac:spMkLst>
             <pc:docMk/>
             <pc:sldMk cId="2005456116" sldId="257"/>
@@ -180,19 +181,11 @@
           </ac:spMkLst>
         </pc:spChg>
         <pc:spChg chg="add mod ord">
-          <ac:chgData name="Read, Zoe" userId="b08cd0fd-26d2-470b-8ec0-c6e6cb2a79bd" providerId="ADAL" clId="{5AEB2719-95A5-4ED2-9E0E-ED462BB10526}" dt="2026-03-13T19:33:32.228" v="6207" actId="20577"/>
+          <ac:chgData name="Read, Zoe" userId="b08cd0fd-26d2-470b-8ec0-c6e6cb2a79bd" providerId="ADAL" clId="{5AEB2719-95A5-4ED2-9E0E-ED462BB10526}" dt="2026-03-16T11:23:15.018" v="6445" actId="207"/>
           <ac:spMkLst>
             <pc:docMk/>
             <pc:sldMk cId="2005456116" sldId="257"/>
             <ac:spMk id="7" creationId="{B580F8D7-E067-282C-0BEF-1FA899DCFD3B}"/>
-          </ac:spMkLst>
-        </pc:spChg>
-        <pc:spChg chg="del mod">
-          <ac:chgData name="Read, Zoe" userId="b08cd0fd-26d2-470b-8ec0-c6e6cb2a79bd" providerId="ADAL" clId="{5AEB2719-95A5-4ED2-9E0E-ED462BB10526}" dt="2026-03-12T20:26:30.998" v="3594" actId="478"/>
-          <ac:spMkLst>
-            <pc:docMk/>
-            <pc:sldMk cId="2005456116" sldId="257"/>
-            <ac:spMk id="8" creationId="{C27ACF02-AE38-EED1-52AD-AE57386B0269}"/>
           </ac:spMkLst>
         </pc:spChg>
         <pc:spChg chg="mod">
@@ -300,7 +293,7 @@
           </ac:spMkLst>
         </pc:spChg>
         <pc:spChg chg="add mod">
-          <ac:chgData name="Read, Zoe" userId="b08cd0fd-26d2-470b-8ec0-c6e6cb2a79bd" providerId="ADAL" clId="{5AEB2719-95A5-4ED2-9E0E-ED462BB10526}" dt="2026-03-13T20:01:22.771" v="6419" actId="1035"/>
+          <ac:chgData name="Read, Zoe" userId="b08cd0fd-26d2-470b-8ec0-c6e6cb2a79bd" providerId="ADAL" clId="{5AEB2719-95A5-4ED2-9E0E-ED462BB10526}" dt="2026-03-16T11:34:59.565" v="6645" actId="1035"/>
           <ac:spMkLst>
             <pc:docMk/>
             <pc:sldMk cId="2005456116" sldId="257"/>
@@ -308,7 +301,7 @@
           </ac:spMkLst>
         </pc:spChg>
         <pc:spChg chg="add mod">
-          <ac:chgData name="Read, Zoe" userId="b08cd0fd-26d2-470b-8ec0-c6e6cb2a79bd" providerId="ADAL" clId="{5AEB2719-95A5-4ED2-9E0E-ED462BB10526}" dt="2026-03-13T15:20:46.824" v="5011" actId="113"/>
+          <ac:chgData name="Read, Zoe" userId="b08cd0fd-26d2-470b-8ec0-c6e6cb2a79bd" providerId="ADAL" clId="{5AEB2719-95A5-4ED2-9E0E-ED462BB10526}" dt="2026-03-16T11:23:07.849" v="6444" actId="207"/>
           <ac:spMkLst>
             <pc:docMk/>
             <pc:sldMk cId="2005456116" sldId="257"/>
@@ -316,7 +309,7 @@
           </ac:spMkLst>
         </pc:spChg>
         <pc:spChg chg="add mod">
-          <ac:chgData name="Read, Zoe" userId="b08cd0fd-26d2-470b-8ec0-c6e6cb2a79bd" providerId="ADAL" clId="{5AEB2719-95A5-4ED2-9E0E-ED462BB10526}" dt="2026-03-13T19:33:53.441" v="6210" actId="20577"/>
+          <ac:chgData name="Read, Zoe" userId="b08cd0fd-26d2-470b-8ec0-c6e6cb2a79bd" providerId="ADAL" clId="{5AEB2719-95A5-4ED2-9E0E-ED462BB10526}" dt="2026-03-16T11:23:25.664" v="6446" actId="207"/>
           <ac:spMkLst>
             <pc:docMk/>
             <pc:sldMk cId="2005456116" sldId="257"/>
@@ -324,37 +317,13 @@
           </ac:spMkLst>
         </pc:spChg>
         <pc:spChg chg="mod">
-          <ac:chgData name="Read, Zoe" userId="b08cd0fd-26d2-470b-8ec0-c6e6cb2a79bd" providerId="ADAL" clId="{5AEB2719-95A5-4ED2-9E0E-ED462BB10526}" dt="2026-03-13T19:37:17.599" v="6382" actId="1076"/>
+          <ac:chgData name="Read, Zoe" userId="b08cd0fd-26d2-470b-8ec0-c6e6cb2a79bd" providerId="ADAL" clId="{5AEB2719-95A5-4ED2-9E0E-ED462BB10526}" dt="2026-03-16T11:36:02.334" v="6657" actId="1035"/>
           <ac:spMkLst>
             <pc:docMk/>
             <pc:sldMk cId="2005456116" sldId="257"/>
             <ac:spMk id="1046" creationId="{3D22E29A-542C-2707-EE87-D32E923FD26A}"/>
           </ac:spMkLst>
         </pc:spChg>
-        <pc:spChg chg="add del mod">
-          <ac:chgData name="Read, Zoe" userId="b08cd0fd-26d2-470b-8ec0-c6e6cb2a79bd" providerId="ADAL" clId="{5AEB2719-95A5-4ED2-9E0E-ED462BB10526}" dt="2026-03-13T18:44:23.193" v="6000" actId="478"/>
-          <ac:spMkLst>
-            <pc:docMk/>
-            <pc:sldMk cId="2005456116" sldId="257"/>
-            <ac:spMk id="1106" creationId="{990614C8-403D-9EED-A601-7B130D60F6F4}"/>
-          </ac:spMkLst>
-        </pc:spChg>
-        <pc:spChg chg="add del mod">
-          <ac:chgData name="Read, Zoe" userId="b08cd0fd-26d2-470b-8ec0-c6e6cb2a79bd" providerId="ADAL" clId="{5AEB2719-95A5-4ED2-9E0E-ED462BB10526}" dt="2026-03-13T18:39:19.247" v="5999" actId="478"/>
-          <ac:spMkLst>
-            <pc:docMk/>
-            <pc:sldMk cId="2005456116" sldId="257"/>
-            <ac:spMk id="1121" creationId="{E65BED06-F373-80B1-9AE1-C3C5EC044957}"/>
-          </ac:spMkLst>
-        </pc:spChg>
-        <pc:grpChg chg="del">
-          <ac:chgData name="Read, Zoe" userId="b08cd0fd-26d2-470b-8ec0-c6e6cb2a79bd" providerId="ADAL" clId="{5AEB2719-95A5-4ED2-9E0E-ED462BB10526}" dt="2026-03-12T20:13:15.849" v="3367" actId="478"/>
-          <ac:grpSpMkLst>
-            <pc:docMk/>
-            <pc:sldMk cId="2005456116" sldId="257"/>
-            <ac:grpSpMk id="22" creationId="{2BFE48BE-D2C5-8243-5332-F748C7FB4EAC}"/>
-          </ac:grpSpMkLst>
-        </pc:grpChg>
         <pc:graphicFrameChg chg="mod modGraphic">
           <ac:chgData name="Read, Zoe" userId="b08cd0fd-26d2-470b-8ec0-c6e6cb2a79bd" providerId="ADAL" clId="{5AEB2719-95A5-4ED2-9E0E-ED462BB10526}" dt="2026-03-13T18:11:25.336" v="5465" actId="1076"/>
           <ac:graphicFrameMkLst>
@@ -363,8 +332,8 @@
             <ac:graphicFrameMk id="20" creationId="{6EE1AE5B-A26D-71DD-8EF3-D283BC117F1C}"/>
           </ac:graphicFrameMkLst>
         </pc:graphicFrameChg>
-        <pc:picChg chg="add mod ord">
-          <ac:chgData name="Read, Zoe" userId="b08cd0fd-26d2-470b-8ec0-c6e6cb2a79bd" providerId="ADAL" clId="{5AEB2719-95A5-4ED2-9E0E-ED462BB10526}" dt="2026-03-13T20:06:48.937" v="6428" actId="1035"/>
+        <pc:picChg chg="add del mod ord">
+          <ac:chgData name="Read, Zoe" userId="b08cd0fd-26d2-470b-8ec0-c6e6cb2a79bd" providerId="ADAL" clId="{5AEB2719-95A5-4ED2-9E0E-ED462BB10526}" dt="2026-03-16T11:28:05.199" v="6542" actId="478"/>
           <ac:picMkLst>
             <pc:docMk/>
             <pc:sldMk cId="2005456116" sldId="257"/>
@@ -372,499 +341,67 @@
           </ac:picMkLst>
         </pc:picChg>
         <pc:picChg chg="add del mod">
-          <ac:chgData name="Read, Zoe" userId="b08cd0fd-26d2-470b-8ec0-c6e6cb2a79bd" providerId="ADAL" clId="{5AEB2719-95A5-4ED2-9E0E-ED462BB10526}" dt="2026-03-13T14:36:32.963" v="3889" actId="478"/>
+          <ac:chgData name="Read, Zoe" userId="b08cd0fd-26d2-470b-8ec0-c6e6cb2a79bd" providerId="ADAL" clId="{5AEB2719-95A5-4ED2-9E0E-ED462BB10526}" dt="2026-03-16T11:28:46.704" v="6548" actId="478"/>
           <ac:picMkLst>
             <pc:docMk/>
             <pc:sldMk cId="2005456116" sldId="257"/>
-            <ac:picMk id="6" creationId="{E193A4F9-DEAF-C6DE-2623-1C1E36DBB696}"/>
+            <ac:picMk id="8" creationId="{5CF41111-8529-1268-9415-CABE9AC20ADC}"/>
           </ac:picMkLst>
         </pc:picChg>
-        <pc:picChg chg="add del mod modCrop">
-          <ac:chgData name="Read, Zoe" userId="b08cd0fd-26d2-470b-8ec0-c6e6cb2a79bd" providerId="ADAL" clId="{5AEB2719-95A5-4ED2-9E0E-ED462BB10526}" dt="2026-03-13T14:35:54.830" v="3882" actId="478"/>
-          <ac:picMkLst>
-            <pc:docMk/>
-            <pc:sldMk cId="2005456116" sldId="257"/>
-            <ac:picMk id="9" creationId="{09EDF015-AC84-7DA3-BD5A-225267C491D7}"/>
-          </ac:picMkLst>
-        </pc:picChg>
-        <pc:picChg chg="add mod">
-          <ac:chgData name="Read, Zoe" userId="b08cd0fd-26d2-470b-8ec0-c6e6cb2a79bd" providerId="ADAL" clId="{5AEB2719-95A5-4ED2-9E0E-ED462BB10526}" dt="2026-03-13T20:07:06.893" v="6433" actId="1076"/>
+        <pc:picChg chg="add del mod">
+          <ac:chgData name="Read, Zoe" userId="b08cd0fd-26d2-470b-8ec0-c6e6cb2a79bd" providerId="ADAL" clId="{5AEB2719-95A5-4ED2-9E0E-ED462BB10526}" dt="2026-03-16T11:32:18.188" v="6634" actId="478"/>
           <ac:picMkLst>
             <pc:docMk/>
             <pc:sldMk cId="2005456116" sldId="257"/>
             <ac:picMk id="9" creationId="{85DA710A-FE9C-9F98-B2EB-359901B6FE67}"/>
           </ac:picMkLst>
         </pc:picChg>
-        <pc:picChg chg="add del mod">
-          <ac:chgData name="Read, Zoe" userId="b08cd0fd-26d2-470b-8ec0-c6e6cb2a79bd" providerId="ADAL" clId="{5AEB2719-95A5-4ED2-9E0E-ED462BB10526}" dt="2026-03-13T14:37:42.624" v="3894" actId="478"/>
+        <pc:picChg chg="add mod ord">
+          <ac:chgData name="Read, Zoe" userId="b08cd0fd-26d2-470b-8ec0-c6e6cb2a79bd" providerId="ADAL" clId="{5AEB2719-95A5-4ED2-9E0E-ED462BB10526}" dt="2026-03-16T11:28:57.449" v="6551" actId="1076"/>
           <ac:picMkLst>
             <pc:docMk/>
             <pc:sldMk cId="2005456116" sldId="257"/>
-            <ac:picMk id="10" creationId="{87488FFA-0267-8CB3-3D6F-2F08271CB032}"/>
+            <ac:picMk id="11" creationId="{DA28F95C-2111-E10A-4CC1-C069E3C51045}"/>
           </ac:picMkLst>
         </pc:picChg>
-        <pc:picChg chg="add del mod ord modCrop">
-          <ac:chgData name="Read, Zoe" userId="b08cd0fd-26d2-470b-8ec0-c6e6cb2a79bd" providerId="ADAL" clId="{5AEB2719-95A5-4ED2-9E0E-ED462BB10526}" dt="2026-03-13T19:02:40.378" v="6050" actId="478"/>
+        <pc:picChg chg="add del mod">
+          <ac:chgData name="Read, Zoe" userId="b08cd0fd-26d2-470b-8ec0-c6e6cb2a79bd" providerId="ADAL" clId="{5AEB2719-95A5-4ED2-9E0E-ED462BB10526}" dt="2026-03-16T11:35:39.896" v="6650" actId="478"/>
           <ac:picMkLst>
             <pc:docMk/>
             <pc:sldMk cId="2005456116" sldId="257"/>
-            <ac:picMk id="11" creationId="{0144416F-2A82-F7CC-0427-8A36932666F6}"/>
+            <ac:picMk id="15" creationId="{D5EFE006-592F-3411-CBFD-F9BC7ECA928A}"/>
+          </ac:picMkLst>
+        </pc:picChg>
+        <pc:picChg chg="add mod">
+          <ac:chgData name="Read, Zoe" userId="b08cd0fd-26d2-470b-8ec0-c6e6cb2a79bd" providerId="ADAL" clId="{5AEB2719-95A5-4ED2-9E0E-ED462BB10526}" dt="2026-03-16T11:34:11.066" v="6642" actId="1076"/>
+          <ac:picMkLst>
+            <pc:docMk/>
+            <pc:sldMk cId="2005456116" sldId="257"/>
+            <ac:picMk id="22" creationId="{00462A3D-D24C-025E-9B9B-C8F9481AB05B}"/>
           </ac:picMkLst>
         </pc:picChg>
         <pc:picChg chg="add del mod">
-          <ac:chgData name="Read, Zoe" userId="b08cd0fd-26d2-470b-8ec0-c6e6cb2a79bd" providerId="ADAL" clId="{5AEB2719-95A5-4ED2-9E0E-ED462BB10526}" dt="2026-03-13T15:26:55.493" v="5045" actId="478"/>
-          <ac:picMkLst>
-            <pc:docMk/>
-            <pc:sldMk cId="2005456116" sldId="257"/>
-            <ac:picMk id="14" creationId="{37395166-1C97-2974-4774-B9647BFFD3B0}"/>
-          </ac:picMkLst>
-        </pc:picChg>
-        <pc:picChg chg="add del mod ord modCrop">
-          <ac:chgData name="Read, Zoe" userId="b08cd0fd-26d2-470b-8ec0-c6e6cb2a79bd" providerId="ADAL" clId="{5AEB2719-95A5-4ED2-9E0E-ED462BB10526}" dt="2026-03-13T15:13:14.944" v="4945" actId="478"/>
-          <ac:picMkLst>
-            <pc:docMk/>
-            <pc:sldMk cId="2005456116" sldId="257"/>
-            <ac:picMk id="15" creationId="{6F1E99EB-549B-E9F4-C4C6-CCFBCE759AD8}"/>
-          </ac:picMkLst>
-        </pc:picChg>
-        <pc:picChg chg="add del mod">
-          <ac:chgData name="Read, Zoe" userId="b08cd0fd-26d2-470b-8ec0-c6e6cb2a79bd" providerId="ADAL" clId="{5AEB2719-95A5-4ED2-9E0E-ED462BB10526}" dt="2026-03-13T14:58:09.041" v="4859" actId="478"/>
-          <ac:picMkLst>
-            <pc:docMk/>
-            <pc:sldMk cId="2005456116" sldId="257"/>
-            <ac:picMk id="19" creationId="{4A548E57-4FEC-FC9E-37C8-9C6818770C12}"/>
-          </ac:picMkLst>
-        </pc:picChg>
-        <pc:picChg chg="del mod">
-          <ac:chgData name="Read, Zoe" userId="b08cd0fd-26d2-470b-8ec0-c6e6cb2a79bd" providerId="ADAL" clId="{5AEB2719-95A5-4ED2-9E0E-ED462BB10526}" dt="2026-03-12T20:13:02.055" v="3365" actId="478"/>
-          <ac:picMkLst>
-            <pc:docMk/>
-            <pc:sldMk cId="2005456116" sldId="257"/>
-            <ac:picMk id="19" creationId="{6F6CCBC1-FB78-D641-2558-44EE723465AE}"/>
-          </ac:picMkLst>
-        </pc:picChg>
-        <pc:picChg chg="del">
-          <ac:chgData name="Read, Zoe" userId="b08cd0fd-26d2-470b-8ec0-c6e6cb2a79bd" providerId="ADAL" clId="{5AEB2719-95A5-4ED2-9E0E-ED462BB10526}" dt="2026-03-12T20:13:15.849" v="3367" actId="478"/>
-          <ac:picMkLst>
-            <pc:docMk/>
-            <pc:sldMk cId="2005456116" sldId="257"/>
-            <ac:picMk id="24" creationId="{04440FAB-EE3F-FD41-C5C0-9224F3ADC6B1}"/>
-          </ac:picMkLst>
-        </pc:picChg>
-        <pc:picChg chg="add del mod">
-          <ac:chgData name="Read, Zoe" userId="b08cd0fd-26d2-470b-8ec0-c6e6cb2a79bd" providerId="ADAL" clId="{5AEB2719-95A5-4ED2-9E0E-ED462BB10526}" dt="2026-03-13T15:01:01.939" v="4868" actId="478"/>
-          <ac:picMkLst>
-            <pc:docMk/>
-            <pc:sldMk cId="2005456116" sldId="257"/>
-            <ac:picMk id="24" creationId="{3F0569DE-707F-D9F1-1D75-6E1DDB13B5E4}"/>
-          </ac:picMkLst>
-        </pc:picChg>
-        <pc:picChg chg="add del mod ord">
-          <ac:chgData name="Read, Zoe" userId="b08cd0fd-26d2-470b-8ec0-c6e6cb2a79bd" providerId="ADAL" clId="{5AEB2719-95A5-4ED2-9E0E-ED462BB10526}" dt="2026-03-13T15:01:53.310" v="4884" actId="478"/>
-          <ac:picMkLst>
-            <pc:docMk/>
-            <pc:sldMk cId="2005456116" sldId="257"/>
-            <ac:picMk id="1038" creationId="{79B545FE-4759-2D41-AC8C-49367F5FD302}"/>
-          </ac:picMkLst>
-        </pc:picChg>
-        <pc:picChg chg="add del mod">
-          <ac:chgData name="Read, Zoe" userId="b08cd0fd-26d2-470b-8ec0-c6e6cb2a79bd" providerId="ADAL" clId="{5AEB2719-95A5-4ED2-9E0E-ED462BB10526}" dt="2026-03-13T15:02:36.270" v="4894" actId="478"/>
-          <ac:picMkLst>
-            <pc:docMk/>
-            <pc:sldMk cId="2005456116" sldId="257"/>
-            <ac:picMk id="1041" creationId="{C6F1CF14-BF24-F636-555B-EE0412FF8575}"/>
-          </ac:picMkLst>
-        </pc:picChg>
-        <pc:picChg chg="add del mod modCrop">
-          <ac:chgData name="Read, Zoe" userId="b08cd0fd-26d2-470b-8ec0-c6e6cb2a79bd" providerId="ADAL" clId="{5AEB2719-95A5-4ED2-9E0E-ED462BB10526}" dt="2026-03-13T15:13:14.944" v="4945" actId="478"/>
-          <ac:picMkLst>
-            <pc:docMk/>
-            <pc:sldMk cId="2005456116" sldId="257"/>
-            <ac:picMk id="1042" creationId="{04363E67-54FD-37B3-65BB-A8173A952E9D}"/>
-          </ac:picMkLst>
-        </pc:picChg>
-        <pc:picChg chg="add del mod">
-          <ac:chgData name="Read, Zoe" userId="b08cd0fd-26d2-470b-8ec0-c6e6cb2a79bd" providerId="ADAL" clId="{5AEB2719-95A5-4ED2-9E0E-ED462BB10526}" dt="2026-03-13T15:06:17.977" v="4922" actId="478"/>
-          <ac:picMkLst>
-            <pc:docMk/>
-            <pc:sldMk cId="2005456116" sldId="257"/>
-            <ac:picMk id="1048" creationId="{3A2666A1-2DC7-950A-723E-6840B5BC5392}"/>
-          </ac:picMkLst>
-        </pc:picChg>
-        <pc:picChg chg="add del mod">
-          <ac:chgData name="Read, Zoe" userId="b08cd0fd-26d2-470b-8ec0-c6e6cb2a79bd" providerId="ADAL" clId="{5AEB2719-95A5-4ED2-9E0E-ED462BB10526}" dt="2026-03-13T15:06:58.060" v="4929" actId="478"/>
-          <ac:picMkLst>
-            <pc:docMk/>
-            <pc:sldMk cId="2005456116" sldId="257"/>
-            <ac:picMk id="1059" creationId="{EB3694CB-2E69-2599-592D-A9902BAD3ADD}"/>
-          </ac:picMkLst>
-        </pc:picChg>
-        <pc:picChg chg="add del mod">
-          <ac:chgData name="Read, Zoe" userId="b08cd0fd-26d2-470b-8ec0-c6e6cb2a79bd" providerId="ADAL" clId="{5AEB2719-95A5-4ED2-9E0E-ED462BB10526}" dt="2026-03-13T15:07:38.327" v="4937" actId="478"/>
-          <ac:picMkLst>
-            <pc:docMk/>
-            <pc:sldMk cId="2005456116" sldId="257"/>
-            <ac:picMk id="1061" creationId="{5C64DEE6-3355-98B2-AC38-10A3DD327236}"/>
-          </ac:picMkLst>
-        </pc:picChg>
-        <pc:picChg chg="add del mod">
-          <ac:chgData name="Read, Zoe" userId="b08cd0fd-26d2-470b-8ec0-c6e6cb2a79bd" providerId="ADAL" clId="{5AEB2719-95A5-4ED2-9E0E-ED462BB10526}" dt="2026-03-13T15:08:12.270" v="4943" actId="478"/>
-          <ac:picMkLst>
-            <pc:docMk/>
-            <pc:sldMk cId="2005456116" sldId="257"/>
-            <ac:picMk id="1063" creationId="{AC1EC631-C193-3A00-6730-F1F2DABABD96}"/>
-          </ac:picMkLst>
-        </pc:picChg>
-        <pc:picChg chg="add del mod">
-          <ac:chgData name="Read, Zoe" userId="b08cd0fd-26d2-470b-8ec0-c6e6cb2a79bd" providerId="ADAL" clId="{5AEB2719-95A5-4ED2-9E0E-ED462BB10526}" dt="2026-03-13T15:22:30.164" v="5023" actId="478"/>
-          <ac:picMkLst>
-            <pc:docMk/>
-            <pc:sldMk cId="2005456116" sldId="257"/>
-            <ac:picMk id="1065" creationId="{D9220666-D88E-9558-B956-D1D5B159C76E}"/>
-          </ac:picMkLst>
-        </pc:picChg>
-        <pc:picChg chg="add del mod">
-          <ac:chgData name="Read, Zoe" userId="b08cd0fd-26d2-470b-8ec0-c6e6cb2a79bd" providerId="ADAL" clId="{5AEB2719-95A5-4ED2-9E0E-ED462BB10526}" dt="2026-03-13T15:14:14.848" v="4949" actId="478"/>
-          <ac:picMkLst>
-            <pc:docMk/>
-            <pc:sldMk cId="2005456116" sldId="257"/>
-            <ac:picMk id="1067" creationId="{2E554507-40AB-39F1-06F7-5ACA98D452FD}"/>
-          </ac:picMkLst>
-        </pc:picChg>
-        <pc:picChg chg="add del mod">
-          <ac:chgData name="Read, Zoe" userId="b08cd0fd-26d2-470b-8ec0-c6e6cb2a79bd" providerId="ADAL" clId="{5AEB2719-95A5-4ED2-9E0E-ED462BB10526}" dt="2026-03-13T15:14:29.167" v="4954" actId="478"/>
-          <ac:picMkLst>
-            <pc:docMk/>
-            <pc:sldMk cId="2005456116" sldId="257"/>
-            <ac:picMk id="1069" creationId="{8D91DBDB-9E9E-52CB-55AD-9A637EFC0709}"/>
-          </ac:picMkLst>
-        </pc:picChg>
-        <pc:picChg chg="add del mod">
-          <ac:chgData name="Read, Zoe" userId="b08cd0fd-26d2-470b-8ec0-c6e6cb2a79bd" providerId="ADAL" clId="{5AEB2719-95A5-4ED2-9E0E-ED462BB10526}" dt="2026-03-13T15:15:01.560" v="4958" actId="478"/>
-          <ac:picMkLst>
-            <pc:docMk/>
-            <pc:sldMk cId="2005456116" sldId="257"/>
-            <ac:picMk id="1071" creationId="{FEABA2EA-EFA6-54BC-2013-B77804E53F02}"/>
-          </ac:picMkLst>
-        </pc:picChg>
-        <pc:picChg chg="add del mod">
-          <ac:chgData name="Read, Zoe" userId="b08cd0fd-26d2-470b-8ec0-c6e6cb2a79bd" providerId="ADAL" clId="{5AEB2719-95A5-4ED2-9E0E-ED462BB10526}" dt="2026-03-13T15:15:41.221" v="4963" actId="478"/>
-          <ac:picMkLst>
-            <pc:docMk/>
-            <pc:sldMk cId="2005456116" sldId="257"/>
-            <ac:picMk id="1073" creationId="{5466ADED-34D8-BA58-93D9-9F5AE1DBBC21}"/>
-          </ac:picMkLst>
-        </pc:picChg>
-        <pc:picChg chg="add del mod">
-          <ac:chgData name="Read, Zoe" userId="b08cd0fd-26d2-470b-8ec0-c6e6cb2a79bd" providerId="ADAL" clId="{5AEB2719-95A5-4ED2-9E0E-ED462BB10526}" dt="2026-03-13T15:16:18.449" v="4968" actId="478"/>
-          <ac:picMkLst>
-            <pc:docMk/>
-            <pc:sldMk cId="2005456116" sldId="257"/>
-            <ac:picMk id="1075" creationId="{AAEC5A0E-A8A7-5F3D-FF7E-D5A1310DC25F}"/>
-          </ac:picMkLst>
-        </pc:picChg>
-        <pc:picChg chg="add del mod">
-          <ac:chgData name="Read, Zoe" userId="b08cd0fd-26d2-470b-8ec0-c6e6cb2a79bd" providerId="ADAL" clId="{5AEB2719-95A5-4ED2-9E0E-ED462BB10526}" dt="2026-03-13T15:16:58.206" v="4975" actId="478"/>
-          <ac:picMkLst>
-            <pc:docMk/>
-            <pc:sldMk cId="2005456116" sldId="257"/>
-            <ac:picMk id="1077" creationId="{FFBEF150-4996-ACCF-2FF8-42C26451A7FE}"/>
-          </ac:picMkLst>
-        </pc:picChg>
-        <pc:picChg chg="add del mod ord">
-          <ac:chgData name="Read, Zoe" userId="b08cd0fd-26d2-470b-8ec0-c6e6cb2a79bd" providerId="ADAL" clId="{5AEB2719-95A5-4ED2-9E0E-ED462BB10526}" dt="2026-03-13T15:20:09.550" v="4992" actId="478"/>
-          <ac:picMkLst>
-            <pc:docMk/>
-            <pc:sldMk cId="2005456116" sldId="257"/>
-            <ac:picMk id="1079" creationId="{E89868C9-5DDE-C444-4252-B8FA393EF2CE}"/>
-          </ac:picMkLst>
-        </pc:picChg>
-        <pc:picChg chg="add del mod ord">
-          <ac:chgData name="Read, Zoe" userId="b08cd0fd-26d2-470b-8ec0-c6e6cb2a79bd" providerId="ADAL" clId="{5AEB2719-95A5-4ED2-9E0E-ED462BB10526}" dt="2026-03-13T20:06:24.207" v="6421" actId="478"/>
-          <ac:picMkLst>
-            <pc:docMk/>
-            <pc:sldMk cId="2005456116" sldId="257"/>
-            <ac:picMk id="1081" creationId="{E751C4E4-E854-FE7E-1EF9-268DA1A23024}"/>
-          </ac:picMkLst>
-        </pc:picChg>
-        <pc:picChg chg="add del mod">
-          <ac:chgData name="Read, Zoe" userId="b08cd0fd-26d2-470b-8ec0-c6e6cb2a79bd" providerId="ADAL" clId="{5AEB2719-95A5-4ED2-9E0E-ED462BB10526}" dt="2026-03-13T15:22:37.877" v="5027" actId="478"/>
-          <ac:picMkLst>
-            <pc:docMk/>
-            <pc:sldMk cId="2005456116" sldId="257"/>
-            <ac:picMk id="1083" creationId="{79DA7F69-4E83-B1E5-DFEA-930123DA7F46}"/>
-          </ac:picMkLst>
-        </pc:picChg>
-        <pc:picChg chg="add mod">
-          <ac:chgData name="Read, Zoe" userId="b08cd0fd-26d2-470b-8ec0-c6e6cb2a79bd" providerId="ADAL" clId="{5AEB2719-95A5-4ED2-9E0E-ED462BB10526}" dt="2026-03-13T15:23:32.914" v="5041" actId="1076"/>
+          <ac:chgData name="Read, Zoe" userId="b08cd0fd-26d2-470b-8ec0-c6e6cb2a79bd" providerId="ADAL" clId="{5AEB2719-95A5-4ED2-9E0E-ED462BB10526}" dt="2026-03-16T11:34:01.951" v="6640" actId="478"/>
           <ac:picMkLst>
             <pc:docMk/>
             <pc:sldMk cId="2005456116" sldId="257"/>
             <ac:picMk id="1085" creationId="{9E2D53CD-2078-3011-EB8F-F1979C9B3B22}"/>
           </ac:picMkLst>
         </pc:picChg>
-        <pc:picChg chg="add del mod">
-          <ac:chgData name="Read, Zoe" userId="b08cd0fd-26d2-470b-8ec0-c6e6cb2a79bd" providerId="ADAL" clId="{5AEB2719-95A5-4ED2-9E0E-ED462BB10526}" dt="2026-03-13T15:27:09.698" v="5050" actId="478"/>
+        <pc:picChg chg="add mod">
+          <ac:chgData name="Read, Zoe" userId="b08cd0fd-26d2-470b-8ec0-c6e6cb2a79bd" providerId="ADAL" clId="{5AEB2719-95A5-4ED2-9E0E-ED462BB10526}" dt="2026-03-16T11:35:52.227" v="6654" actId="1076"/>
           <ac:picMkLst>
             <pc:docMk/>
             <pc:sldMk cId="2005456116" sldId="257"/>
-            <ac:picMk id="1088" creationId="{6780A67C-EA16-F57D-656A-1D4EE2D0B56B}"/>
-          </ac:picMkLst>
-        </pc:picChg>
-        <pc:picChg chg="add del mod">
-          <ac:chgData name="Read, Zoe" userId="b08cd0fd-26d2-470b-8ec0-c6e6cb2a79bd" providerId="ADAL" clId="{5AEB2719-95A5-4ED2-9E0E-ED462BB10526}" dt="2026-03-13T15:27:37.034" v="5056" actId="478"/>
-          <ac:picMkLst>
-            <pc:docMk/>
-            <pc:sldMk cId="2005456116" sldId="257"/>
-            <ac:picMk id="1090" creationId="{22F59BC5-2C35-DDF1-6E10-AC204BAEB7DC}"/>
-          </ac:picMkLst>
-        </pc:picChg>
-        <pc:picChg chg="add del mod">
-          <ac:chgData name="Read, Zoe" userId="b08cd0fd-26d2-470b-8ec0-c6e6cb2a79bd" providerId="ADAL" clId="{5AEB2719-95A5-4ED2-9E0E-ED462BB10526}" dt="2026-03-13T15:28:10.572" v="5061" actId="478"/>
-          <ac:picMkLst>
-            <pc:docMk/>
-            <pc:sldMk cId="2005456116" sldId="257"/>
-            <ac:picMk id="1092" creationId="{B289EE1B-058F-1CF1-4DE6-B6EEE7938A9B}"/>
-          </ac:picMkLst>
-        </pc:picChg>
-        <pc:picChg chg="add del mod">
-          <ac:chgData name="Read, Zoe" userId="b08cd0fd-26d2-470b-8ec0-c6e6cb2a79bd" providerId="ADAL" clId="{5AEB2719-95A5-4ED2-9E0E-ED462BB10526}" dt="2026-03-13T15:29:43.633" v="5069" actId="478"/>
-          <ac:picMkLst>
-            <pc:docMk/>
-            <pc:sldMk cId="2005456116" sldId="257"/>
-            <ac:picMk id="1094" creationId="{F50E4DC2-8AE0-9280-8B55-572851BC47EC}"/>
-          </ac:picMkLst>
-        </pc:picChg>
-        <pc:picChg chg="add del mod">
-          <ac:chgData name="Read, Zoe" userId="b08cd0fd-26d2-470b-8ec0-c6e6cb2a79bd" providerId="ADAL" clId="{5AEB2719-95A5-4ED2-9E0E-ED462BB10526}" dt="2026-03-13T15:30:15.570" v="5071" actId="478"/>
-          <ac:picMkLst>
-            <pc:docMk/>
-            <pc:sldMk cId="2005456116" sldId="257"/>
-            <ac:picMk id="1096" creationId="{19A9F59A-6905-0461-921F-53D44D6FE9B4}"/>
-          </ac:picMkLst>
-        </pc:picChg>
-        <pc:picChg chg="add del mod">
-          <ac:chgData name="Read, Zoe" userId="b08cd0fd-26d2-470b-8ec0-c6e6cb2a79bd" providerId="ADAL" clId="{5AEB2719-95A5-4ED2-9E0E-ED462BB10526}" dt="2026-03-13T15:31:42.114" v="5079" actId="478"/>
-          <ac:picMkLst>
-            <pc:docMk/>
-            <pc:sldMk cId="2005456116" sldId="257"/>
-            <ac:picMk id="1098" creationId="{371F0427-7C9D-A089-1550-355CC41A1B47}"/>
-          </ac:picMkLst>
-        </pc:picChg>
-        <pc:picChg chg="add del mod">
-          <ac:chgData name="Read, Zoe" userId="b08cd0fd-26d2-470b-8ec0-c6e6cb2a79bd" providerId="ADAL" clId="{5AEB2719-95A5-4ED2-9E0E-ED462BB10526}" dt="2026-03-13T15:54:01.795" v="5096" actId="478"/>
-          <ac:picMkLst>
-            <pc:docMk/>
-            <pc:sldMk cId="2005456116" sldId="257"/>
-            <ac:picMk id="1100" creationId="{A43F5C94-F21D-A325-C5D6-3A47C4C3B61F}"/>
-          </ac:picMkLst>
-        </pc:picChg>
-        <pc:picChg chg="add del mod">
-          <ac:chgData name="Read, Zoe" userId="b08cd0fd-26d2-470b-8ec0-c6e6cb2a79bd" providerId="ADAL" clId="{5AEB2719-95A5-4ED2-9E0E-ED462BB10526}" dt="2026-03-13T15:57:59.527" v="5369" actId="478"/>
-          <ac:picMkLst>
-            <pc:docMk/>
-            <pc:sldMk cId="2005456116" sldId="257"/>
-            <ac:picMk id="1102" creationId="{409410D1-8C61-C5F2-2ED0-8AE9EB772068}"/>
-          </ac:picMkLst>
-        </pc:picChg>
-        <pc:picChg chg="add del mod">
-          <ac:chgData name="Read, Zoe" userId="b08cd0fd-26d2-470b-8ec0-c6e6cb2a79bd" providerId="ADAL" clId="{5AEB2719-95A5-4ED2-9E0E-ED462BB10526}" dt="2026-03-13T18:28:42.166" v="5951" actId="478"/>
-          <ac:picMkLst>
-            <pc:docMk/>
-            <pc:sldMk cId="2005456116" sldId="257"/>
-            <ac:picMk id="1104" creationId="{BB487FD2-0D02-18A0-8E65-73832FF97000}"/>
-          </ac:picMkLst>
-        </pc:picChg>
-        <pc:picChg chg="add del mod">
-          <ac:chgData name="Read, Zoe" userId="b08cd0fd-26d2-470b-8ec0-c6e6cb2a79bd" providerId="ADAL" clId="{5AEB2719-95A5-4ED2-9E0E-ED462BB10526}" dt="2026-03-13T18:29:11.510" v="5953" actId="478"/>
-          <ac:picMkLst>
-            <pc:docMk/>
-            <pc:sldMk cId="2005456116" sldId="257"/>
-            <ac:picMk id="1108" creationId="{C1693025-7B3E-924A-5F00-7BE2F534CE94}"/>
-          </ac:picMkLst>
-        </pc:picChg>
-        <pc:picChg chg="add del mod ord">
-          <ac:chgData name="Read, Zoe" userId="b08cd0fd-26d2-470b-8ec0-c6e6cb2a79bd" providerId="ADAL" clId="{5AEB2719-95A5-4ED2-9E0E-ED462BB10526}" dt="2026-03-13T18:44:39.141" v="6006" actId="478"/>
-          <ac:picMkLst>
-            <pc:docMk/>
-            <pc:sldMk cId="2005456116" sldId="257"/>
-            <ac:picMk id="1110" creationId="{B4368826-C15A-60ED-182C-BDDCB7AE0450}"/>
-          </ac:picMkLst>
-        </pc:picChg>
-        <pc:picChg chg="add del mod">
-          <ac:chgData name="Read, Zoe" userId="b08cd0fd-26d2-470b-8ec0-c6e6cb2a79bd" providerId="ADAL" clId="{5AEB2719-95A5-4ED2-9E0E-ED462BB10526}" dt="2026-03-13T18:30:19.459" v="5961" actId="478"/>
-          <ac:picMkLst>
-            <pc:docMk/>
-            <pc:sldMk cId="2005456116" sldId="257"/>
-            <ac:picMk id="1112" creationId="{1D61C42D-3DE8-6030-77E4-BEF2648FC623}"/>
-          </ac:picMkLst>
-        </pc:picChg>
-        <pc:picChg chg="add del mod">
-          <ac:chgData name="Read, Zoe" userId="b08cd0fd-26d2-470b-8ec0-c6e6cb2a79bd" providerId="ADAL" clId="{5AEB2719-95A5-4ED2-9E0E-ED462BB10526}" dt="2026-03-13T18:31:22.981" v="5964" actId="478"/>
-          <ac:picMkLst>
-            <pc:docMk/>
-            <pc:sldMk cId="2005456116" sldId="257"/>
-            <ac:picMk id="1114" creationId="{EFC001B8-BD61-1505-17D5-BA752A5B2FBC}"/>
-          </ac:picMkLst>
-        </pc:picChg>
-        <pc:picChg chg="add del mod">
-          <ac:chgData name="Read, Zoe" userId="b08cd0fd-26d2-470b-8ec0-c6e6cb2a79bd" providerId="ADAL" clId="{5AEB2719-95A5-4ED2-9E0E-ED462BB10526}" dt="2026-03-13T18:31:58.499" v="5967" actId="478"/>
-          <ac:picMkLst>
-            <pc:docMk/>
-            <pc:sldMk cId="2005456116" sldId="257"/>
-            <ac:picMk id="1116" creationId="{65AF378F-5CD2-D33D-63DD-3174D0B4ABE3}"/>
-          </ac:picMkLst>
-        </pc:picChg>
-        <pc:picChg chg="add del mod">
-          <ac:chgData name="Read, Zoe" userId="b08cd0fd-26d2-470b-8ec0-c6e6cb2a79bd" providerId="ADAL" clId="{5AEB2719-95A5-4ED2-9E0E-ED462BB10526}" dt="2026-03-13T18:32:48.323" v="5972" actId="478"/>
-          <ac:picMkLst>
-            <pc:docMk/>
-            <pc:sldMk cId="2005456116" sldId="257"/>
-            <ac:picMk id="1118" creationId="{FD3EE651-DB72-0E6C-A520-B8763C8AD8B2}"/>
-          </ac:picMkLst>
-        </pc:picChg>
-        <pc:picChg chg="add del mod modCrop">
-          <ac:chgData name="Read, Zoe" userId="b08cd0fd-26d2-470b-8ec0-c6e6cb2a79bd" providerId="ADAL" clId="{5AEB2719-95A5-4ED2-9E0E-ED462BB10526}" dt="2026-03-13T18:44:27.949" v="6001" actId="478"/>
-          <ac:picMkLst>
-            <pc:docMk/>
-            <pc:sldMk cId="2005456116" sldId="257"/>
-            <ac:picMk id="1119" creationId="{6B0255B7-3633-4468-0D88-5578BD3FA01B}"/>
-          </ac:picMkLst>
-        </pc:picChg>
-        <pc:picChg chg="add del mod">
-          <ac:chgData name="Read, Zoe" userId="b08cd0fd-26d2-470b-8ec0-c6e6cb2a79bd" providerId="ADAL" clId="{5AEB2719-95A5-4ED2-9E0E-ED462BB10526}" dt="2026-03-13T18:47:33.690" v="6018" actId="478"/>
-          <ac:picMkLst>
-            <pc:docMk/>
-            <pc:sldMk cId="2005456116" sldId="257"/>
-            <ac:picMk id="1123" creationId="{CE88C600-3733-61AF-6D89-0D2360023238}"/>
-          </ac:picMkLst>
-        </pc:picChg>
-        <pc:picChg chg="add del mod">
-          <ac:chgData name="Read, Zoe" userId="b08cd0fd-26d2-470b-8ec0-c6e6cb2a79bd" providerId="ADAL" clId="{5AEB2719-95A5-4ED2-9E0E-ED462BB10526}" dt="2026-03-13T18:47:31.828" v="6017" actId="478"/>
-          <ac:picMkLst>
-            <pc:docMk/>
-            <pc:sldMk cId="2005456116" sldId="257"/>
-            <ac:picMk id="1125" creationId="{0FCE25EE-4310-CAAC-66A8-C2FEE8321D3F}"/>
-          </ac:picMkLst>
-        </pc:picChg>
-        <pc:picChg chg="add del mod">
-          <ac:chgData name="Read, Zoe" userId="b08cd0fd-26d2-470b-8ec0-c6e6cb2a79bd" providerId="ADAL" clId="{5AEB2719-95A5-4ED2-9E0E-ED462BB10526}" dt="2026-03-13T18:50:50.707" v="6029" actId="478"/>
-          <ac:picMkLst>
-            <pc:docMk/>
-            <pc:sldMk cId="2005456116" sldId="257"/>
-            <ac:picMk id="1127" creationId="{A6BAE1D5-13FF-E627-6DEA-53877405D740}"/>
-          </ac:picMkLst>
-        </pc:picChg>
-        <pc:picChg chg="add del mod">
-          <ac:chgData name="Read, Zoe" userId="b08cd0fd-26d2-470b-8ec0-c6e6cb2a79bd" providerId="ADAL" clId="{5AEB2719-95A5-4ED2-9E0E-ED462BB10526}" dt="2026-03-13T18:50:42.061" v="6025" actId="478"/>
-          <ac:picMkLst>
-            <pc:docMk/>
-            <pc:sldMk cId="2005456116" sldId="257"/>
-            <ac:picMk id="1129" creationId="{8ED4C85E-9940-B3B4-D13C-C579770212D7}"/>
-          </ac:picMkLst>
-        </pc:picChg>
-        <pc:picChg chg="add del mod">
-          <ac:chgData name="Read, Zoe" userId="b08cd0fd-26d2-470b-8ec0-c6e6cb2a79bd" providerId="ADAL" clId="{5AEB2719-95A5-4ED2-9E0E-ED462BB10526}" dt="2026-03-13T18:51:33.492" v="6033" actId="478"/>
-          <ac:picMkLst>
-            <pc:docMk/>
-            <pc:sldMk cId="2005456116" sldId="257"/>
-            <ac:picMk id="1131" creationId="{AD16F9B4-9CB9-F089-774F-0B07610A46B6}"/>
-          </ac:picMkLst>
-        </pc:picChg>
-        <pc:picChg chg="add del mod">
-          <ac:chgData name="Read, Zoe" userId="b08cd0fd-26d2-470b-8ec0-c6e6cb2a79bd" providerId="ADAL" clId="{5AEB2719-95A5-4ED2-9E0E-ED462BB10526}" dt="2026-03-13T18:54:09.040" v="6041" actId="478"/>
-          <ac:picMkLst>
-            <pc:docMk/>
-            <pc:sldMk cId="2005456116" sldId="257"/>
-            <ac:picMk id="1133" creationId="{B3130CC2-25A3-ED65-64F7-35DA082315FF}"/>
-          </ac:picMkLst>
-        </pc:picChg>
-        <pc:picChg chg="add del mod ord">
-          <ac:chgData name="Read, Zoe" userId="b08cd0fd-26d2-470b-8ec0-c6e6cb2a79bd" providerId="ADAL" clId="{5AEB2719-95A5-4ED2-9E0E-ED462BB10526}" dt="2026-03-13T19:59:07.956" v="6396" actId="478"/>
-          <ac:picMkLst>
-            <pc:docMk/>
-            <pc:sldMk cId="2005456116" sldId="257"/>
-            <ac:picMk id="1135" creationId="{3E27048A-DB49-B226-206B-F20819C4D439}"/>
-          </ac:picMkLst>
-        </pc:picChg>
-        <pc:picChg chg="add del mod">
-          <ac:chgData name="Read, Zoe" userId="b08cd0fd-26d2-470b-8ec0-c6e6cb2a79bd" providerId="ADAL" clId="{5AEB2719-95A5-4ED2-9E0E-ED462BB10526}" dt="2026-03-13T19:02:38.664" v="6049" actId="478"/>
-          <ac:picMkLst>
-            <pc:docMk/>
-            <pc:sldMk cId="2005456116" sldId="257"/>
-            <ac:picMk id="1137" creationId="{7DD4138F-3BA3-84BC-A0E4-C1F9CB95CCF7}"/>
-          </ac:picMkLst>
-        </pc:picChg>
-        <pc:picChg chg="add del mod">
-          <ac:chgData name="Read, Zoe" userId="b08cd0fd-26d2-470b-8ec0-c6e6cb2a79bd" providerId="ADAL" clId="{5AEB2719-95A5-4ED2-9E0E-ED462BB10526}" dt="2026-03-13T19:08:54.435" v="6056" actId="478"/>
-          <ac:picMkLst>
-            <pc:docMk/>
-            <pc:sldMk cId="2005456116" sldId="257"/>
-            <ac:picMk id="1139" creationId="{57D43B10-EF66-AE54-8719-FCB4C9F2A313}"/>
-          </ac:picMkLst>
-        </pc:picChg>
-        <pc:picChg chg="add del mod">
-          <ac:chgData name="Read, Zoe" userId="b08cd0fd-26d2-470b-8ec0-c6e6cb2a79bd" providerId="ADAL" clId="{5AEB2719-95A5-4ED2-9E0E-ED462BB10526}" dt="2026-03-13T19:18:55.396" v="6058" actId="478"/>
-          <ac:picMkLst>
-            <pc:docMk/>
-            <pc:sldMk cId="2005456116" sldId="257"/>
-            <ac:picMk id="1141" creationId="{9DDFB753-78A2-CB94-8E7A-789D9194846D}"/>
-          </ac:picMkLst>
-        </pc:picChg>
-        <pc:picChg chg="add del mod">
-          <ac:chgData name="Read, Zoe" userId="b08cd0fd-26d2-470b-8ec0-c6e6cb2a79bd" providerId="ADAL" clId="{5AEB2719-95A5-4ED2-9E0E-ED462BB10526}" dt="2026-03-13T19:19:13.900" v="6063" actId="478"/>
-          <ac:picMkLst>
-            <pc:docMk/>
-            <pc:sldMk cId="2005456116" sldId="257"/>
-            <ac:picMk id="1143" creationId="{741B156B-9832-91C1-0098-489BAF823450}"/>
-          </ac:picMkLst>
-        </pc:picChg>
-        <pc:picChg chg="add del mod">
-          <ac:chgData name="Read, Zoe" userId="b08cd0fd-26d2-470b-8ec0-c6e6cb2a79bd" providerId="ADAL" clId="{5AEB2719-95A5-4ED2-9E0E-ED462BB10526}" dt="2026-03-13T19:19:53.661" v="6068" actId="478"/>
-          <ac:picMkLst>
-            <pc:docMk/>
-            <pc:sldMk cId="2005456116" sldId="257"/>
-            <ac:picMk id="1145" creationId="{7CCB61CC-B337-A6CA-94D4-6F5ECFDB3A51}"/>
-          </ac:picMkLst>
-        </pc:picChg>
-        <pc:picChg chg="add del mod">
-          <ac:chgData name="Read, Zoe" userId="b08cd0fd-26d2-470b-8ec0-c6e6cb2a79bd" providerId="ADAL" clId="{5AEB2719-95A5-4ED2-9E0E-ED462BB10526}" dt="2026-03-13T19:20:41.748" v="6073" actId="478"/>
-          <ac:picMkLst>
-            <pc:docMk/>
-            <pc:sldMk cId="2005456116" sldId="257"/>
-            <ac:picMk id="1147" creationId="{7BE27AB1-F5AB-A571-45D7-F25FA0E5EE9E}"/>
-          </ac:picMkLst>
-        </pc:picChg>
-        <pc:picChg chg="add del mod">
-          <ac:chgData name="Read, Zoe" userId="b08cd0fd-26d2-470b-8ec0-c6e6cb2a79bd" providerId="ADAL" clId="{5AEB2719-95A5-4ED2-9E0E-ED462BB10526}" dt="2026-03-13T19:21:46.771" v="6081" actId="478"/>
-          <ac:picMkLst>
-            <pc:docMk/>
-            <pc:sldMk cId="2005456116" sldId="257"/>
-            <ac:picMk id="1149" creationId="{298943F4-4EB4-071A-5FBC-D17B04303C2C}"/>
+            <ac:picMk id="1120" creationId="{B0C5102B-10F2-E0CF-866D-ECB35E6B9A2F}"/>
           </ac:picMkLst>
         </pc:picChg>
         <pc:picChg chg="add mod ord">
-          <ac:chgData name="Read, Zoe" userId="b08cd0fd-26d2-470b-8ec0-c6e6cb2a79bd" providerId="ADAL" clId="{5AEB2719-95A5-4ED2-9E0E-ED462BB10526}" dt="2026-03-13T20:07:33.645" v="6439" actId="1038"/>
+          <ac:chgData name="Read, Zoe" userId="b08cd0fd-26d2-470b-8ec0-c6e6cb2a79bd" providerId="ADAL" clId="{5AEB2719-95A5-4ED2-9E0E-ED462BB10526}" dt="2026-03-16T11:34:52.611" v="6643" actId="1076"/>
           <ac:picMkLst>
             <pc:docMk/>
             <pc:sldMk cId="2005456116" sldId="257"/>
             <ac:picMk id="1151" creationId="{9270BAB1-911D-6871-CCA4-EC0A16BAE319}"/>
-          </ac:picMkLst>
-        </pc:picChg>
-        <pc:picChg chg="add del mod">
-          <ac:chgData name="Read, Zoe" userId="b08cd0fd-26d2-470b-8ec0-c6e6cb2a79bd" providerId="ADAL" clId="{5AEB2719-95A5-4ED2-9E0E-ED462BB10526}" dt="2026-03-13T19:59:50.117" v="6403" actId="478"/>
-          <ac:picMkLst>
-            <pc:docMk/>
-            <pc:sldMk cId="2005456116" sldId="257"/>
-            <ac:picMk id="1172" creationId="{39EE0B8F-02B0-BFBB-E24F-71F6667F34A8}"/>
-          </ac:picMkLst>
-        </pc:picChg>
-        <pc:picChg chg="add del mod">
-          <ac:chgData name="Read, Zoe" userId="b08cd0fd-26d2-470b-8ec0-c6e6cb2a79bd" providerId="ADAL" clId="{5AEB2719-95A5-4ED2-9E0E-ED462BB10526}" dt="2026-03-13T20:06:59.447" v="6429" actId="478"/>
-          <ac:picMkLst>
-            <pc:docMk/>
-            <pc:sldMk cId="2005456116" sldId="257"/>
-            <ac:picMk id="1174" creationId="{75BF8206-810D-06F7-F805-252C6EE25DD9}"/>
           </ac:picMkLst>
         </pc:picChg>
         <pc:cxnChg chg="add mod ord">
@@ -884,7 +421,7 @@
           </ac:cxnSpMkLst>
         </pc:cxnChg>
         <pc:cxnChg chg="add mod ord">
-          <ac:chgData name="Read, Zoe" userId="b08cd0fd-26d2-470b-8ec0-c6e6cb2a79bd" providerId="ADAL" clId="{5AEB2719-95A5-4ED2-9E0E-ED462BB10526}" dt="2026-03-13T20:01:30.523" v="6420" actId="1036"/>
+          <ac:chgData name="Read, Zoe" userId="b08cd0fd-26d2-470b-8ec0-c6e6cb2a79bd" providerId="ADAL" clId="{5AEB2719-95A5-4ED2-9E0E-ED462BB10526}" dt="2026-03-16T11:34:59.565" v="6645" actId="1035"/>
           <ac:cxnSpMkLst>
             <pc:docMk/>
             <pc:sldMk cId="2005456116" sldId="257"/>
@@ -892,7 +429,7 @@
           </ac:cxnSpMkLst>
         </pc:cxnChg>
         <pc:cxnChg chg="mod">
-          <ac:chgData name="Read, Zoe" userId="b08cd0fd-26d2-470b-8ec0-c6e6cb2a79bd" providerId="ADAL" clId="{5AEB2719-95A5-4ED2-9E0E-ED462BB10526}" dt="2026-03-13T19:37:13.255" v="6381" actId="1076"/>
+          <ac:chgData name="Read, Zoe" userId="b08cd0fd-26d2-470b-8ec0-c6e6cb2a79bd" providerId="ADAL" clId="{5AEB2719-95A5-4ED2-9E0E-ED462BB10526}" dt="2026-03-16T11:36:02.334" v="6657" actId="1035"/>
           <ac:cxnSpMkLst>
             <pc:docMk/>
             <pc:sldMk cId="2005456116" sldId="257"/>
@@ -900,7 +437,7 @@
           </ac:cxnSpMkLst>
         </pc:cxnChg>
         <pc:cxnChg chg="mod">
-          <ac:chgData name="Read, Zoe" userId="b08cd0fd-26d2-470b-8ec0-c6e6cb2a79bd" providerId="ADAL" clId="{5AEB2719-95A5-4ED2-9E0E-ED462BB10526}" dt="2026-03-13T15:03:37.399" v="4902" actId="1036"/>
+          <ac:chgData name="Read, Zoe" userId="b08cd0fd-26d2-470b-8ec0-c6e6cb2a79bd" providerId="ADAL" clId="{5AEB2719-95A5-4ED2-9E0E-ED462BB10526}" dt="2026-03-16T11:32:05.348" v="6629" actId="14100"/>
           <ac:cxnSpMkLst>
             <pc:docMk/>
             <pc:sldMk cId="2005456116" sldId="257"/>
@@ -913,94 +450,6 @@
             <pc:docMk/>
             <pc:sldMk cId="2005456116" sldId="257"/>
             <ac:cxnSpMk id="1044" creationId="{8463A8F4-CE87-F09A-8258-6D6979B36D80}"/>
-          </ac:cxnSpMkLst>
-        </pc:cxnChg>
-        <pc:cxnChg chg="add del mod ord">
-          <ac:chgData name="Read, Zoe" userId="b08cd0fd-26d2-470b-8ec0-c6e6cb2a79bd" providerId="ADAL" clId="{5AEB2719-95A5-4ED2-9E0E-ED462BB10526}" dt="2026-03-13T14:43:58.200" v="4435" actId="478"/>
-          <ac:cxnSpMkLst>
-            <pc:docMk/>
-            <pc:sldMk cId="2005456116" sldId="257"/>
-            <ac:cxnSpMk id="1045" creationId="{BB33F361-7DB9-04C2-C03A-778C0DF80E8F}"/>
-          </ac:cxnSpMkLst>
-        </pc:cxnChg>
-        <pc:cxnChg chg="add del mod">
-          <ac:chgData name="Read, Zoe" userId="b08cd0fd-26d2-470b-8ec0-c6e6cb2a79bd" providerId="ADAL" clId="{5AEB2719-95A5-4ED2-9E0E-ED462BB10526}" dt="2026-03-13T14:43:58.200" v="4435" actId="478"/>
-          <ac:cxnSpMkLst>
-            <pc:docMk/>
-            <pc:sldMk cId="2005456116" sldId="257"/>
-            <ac:cxnSpMk id="1047" creationId="{375CA06C-A251-4ED8-A38F-281C7D414E0B}"/>
-          </ac:cxnSpMkLst>
-        </pc:cxnChg>
-        <pc:cxnChg chg="add del mod ord">
-          <ac:chgData name="Read, Zoe" userId="b08cd0fd-26d2-470b-8ec0-c6e6cb2a79bd" providerId="ADAL" clId="{5AEB2719-95A5-4ED2-9E0E-ED462BB10526}" dt="2026-03-13T14:43:58.200" v="4435" actId="478"/>
-          <ac:cxnSpMkLst>
-            <pc:docMk/>
-            <pc:sldMk cId="2005456116" sldId="257"/>
-            <ac:cxnSpMk id="1050" creationId="{D3DAFDEE-D9E5-1D68-8EB9-E51F04AB1645}"/>
-          </ac:cxnSpMkLst>
-        </pc:cxnChg>
-        <pc:cxnChg chg="add del mod ord">
-          <ac:chgData name="Read, Zoe" userId="b08cd0fd-26d2-470b-8ec0-c6e6cb2a79bd" providerId="ADAL" clId="{5AEB2719-95A5-4ED2-9E0E-ED462BB10526}" dt="2026-03-13T14:43:58.200" v="4435" actId="478"/>
-          <ac:cxnSpMkLst>
-            <pc:docMk/>
-            <pc:sldMk cId="2005456116" sldId="257"/>
-            <ac:cxnSpMk id="1051" creationId="{F2AFA6AA-F2FA-7B6D-89B6-C18FBAE3FB74}"/>
-          </ac:cxnSpMkLst>
-        </pc:cxnChg>
-        <pc:cxnChg chg="add del mod ord">
-          <ac:chgData name="Read, Zoe" userId="b08cd0fd-26d2-470b-8ec0-c6e6cb2a79bd" providerId="ADAL" clId="{5AEB2719-95A5-4ED2-9E0E-ED462BB10526}" dt="2026-03-13T14:43:58.200" v="4435" actId="478"/>
-          <ac:cxnSpMkLst>
-            <pc:docMk/>
-            <pc:sldMk cId="2005456116" sldId="257"/>
-            <ac:cxnSpMk id="1052" creationId="{9F2A7656-0EEE-7013-0DB8-ADC5FDA2A8B2}"/>
-          </ac:cxnSpMkLst>
-        </pc:cxnChg>
-        <pc:cxnChg chg="add del mod ord">
-          <ac:chgData name="Read, Zoe" userId="b08cd0fd-26d2-470b-8ec0-c6e6cb2a79bd" providerId="ADAL" clId="{5AEB2719-95A5-4ED2-9E0E-ED462BB10526}" dt="2026-03-13T14:43:58.200" v="4435" actId="478"/>
-          <ac:cxnSpMkLst>
-            <pc:docMk/>
-            <pc:sldMk cId="2005456116" sldId="257"/>
-            <ac:cxnSpMk id="1053" creationId="{45B61E4A-833A-BA3F-9B21-F25237F7E669}"/>
-          </ac:cxnSpMkLst>
-        </pc:cxnChg>
-        <pc:cxnChg chg="add mod ord">
-          <ac:chgData name="Read, Zoe" userId="b08cd0fd-26d2-470b-8ec0-c6e6cb2a79bd" providerId="ADAL" clId="{5AEB2719-95A5-4ED2-9E0E-ED462BB10526}" dt="2026-03-12T20:12:17.256" v="3359" actId="167"/>
-          <ac:cxnSpMkLst>
-            <pc:docMk/>
-            <pc:sldMk cId="2005456116" sldId="257"/>
-            <ac:cxnSpMk id="1054" creationId="{B4545213-9D78-5A7D-F0ED-7247C7E86F0A}"/>
-          </ac:cxnSpMkLst>
-        </pc:cxnChg>
-        <pc:cxnChg chg="add del mod ord">
-          <ac:chgData name="Read, Zoe" userId="b08cd0fd-26d2-470b-8ec0-c6e6cb2a79bd" providerId="ADAL" clId="{5AEB2719-95A5-4ED2-9E0E-ED462BB10526}" dt="2026-03-13T14:43:58.200" v="4435" actId="478"/>
-          <ac:cxnSpMkLst>
-            <pc:docMk/>
-            <pc:sldMk cId="2005456116" sldId="257"/>
-            <ac:cxnSpMk id="1055" creationId="{EAF13472-2A54-A942-9989-189633D8FC45}"/>
-          </ac:cxnSpMkLst>
-        </pc:cxnChg>
-        <pc:cxnChg chg="add del mod">
-          <ac:chgData name="Read, Zoe" userId="b08cd0fd-26d2-470b-8ec0-c6e6cb2a79bd" providerId="ADAL" clId="{5AEB2719-95A5-4ED2-9E0E-ED462BB10526}" dt="2026-03-13T14:43:58.200" v="4435" actId="478"/>
-          <ac:cxnSpMkLst>
-            <pc:docMk/>
-            <pc:sldMk cId="2005456116" sldId="257"/>
-            <ac:cxnSpMk id="1056" creationId="{97023478-EBF1-C0B2-4640-43B6062C44A4}"/>
-          </ac:cxnSpMkLst>
-        </pc:cxnChg>
-        <pc:cxnChg chg="add del mod">
-          <ac:chgData name="Read, Zoe" userId="b08cd0fd-26d2-470b-8ec0-c6e6cb2a79bd" providerId="ADAL" clId="{5AEB2719-95A5-4ED2-9E0E-ED462BB10526}" dt="2026-03-13T14:43:58.200" v="4435" actId="478"/>
-          <ac:cxnSpMkLst>
-            <pc:docMk/>
-            <pc:sldMk cId="2005456116" sldId="257"/>
-            <ac:cxnSpMk id="1057" creationId="{EABAA8CD-3573-D737-5C52-07AF46DD77DB}"/>
-          </ac:cxnSpMkLst>
-        </pc:cxnChg>
-        <pc:cxnChg chg="add del mod">
-          <ac:chgData name="Read, Zoe" userId="b08cd0fd-26d2-470b-8ec0-c6e6cb2a79bd" providerId="ADAL" clId="{5AEB2719-95A5-4ED2-9E0E-ED462BB10526}" dt="2026-03-13T14:43:58.200" v="4435" actId="478"/>
-          <ac:cxnSpMkLst>
-            <pc:docMk/>
-            <pc:sldMk cId="2005456116" sldId="257"/>
-            <ac:cxnSpMk id="1058" creationId="{60C150C5-AE9C-3C24-36BA-5DE7D6481E18}"/>
           </ac:cxnSpMkLst>
         </pc:cxnChg>
         <pc:cxnChg chg="add mod">
@@ -1060,7 +509,7 @@
           </ac:cxnSpMkLst>
         </pc:cxnChg>
         <pc:cxnChg chg="add mod">
-          <ac:chgData name="Read, Zoe" userId="b08cd0fd-26d2-470b-8ec0-c6e6cb2a79bd" providerId="ADAL" clId="{5AEB2719-95A5-4ED2-9E0E-ED462BB10526}" dt="2026-03-13T20:07:33.645" v="6439" actId="1038"/>
+          <ac:chgData name="Read, Zoe" userId="b08cd0fd-26d2-470b-8ec0-c6e6cb2a79bd" providerId="ADAL" clId="{5AEB2719-95A5-4ED2-9E0E-ED462BB10526}" dt="2026-03-16T11:24:24.947" v="6504" actId="1076"/>
           <ac:cxnSpMkLst>
             <pc:docMk/>
             <pc:sldMk cId="2005456116" sldId="257"/>
@@ -1091,6 +540,26 @@
             <ac:cxnSpMk id="1169" creationId="{BC6DBC99-57E5-A3C2-FA3D-D7BF95FDBC1C}"/>
           </ac:cxnSpMkLst>
         </pc:cxnChg>
+        <pc:extLst>
+          <p:ext xmlns:p="http://schemas.openxmlformats.org/presentationml/2006/main" uri="{D6D511B9-2390-475A-947B-AFAB55BFBCF1}">
+            <pc226:cmChg xmlns:pc226="http://schemas.microsoft.com/office/powerpoint/2022/06/main/command" chg="mod">
+              <pc226:chgData name="Read, Zoe" userId="b08cd0fd-26d2-470b-8ec0-c6e6cb2a79bd" providerId="ADAL" clId="{5AEB2719-95A5-4ED2-9E0E-ED462BB10526}" dt="2026-03-16T11:31:50.114" v="6626" actId="20577"/>
+              <pc2:cmMkLst xmlns:pc2="http://schemas.microsoft.com/office/powerpoint/2019/9/main/command">
+                <pc:docMk/>
+                <pc:sldMk cId="2005456116" sldId="257"/>
+                <pc2:cmMk id="{C2D71113-D824-4EA1-8346-E7FF9B9C44E2}"/>
+              </pc2:cmMkLst>
+            </pc226:cmChg>
+            <pc226:cmChg xmlns:pc226="http://schemas.microsoft.com/office/powerpoint/2022/06/main/command" chg="mod">
+              <pc226:chgData name="Read, Zoe" userId="b08cd0fd-26d2-470b-8ec0-c6e6cb2a79bd" providerId="ADAL" clId="{5AEB2719-95A5-4ED2-9E0E-ED462BB10526}" dt="2026-03-16T11:24:14.970" v="6501" actId="20577"/>
+              <pc2:cmMkLst xmlns:pc2="http://schemas.microsoft.com/office/powerpoint/2019/9/main/command">
+                <pc:docMk/>
+                <pc:sldMk cId="2005456116" sldId="257"/>
+                <pc2:cmMk id="{597E5C60-A8AD-485E-8A84-796A7E2CF6A3}"/>
+              </pc2:cmMkLst>
+            </pc226:cmChg>
+          </p:ext>
+        </pc:extLst>
       </pc:sldChg>
       <pc:sldChg chg="add del">
         <pc:chgData name="Read, Zoe" userId="b08cd0fd-26d2-470b-8ec0-c6e6cb2a79bd" providerId="ADAL" clId="{5AEB2719-95A5-4ED2-9E0E-ED462BB10526}" dt="2026-03-12T20:18:17.564" v="3533"/>
@@ -1130,36 +599,23 @@
 
 <file path=ppt/comments/modernComment_101_7788D4F4.xml><?xml version="1.0" encoding="utf-8"?>
 <p188:cmLst xmlns:a="http://schemas.openxmlformats.org/drawingml/2006/main" xmlns:r="http://schemas.openxmlformats.org/officeDocument/2006/relationships" xmlns:p188="http://schemas.microsoft.com/office/powerpoint/2018/8/main">
-  <p188:cm id="{B8A07343-8EBD-4063-9515-C0EDE7CA19F0}" authorId="{50137B73-C207-1407-898B-797CE70D2312}" created="2026-03-13T14:20:44.092">
-    <ac:deMkLst xmlns:ac="http://schemas.microsoft.com/office/drawing/2013/main/command">
+  <p188:cm id="{597E5C60-A8AD-485E-8A84-796A7E2CF6A3}" authorId="{231D7B86-FC17-2341-A59E-74856DBD8393}" status="resolved" created="2026-03-13T21:58:16.626" complete="100000">
+    <ac:txMkLst xmlns:ac="http://schemas.microsoft.com/office/drawing/2013/main/command">
       <pc:docMk xmlns:pc="http://schemas.microsoft.com/office/powerpoint/2013/main/command"/>
       <pc:sldMk xmlns:pc="http://schemas.microsoft.com/office/powerpoint/2013/main/command" cId="2005456116" sldId="257"/>
-      <ac:picMk id="9" creationId="{09EDF015-AC84-7DA3-BD5A-225267C491D7}"/>
-    </ac:deMkLst>
+      <ac:spMk id="1046" creationId="{3D22E29A-542C-2707-EE87-D32E923FD26A}"/>
+      <ac:txMk cp="339" len="10">
+        <ac:context len="445" hash="2235153434"/>
+      </ac:txMk>
+    </ac:txMkLst>
+    <p188:pos x="13446686" y="1916171"/>
     <p188:txBody>
       <a:bodyPr/>
       <a:lstStyle/>
       <a:p>
         <a:r>
           <a:rPr lang="en-US"/>
-          <a:t>Print the anova table into a csv for Steph to look at</a:t>
-        </a:r>
-      </a:p>
-    </p188:txBody>
-  </p188:cm>
-  <p188:cm id="{F7D370C0-1A77-42D9-8499-1F9C74E5F229}" authorId="{50137B73-C207-1407-898B-797CE70D2312}" created="2026-03-13T16:00:05.398">
-    <ac:deMkLst xmlns:ac="http://schemas.microsoft.com/office/drawing/2013/main/command">
-      <pc:docMk xmlns:pc="http://schemas.microsoft.com/office/powerpoint/2013/main/command"/>
-      <pc:sldMk xmlns:pc="http://schemas.microsoft.com/office/powerpoint/2013/main/command" cId="2005456116" sldId="257"/>
-      <ac:picMk id="1104" creationId="{BB487FD2-0D02-18A0-8E65-73832FF97000}"/>
-    </ac:deMkLst>
-    <p188:txBody>
-      <a:bodyPr/>
-      <a:lstStyle/>
-      <a:p>
-        <a:r>
-          <a:rPr lang="en-US"/>
-          <a:t>I should try to add the values and units to the x-axes of these graphs</a:t>
+          <a:t>Not necessary for now, but we might plot this same graph of the 0cm  /SW samples and see if they follow the same pattern - it might be that the surface water salinity drives the sulfate concentrations? </a:t>
         </a:r>
       </a:p>
     </p188:txBody>
@@ -1249,7 +705,7 @@
           <a:p>
             <a:fld id="{0407BD97-90D8-3541-9414-B17D17D02539}" type="datetimeFigureOut">
               <a:rPr lang="en-US" smtClean="0"/>
-              <a:t>3/13/2026</a:t>
+              <a:t>3/16/2026</a:t>
             </a:fld>
             <a:endParaRPr lang="en-US"/>
           </a:p>
@@ -2817,10 +2273,10 @@
       </p:grpSpPr>
       <p:pic>
         <p:nvPicPr>
-          <p:cNvPr id="6" name="Picture 5" descr="A chart of different colored boxes&#10;&#10;AI-generated content may be incorrect.">
+          <p:cNvPr id="11" name="Picture 10" descr="A chart of different colored boxes&#10;&#10;AI-generated content may be incorrect.">
             <a:extLst>
               <a:ext uri="{FF2B5EF4-FFF2-40B4-BE49-F238E27FC236}">
-                <a16:creationId xmlns:a16="http://schemas.microsoft.com/office/drawing/2014/main" id="{65D6C5CC-18B1-CDA4-E731-06FAAFE46261}"/>
+                <a16:creationId xmlns:a16="http://schemas.microsoft.com/office/drawing/2014/main" id="{DA28F95C-2111-E10A-4CC1-C069E3C51045}"/>
               </a:ext>
             </a:extLst>
           </p:cNvPr>
@@ -2843,7 +2299,7 @@
         </p:blipFill>
         <p:spPr>
           <a:xfrm>
-            <a:off x="501300" y="18455481"/>
+            <a:off x="674775" y="18453596"/>
             <a:ext cx="16459233" cy="6400813"/>
           </a:xfrm>
           <a:prstGeom prst="rect">
@@ -2879,7 +2335,7 @@
         </p:blipFill>
         <p:spPr>
           <a:xfrm>
-            <a:off x="17525966" y="19484222"/>
+            <a:off x="17579959" y="19446061"/>
             <a:ext cx="16916434" cy="10058420"/>
           </a:xfrm>
           <a:prstGeom prst="rect">
@@ -2903,7 +2359,7 @@
         </p:nvCxnSpPr>
         <p:spPr>
           <a:xfrm>
-            <a:off x="18166504" y="29504481"/>
+            <a:off x="18166504" y="29352081"/>
             <a:ext cx="15770805" cy="0"/>
           </a:xfrm>
           <a:prstGeom prst="line">
@@ -3015,7 +2471,7 @@
             </a:r>
             <a:r>
               <a:rPr lang="en-US" sz="3600" dirty="0"/>
-              <a:t>Pacific Northwest National Laboratory</a:t>
+              <a:t>Joint Global Change Research Institute, PNNL, Maryland, USA</a:t>
             </a:r>
           </a:p>
         </p:txBody>
@@ -3221,21 +2677,7 @@
                 <a:latin typeface="Arial" panose="020B0604020202020204" pitchFamily="34" charset="0"/>
                 <a:cs typeface="Arial" panose="020B0604020202020204" pitchFamily="34" charset="0"/>
               </a:rPr>
-              <a:t>that are oligohaline, mesohaline, and </a:t>
-            </a:r>
-            <a:r>
-              <a:rPr lang="en-US" sz="2800" dirty="0" err="1">
-                <a:latin typeface="Arial" panose="020B0604020202020204" pitchFamily="34" charset="0"/>
-                <a:cs typeface="Arial" panose="020B0604020202020204" pitchFamily="34" charset="0"/>
-              </a:rPr>
-              <a:t>polyhaline</a:t>
-            </a:r>
-            <a:r>
-              <a:rPr lang="en-US" sz="2800" dirty="0">
-                <a:latin typeface="Arial" panose="020B0604020202020204" pitchFamily="34" charset="0"/>
-                <a:cs typeface="Arial" panose="020B0604020202020204" pitchFamily="34" charset="0"/>
-              </a:rPr>
-              <a:t> </a:t>
+              <a:t>that are oligohaline, mesohaline, and polyhaline </a:t>
             </a:r>
           </a:p>
           <a:p>
@@ -3391,7 +2833,7 @@
         </p:nvCxnSpPr>
         <p:spPr>
           <a:xfrm>
-            <a:off x="18036412" y="16550481"/>
+            <a:off x="18036412" y="16093281"/>
             <a:ext cx="15862150" cy="0"/>
           </a:xfrm>
           <a:prstGeom prst="line">
@@ -3435,7 +2877,7 @@
         <p:spPr>
           <a:xfrm>
             <a:off x="17385664" y="5073039"/>
-            <a:ext cx="0" cy="26641242"/>
+            <a:ext cx="0" cy="27479442"/>
           </a:xfrm>
           <a:prstGeom prst="line">
             <a:avLst/>
@@ -3520,8 +2962,8 @@
         </p:nvSpPr>
         <p:spPr>
           <a:xfrm>
-            <a:off x="18156261" y="16660587"/>
-            <a:ext cx="15095898" cy="2097650"/>
+            <a:off x="18156261" y="16203386"/>
+            <a:ext cx="15862150" cy="3157193"/>
           </a:xfrm>
           <a:prstGeom prst="rect">
             <a:avLst/>
@@ -3676,7 +3118,7 @@
                   <a:srgbClr val="75BFE2"/>
                 </a:solidFill>
               </a:rPr>
-              <a:t>Seasonal variation</a:t>
+              <a:t>Seasonal variation in transitioning forests</a:t>
             </a:r>
             <a:r>
               <a:rPr lang="en-US" sz="3600" b="1" dirty="0"/>
@@ -3690,7 +3132,27 @@
             </a:pPr>
             <a:r>
               <a:rPr lang="en-US" sz="2800" dirty="0"/>
-              <a:t>Sulfate tends to increase throughout each year, especially in the fall, and decrease at the start of a new year. This could be because sulfate-reducing microbes are less active as temperatures decrease at the end of each year. </a:t>
+              <a:t>SO</a:t>
+            </a:r>
+            <a:r>
+              <a:rPr lang="en-US" sz="2800" baseline="-25000" dirty="0"/>
+              <a:t>4</a:t>
+            </a:r>
+            <a:r>
+              <a:rPr lang="en-US" sz="2800" baseline="30000" dirty="0"/>
+              <a:t>2-</a:t>
+            </a:r>
+            <a:r>
+              <a:rPr lang="en-US" sz="2800" dirty="0"/>
+              <a:t> tends to increase throughout each year, especially in the fall, and decrease at the start of a new year. This could be because sulfate-reducing microbes are less active as temperatures decrease at the end of each year, or this could be related to changes in precipitation or </a:t>
+            </a:r>
+            <a:r>
+              <a:rPr lang="en-US" sz="2800" dirty="0" err="1"/>
+              <a:t>surfacewater</a:t>
+            </a:r>
+            <a:r>
+              <a:rPr lang="en-US" sz="2800" dirty="0"/>
+              <a:t> salinities throughout the year. </a:t>
             </a:r>
           </a:p>
           <a:p>
@@ -3700,7 +3162,19 @@
             </a:pPr>
             <a:r>
               <a:rPr lang="en-US" sz="2800" dirty="0"/>
-              <a:t>Sulfate appears to be increasing over time at the </a:t>
+              <a:t>SO</a:t>
+            </a:r>
+            <a:r>
+              <a:rPr lang="en-US" sz="2800" baseline="-25000" dirty="0"/>
+              <a:t>4</a:t>
+            </a:r>
+            <a:r>
+              <a:rPr lang="en-US" sz="2800" baseline="30000" dirty="0"/>
+              <a:t>2-</a:t>
+            </a:r>
+            <a:r>
+              <a:rPr lang="en-US" sz="2800" dirty="0"/>
+              <a:t> appears to be increasing over time at the </a:t>
             </a:r>
             <a:r>
               <a:rPr lang="en-US" sz="2800" dirty="0" err="1"/>
@@ -5614,8 +5088,8 @@
         </p:nvSpPr>
         <p:spPr>
           <a:xfrm>
-            <a:off x="18166504" y="29641484"/>
-            <a:ext cx="15894896" cy="3358873"/>
+            <a:off x="18166503" y="29489084"/>
+            <a:ext cx="16275887" cy="3358873"/>
           </a:xfrm>
           <a:prstGeom prst="rect">
             <a:avLst/>
@@ -5781,19 +5255,19 @@
             </a:pPr>
             <a:r>
               <a:rPr lang="en-US" sz="2800" dirty="0"/>
-              <a:t>Sulfate, a redox-sensitive element, varies across depth and seasonally, although this effect differs across the </a:t>
-            </a:r>
-            <a:r>
-              <a:rPr lang="en-US" sz="2800" dirty="0">
-                <a:solidFill>
-                  <a:srgbClr val="000000"/>
-                </a:solidFill>
-              </a:rPr>
-              <a:t>coastal terrestrial aquatic interface</a:t>
+              <a:t>SO</a:t>
+            </a:r>
+            <a:r>
+              <a:rPr lang="en-US" sz="2800" baseline="-25000" dirty="0"/>
+              <a:t>4</a:t>
+            </a:r>
+            <a:r>
+              <a:rPr lang="en-US" sz="2800" baseline="30000" dirty="0"/>
+              <a:t>2-</a:t>
             </a:r>
             <a:r>
               <a:rPr lang="en-US" sz="2800" dirty="0"/>
-              <a:t>. </a:t>
+              <a:t>, a redox-sensitive element, varies across depth and season, although this effect differs across different sites in the Chesapeake Bay as well as across zones in the coastal terrestrial aquatic interface. </a:t>
             </a:r>
           </a:p>
           <a:p>
@@ -5803,7 +5277,19 @@
             </a:pPr>
             <a:r>
               <a:rPr lang="en-US" sz="2800" dirty="0"/>
-              <a:t>Sulfate was positively correlated with indicators of soil saturation. </a:t>
+              <a:t>SO</a:t>
+            </a:r>
+            <a:r>
+              <a:rPr lang="en-US" sz="2800" baseline="-25000" dirty="0"/>
+              <a:t>4</a:t>
+            </a:r>
+            <a:r>
+              <a:rPr lang="en-US" sz="2800" baseline="30000" dirty="0"/>
+              <a:t>2-</a:t>
+            </a:r>
+            <a:r>
+              <a:rPr lang="en-US" sz="2800" dirty="0"/>
+              <a:t> was positively correlated with indicators of soil saturation. </a:t>
             </a:r>
           </a:p>
           <a:p>
@@ -5813,7 +5299,31 @@
             </a:pPr>
             <a:r>
               <a:rPr lang="en-US" sz="2800" dirty="0"/>
-              <a:t>In the future, we can examine the sulfate-depth relationship to determine if there are patterns that explain its variability across sites and zones. </a:t>
+              <a:t>In the future, we can examine the SO</a:t>
+            </a:r>
+            <a:r>
+              <a:rPr lang="en-US" sz="2800" baseline="-25000" dirty="0"/>
+              <a:t>4</a:t>
+            </a:r>
+            <a:r>
+              <a:rPr lang="en-US" sz="2800" baseline="30000" dirty="0"/>
+              <a:t>2-</a:t>
+            </a:r>
+            <a:r>
+              <a:rPr lang="en-US" sz="2800" dirty="0"/>
+              <a:t> – depth relationship and surface water SO</a:t>
+            </a:r>
+            <a:r>
+              <a:rPr lang="en-US" sz="2800" baseline="-25000" dirty="0"/>
+              <a:t>4</a:t>
+            </a:r>
+            <a:r>
+              <a:rPr lang="en-US" sz="2800" baseline="30000" dirty="0"/>
+              <a:t>2-</a:t>
+            </a:r>
+            <a:r>
+              <a:rPr lang="en-US" sz="2800" dirty="0"/>
+              <a:t> patterns to determine if there are patterns that explain its variability across sites and zones. </a:t>
             </a:r>
           </a:p>
         </p:txBody>
@@ -6012,7 +5522,11 @@
             </a:r>
             <a:r>
               <a:rPr lang="en-US" sz="2800" dirty="0"/>
-              <a:t>) in 2,293 samples</a:t>
+              <a:t>, n=2,293) </a:t>
+            </a:r>
+            <a:r>
+              <a:rPr lang="en-US" sz="2800" strike="sngStrike" dirty="0"/>
+              <a:t>in 2,293 samples</a:t>
             </a:r>
           </a:p>
           <a:p>
@@ -6022,7 +5536,19 @@
             </a:pPr>
             <a:r>
               <a:rPr lang="en-US" sz="2800" dirty="0"/>
-              <a:t>Sulfate increased from upland forest through transition zones to the wetland</a:t>
+              <a:t>Across sites SO</a:t>
+            </a:r>
+            <a:r>
+              <a:rPr lang="en-US" sz="2800" baseline="-25000" dirty="0"/>
+              <a:t>4</a:t>
+            </a:r>
+            <a:r>
+              <a:rPr lang="en-US" sz="2800" baseline="30000" dirty="0"/>
+              <a:t>2-</a:t>
+            </a:r>
+            <a:r>
+              <a:rPr lang="en-US" sz="2800" dirty="0"/>
+              <a:t> increased from upland forest through transition zones to the wetland </a:t>
             </a:r>
           </a:p>
           <a:p>
@@ -6032,23 +5558,19 @@
             </a:pPr>
             <a:r>
               <a:rPr lang="en-US" sz="2800" dirty="0"/>
-              <a:t>Sulfate also increased from </a:t>
-            </a:r>
-            <a:r>
-              <a:rPr lang="en-US" sz="2800" dirty="0" err="1"/>
-              <a:t>Sweethall</a:t>
+              <a:t>SO</a:t>
+            </a:r>
+            <a:r>
+              <a:rPr lang="en-US" sz="2800" baseline="-25000" dirty="0"/>
+              <a:t>4</a:t>
+            </a:r>
+            <a:r>
+              <a:rPr lang="en-US" sz="2800" baseline="30000" dirty="0"/>
+              <a:t>2-</a:t>
             </a:r>
             <a:r>
               <a:rPr lang="en-US" sz="2800" dirty="0"/>
-              <a:t> site (oligohaline) to Goodwin Islands site (</a:t>
-            </a:r>
-            <a:r>
-              <a:rPr lang="en-US" sz="2800" dirty="0" err="1"/>
-              <a:t>polyhaline</a:t>
-            </a:r>
-            <a:r>
-              <a:rPr lang="en-US" sz="2800" dirty="0"/>
-              <a:t>). </a:t>
+              <a:t> also increased from Sweet Hall site (oligohaline) to Goodwin Islands site (polyhaline). </a:t>
             </a:r>
           </a:p>
           <a:p>
@@ -6058,7 +5580,19 @@
             </a:pPr>
             <a:r>
               <a:rPr lang="en-US" sz="2800" dirty="0"/>
-              <a:t>Surface water was a source of sulfate into these ecosystems. </a:t>
+              <a:t>Surface water serves as a source of SO</a:t>
+            </a:r>
+            <a:r>
+              <a:rPr lang="en-US" sz="2800" baseline="-25000" dirty="0"/>
+              <a:t>4</a:t>
+            </a:r>
+            <a:r>
+              <a:rPr lang="en-US" sz="2800" baseline="30000" dirty="0"/>
+              <a:t>2-</a:t>
+            </a:r>
+            <a:r>
+              <a:rPr lang="en-US" sz="2800" dirty="0"/>
+              <a:t> into these ecosystems. </a:t>
             </a:r>
           </a:p>
           <a:p>
@@ -6260,7 +5794,19 @@
             </a:pPr>
             <a:r>
               <a:rPr lang="en-US" sz="2800" dirty="0"/>
-              <a:t>Sulfate increases with increasing groundwater salinity, groundwater water level, soil electrical conductivity, and soil volumetric water content. </a:t>
+              <a:t>SO</a:t>
+            </a:r>
+            <a:r>
+              <a:rPr lang="en-US" sz="2800" baseline="-25000" dirty="0"/>
+              <a:t>4</a:t>
+            </a:r>
+            <a:r>
+              <a:rPr lang="en-US" sz="2800" baseline="30000" dirty="0"/>
+              <a:t>2-</a:t>
+            </a:r>
+            <a:r>
+              <a:rPr lang="en-US" sz="2800" dirty="0"/>
+              <a:t> increases with increasing groundwater salinity, groundwater water level, soil electrical conductivity, and soil volumetric water content. </a:t>
             </a:r>
           </a:p>
           <a:p>
@@ -6291,8 +5837,8 @@
         </p:nvSpPr>
         <p:spPr>
           <a:xfrm>
-            <a:off x="888614" y="24794643"/>
-            <a:ext cx="15095898" cy="2423838"/>
+            <a:off x="888613" y="24794643"/>
+            <a:ext cx="15418179" cy="2423838"/>
           </a:xfrm>
           <a:prstGeom prst="rect">
             <a:avLst/>
@@ -6470,11 +6016,23 @@
               <a:buChar char="•"/>
             </a:pPr>
             <a:r>
+              <a:rPr lang="en-US" sz="2800" dirty="0"/>
+              <a:t>SO</a:t>
+            </a:r>
+            <a:r>
+              <a:rPr lang="en-US" sz="2800" baseline="-25000" dirty="0"/>
+              <a:t>4</a:t>
+            </a:r>
+            <a:r>
+              <a:rPr lang="en-US" sz="2800" baseline="30000" dirty="0"/>
+              <a:t>2-</a:t>
+            </a:r>
+            <a:r>
               <a:rPr lang="en-US" sz="2800" dirty="0">
                 <a:latin typeface="Arial" panose="020B0604020202020204" pitchFamily="34" charset="0"/>
                 <a:cs typeface="Arial" panose="020B0604020202020204" pitchFamily="34" charset="0"/>
               </a:rPr>
-              <a:t>Sulfate concentration changes by depth, but this effect differs across site and zone. </a:t>
+              <a:t> concentration changes by depth, but the depth pattern differs across site and zone. </a:t>
             </a:r>
             <a:endParaRPr lang="en-US" sz="2800" dirty="0"/>
           </a:p>
@@ -6523,42 +6081,6 @@
           </a:fontRef>
         </p:style>
       </p:cxnSp>
-      <p:pic>
-        <p:nvPicPr>
-          <p:cNvPr id="1085" name="Picture 1084" descr="A graph of different colored lines&#10;&#10;AI-generated content may be incorrect.">
-            <a:extLst>
-              <a:ext uri="{FF2B5EF4-FFF2-40B4-BE49-F238E27FC236}">
-                <a16:creationId xmlns:a16="http://schemas.microsoft.com/office/drawing/2014/main" id="{9E2D53CD-2078-3011-EB8F-F1979C9B3B22}"/>
-              </a:ext>
-            </a:extLst>
-          </p:cNvPr>
-          <p:cNvPicPr>
-            <a:picLocks noChangeAspect="1"/>
-          </p:cNvPicPr>
-          <p:nvPr/>
-        </p:nvPicPr>
-        <p:blipFill>
-          <a:blip r:embed="rId8">
-            <a:extLst>
-              <a:ext uri="{28A0092B-C50C-407E-A947-70E740481C1C}">
-                <a14:useLocalDpi xmlns:a14="http://schemas.microsoft.com/office/drawing/2010/main" val="0"/>
-              </a:ext>
-            </a:extLst>
-          </a:blip>
-          <a:stretch>
-            <a:fillRect/>
-          </a:stretch>
-        </p:blipFill>
-        <p:spPr>
-          <a:xfrm>
-            <a:off x="778559" y="26620977"/>
-            <a:ext cx="16459233" cy="5029210"/>
-          </a:xfrm>
-          <a:prstGeom prst="rect">
-            <a:avLst/>
-          </a:prstGeom>
-        </p:spPr>
-      </p:pic>
       <p:cxnSp>
         <p:nvCxnSpPr>
           <p:cNvPr id="1153" name="Straight Connector 1152">
@@ -7045,10 +6567,46 @@
       </p:cxnSp>
       <p:pic>
         <p:nvPicPr>
-          <p:cNvPr id="9" name="Picture 8" descr="A graph of different types of water levels&#10;&#10;AI-generated content may be incorrect.">
+          <p:cNvPr id="22" name="Picture 21" descr="A graph of different colored lines&#10;&#10;AI-generated content may be incorrect.">
             <a:extLst>
               <a:ext uri="{FF2B5EF4-FFF2-40B4-BE49-F238E27FC236}">
-                <a16:creationId xmlns:a16="http://schemas.microsoft.com/office/drawing/2014/main" id="{85DA710A-FE9C-9F98-B2EB-359901B6FE67}"/>
+                <a16:creationId xmlns:a16="http://schemas.microsoft.com/office/drawing/2014/main" id="{00462A3D-D24C-025E-9B9B-C8F9481AB05B}"/>
+              </a:ext>
+            </a:extLst>
+          </p:cNvPr>
+          <p:cNvPicPr>
+            <a:picLocks noChangeAspect="1"/>
+          </p:cNvPicPr>
+          <p:nvPr/>
+        </p:nvPicPr>
+        <p:blipFill>
+          <a:blip r:embed="rId8">
+            <a:extLst>
+              <a:ext uri="{28A0092B-C50C-407E-A947-70E740481C1C}">
+                <a14:useLocalDpi xmlns:a14="http://schemas.microsoft.com/office/drawing/2010/main" val="0"/>
+              </a:ext>
+            </a:extLst>
+          </a:blip>
+          <a:stretch>
+            <a:fillRect/>
+          </a:stretch>
+        </p:blipFill>
+        <p:spPr>
+          <a:xfrm>
+            <a:off x="561642" y="26684825"/>
+            <a:ext cx="16459233" cy="5029210"/>
+          </a:xfrm>
+          <a:prstGeom prst="rect">
+            <a:avLst/>
+          </a:prstGeom>
+        </p:spPr>
+      </p:pic>
+      <p:pic>
+        <p:nvPicPr>
+          <p:cNvPr id="1120" name="Picture 1119" descr="A graph of different types of water levels&#10;&#10;AI-generated content may be incorrect.">
+            <a:extLst>
+              <a:ext uri="{FF2B5EF4-FFF2-40B4-BE49-F238E27FC236}">
+                <a16:creationId xmlns:a16="http://schemas.microsoft.com/office/drawing/2014/main" id="{B0C5102B-10F2-E0CF-866D-ECB35E6B9A2F}"/>
               </a:ext>
             </a:extLst>
           </p:cNvPr>
@@ -7071,8 +6629,8 @@
         </p:blipFill>
         <p:spPr>
           <a:xfrm>
-            <a:off x="17737870" y="8163823"/>
-            <a:ext cx="16459233" cy="8229616"/>
+            <a:off x="17778325" y="8099895"/>
+            <a:ext cx="16459233" cy="7772415"/>
           </a:xfrm>
           <a:prstGeom prst="rect">
             <a:avLst/>

</xml_diff>

<commit_message>
Finalized GCReW Symposium Poster
</commit_message>
<xml_diff>
--- a/ReadZ_GCReW_Symposium_Poster_2026.pptx
+++ b/ReadZ_GCReW_Symposium_Poster_2026.pptx
@@ -136,7 +136,7 @@
 <file path=ppt/revisionInfo.xml><?xml version="1.0" encoding="utf-8"?>
 <p1510:revInfo xmlns:a="http://schemas.openxmlformats.org/drawingml/2006/main" xmlns:r="http://schemas.openxmlformats.org/officeDocument/2006/relationships" xmlns:p1510="http://schemas.microsoft.com/office/powerpoint/2015/10/main">
   <p1510:revLst>
-    <p1510:client id="{43AB8F2F-7ED7-4FE6-9983-ECD9988C75B8}" v="6" dt="2026-03-16T11:35:47.524"/>
+    <p1510:client id="{43AB8F2F-7ED7-4FE6-9983-ECD9988C75B8}" v="15" dt="2026-03-23T13:17:30.714"/>
   </p1510:revLst>
 </p1510:revInfo>
 </file>
@@ -146,12 +146,12 @@
   <pc:docChgLst>
     <pc:chgData name="Read, Zoe" userId="b08cd0fd-26d2-470b-8ec0-c6e6cb2a79bd" providerId="ADAL" clId="{5AEB2719-95A5-4ED2-9E0E-ED462BB10526}"/>
     <pc:docChg chg="undo custSel addSld delSld modSld modMainMaster">
-      <pc:chgData name="Read, Zoe" userId="b08cd0fd-26d2-470b-8ec0-c6e6cb2a79bd" providerId="ADAL" clId="{5AEB2719-95A5-4ED2-9E0E-ED462BB10526}" dt="2026-03-16T11:36:02.334" v="6657" actId="1035"/>
+      <pc:chgData name="Read, Zoe" userId="b08cd0fd-26d2-470b-8ec0-c6e6cb2a79bd" providerId="ADAL" clId="{5AEB2719-95A5-4ED2-9E0E-ED462BB10526}" dt="2026-03-23T13:24:28.163" v="6786" actId="1076"/>
       <pc:docMkLst>
         <pc:docMk/>
       </pc:docMkLst>
       <pc:sldChg chg="addSp delSp modSp mod modCm modNotesTx">
-        <pc:chgData name="Read, Zoe" userId="b08cd0fd-26d2-470b-8ec0-c6e6cb2a79bd" providerId="ADAL" clId="{5AEB2719-95A5-4ED2-9E0E-ED462BB10526}" dt="2026-03-16T11:36:02.334" v="6657" actId="1035"/>
+        <pc:chgData name="Read, Zoe" userId="b08cd0fd-26d2-470b-8ec0-c6e6cb2a79bd" providerId="ADAL" clId="{5AEB2719-95A5-4ED2-9E0E-ED462BB10526}" dt="2026-03-23T13:24:28.163" v="6786" actId="1076"/>
         <pc:sldMkLst>
           <pc:docMk/>
           <pc:sldMk cId="2005456116" sldId="257"/>
@@ -165,7 +165,7 @@
           </ac:spMkLst>
         </pc:spChg>
         <pc:spChg chg="mod">
-          <ac:chgData name="Read, Zoe" userId="b08cd0fd-26d2-470b-8ec0-c6e6cb2a79bd" providerId="ADAL" clId="{5AEB2719-95A5-4ED2-9E0E-ED462BB10526}" dt="2026-03-16T11:22:42.938" v="6443" actId="20577"/>
+          <ac:chgData name="Read, Zoe" userId="b08cd0fd-26d2-470b-8ec0-c6e6cb2a79bd" providerId="ADAL" clId="{5AEB2719-95A5-4ED2-9E0E-ED462BB10526}" dt="2026-03-23T13:13:29.329" v="6667"/>
           <ac:spMkLst>
             <pc:docMk/>
             <pc:sldMk cId="2005456116" sldId="257"/>
@@ -181,7 +181,7 @@
           </ac:spMkLst>
         </pc:spChg>
         <pc:spChg chg="add mod ord">
-          <ac:chgData name="Read, Zoe" userId="b08cd0fd-26d2-470b-8ec0-c6e6cb2a79bd" providerId="ADAL" clId="{5AEB2719-95A5-4ED2-9E0E-ED462BB10526}" dt="2026-03-16T11:23:15.018" v="6445" actId="207"/>
+          <ac:chgData name="Read, Zoe" userId="b08cd0fd-26d2-470b-8ec0-c6e6cb2a79bd" providerId="ADAL" clId="{5AEB2719-95A5-4ED2-9E0E-ED462BB10526}" dt="2026-03-23T13:23:07.185" v="6778" actId="20577"/>
           <ac:spMkLst>
             <pc:docMk/>
             <pc:sldMk cId="2005456116" sldId="257"/>
@@ -189,7 +189,7 @@
           </ac:spMkLst>
         </pc:spChg>
         <pc:spChg chg="mod">
-          <ac:chgData name="Read, Zoe" userId="b08cd0fd-26d2-470b-8ec0-c6e6cb2a79bd" providerId="ADAL" clId="{5AEB2719-95A5-4ED2-9E0E-ED462BB10526}" dt="2026-03-13T15:56:17.329" v="5363" actId="1036"/>
+          <ac:chgData name="Read, Zoe" userId="b08cd0fd-26d2-470b-8ec0-c6e6cb2a79bd" providerId="ADAL" clId="{5AEB2719-95A5-4ED2-9E0E-ED462BB10526}" dt="2026-03-23T13:15:54.586" v="6724" actId="20577"/>
           <ac:spMkLst>
             <pc:docMk/>
             <pc:sldMk cId="2005456116" sldId="257"/>
@@ -285,7 +285,7 @@
           </ac:spMkLst>
         </pc:spChg>
         <pc:spChg chg="mod">
-          <ac:chgData name="Read, Zoe" userId="b08cd0fd-26d2-470b-8ec0-c6e6cb2a79bd" providerId="ADAL" clId="{5AEB2719-95A5-4ED2-9E0E-ED462BB10526}" dt="2026-03-13T15:50:15.459" v="5087" actId="1036"/>
+          <ac:chgData name="Read, Zoe" userId="b08cd0fd-26d2-470b-8ec0-c6e6cb2a79bd" providerId="ADAL" clId="{5AEB2719-95A5-4ED2-9E0E-ED462BB10526}" dt="2026-03-23T13:24:28.163" v="6786" actId="1076"/>
           <ac:spMkLst>
             <pc:docMk/>
             <pc:sldMk cId="2005456116" sldId="257"/>
@@ -293,7 +293,7 @@
           </ac:spMkLst>
         </pc:spChg>
         <pc:spChg chg="add mod">
-          <ac:chgData name="Read, Zoe" userId="b08cd0fd-26d2-470b-8ec0-c6e6cb2a79bd" providerId="ADAL" clId="{5AEB2719-95A5-4ED2-9E0E-ED462BB10526}" dt="2026-03-16T11:34:59.565" v="6645" actId="1035"/>
+          <ac:chgData name="Read, Zoe" userId="b08cd0fd-26d2-470b-8ec0-c6e6cb2a79bd" providerId="ADAL" clId="{5AEB2719-95A5-4ED2-9E0E-ED462BB10526}" dt="2026-03-23T13:22:18.367" v="6776" actId="20577"/>
           <ac:spMkLst>
             <pc:docMk/>
             <pc:sldMk cId="2005456116" sldId="257"/>
@@ -301,7 +301,7 @@
           </ac:spMkLst>
         </pc:spChg>
         <pc:spChg chg="add mod">
-          <ac:chgData name="Read, Zoe" userId="b08cd0fd-26d2-470b-8ec0-c6e6cb2a79bd" providerId="ADAL" clId="{5AEB2719-95A5-4ED2-9E0E-ED462BB10526}" dt="2026-03-16T11:23:07.849" v="6444" actId="207"/>
+          <ac:chgData name="Read, Zoe" userId="b08cd0fd-26d2-470b-8ec0-c6e6cb2a79bd" providerId="ADAL" clId="{5AEB2719-95A5-4ED2-9E0E-ED462BB10526}" dt="2026-03-23T13:17:01.169" v="6730" actId="20577"/>
           <ac:spMkLst>
             <pc:docMk/>
             <pc:sldMk cId="2005456116" sldId="257"/>
@@ -309,7 +309,7 @@
           </ac:spMkLst>
         </pc:spChg>
         <pc:spChg chg="add mod">
-          <ac:chgData name="Read, Zoe" userId="b08cd0fd-26d2-470b-8ec0-c6e6cb2a79bd" providerId="ADAL" clId="{5AEB2719-95A5-4ED2-9E0E-ED462BB10526}" dt="2026-03-16T11:23:25.664" v="6446" actId="207"/>
+          <ac:chgData name="Read, Zoe" userId="b08cd0fd-26d2-470b-8ec0-c6e6cb2a79bd" providerId="ADAL" clId="{5AEB2719-95A5-4ED2-9E0E-ED462BB10526}" dt="2026-03-23T13:18:20.272" v="6734" actId="20577"/>
           <ac:spMkLst>
             <pc:docMk/>
             <pc:sldMk cId="2005456116" sldId="257"/>
@@ -317,7 +317,7 @@
           </ac:spMkLst>
         </pc:spChg>
         <pc:spChg chg="mod">
-          <ac:chgData name="Read, Zoe" userId="b08cd0fd-26d2-470b-8ec0-c6e6cb2a79bd" providerId="ADAL" clId="{5AEB2719-95A5-4ED2-9E0E-ED462BB10526}" dt="2026-03-16T11:36:02.334" v="6657" actId="1035"/>
+          <ac:chgData name="Read, Zoe" userId="b08cd0fd-26d2-470b-8ec0-c6e6cb2a79bd" providerId="ADAL" clId="{5AEB2719-95A5-4ED2-9E0E-ED462BB10526}" dt="2026-03-23T13:20:13.186" v="6747" actId="20577"/>
           <ac:spMkLst>
             <pc:docMk/>
             <pc:sldMk cId="2005456116" sldId="257"/>
@@ -325,37 +325,13 @@
           </ac:spMkLst>
         </pc:spChg>
         <pc:graphicFrameChg chg="mod modGraphic">
-          <ac:chgData name="Read, Zoe" userId="b08cd0fd-26d2-470b-8ec0-c6e6cb2a79bd" providerId="ADAL" clId="{5AEB2719-95A5-4ED2-9E0E-ED462BB10526}" dt="2026-03-13T18:11:25.336" v="5465" actId="1076"/>
+          <ac:chgData name="Read, Zoe" userId="b08cd0fd-26d2-470b-8ec0-c6e6cb2a79bd" providerId="ADAL" clId="{5AEB2719-95A5-4ED2-9E0E-ED462BB10526}" dt="2026-03-23T13:24:17.114" v="6782" actId="20577"/>
           <ac:graphicFrameMkLst>
             <pc:docMk/>
             <pc:sldMk cId="2005456116" sldId="257"/>
             <ac:graphicFrameMk id="20" creationId="{6EE1AE5B-A26D-71DD-8EF3-D283BC117F1C}"/>
           </ac:graphicFrameMkLst>
         </pc:graphicFrameChg>
-        <pc:picChg chg="add del mod ord">
-          <ac:chgData name="Read, Zoe" userId="b08cd0fd-26d2-470b-8ec0-c6e6cb2a79bd" providerId="ADAL" clId="{5AEB2719-95A5-4ED2-9E0E-ED462BB10526}" dt="2026-03-16T11:28:05.199" v="6542" actId="478"/>
-          <ac:picMkLst>
-            <pc:docMk/>
-            <pc:sldMk cId="2005456116" sldId="257"/>
-            <ac:picMk id="6" creationId="{65D6C5CC-18B1-CDA4-E731-06FAAFE46261}"/>
-          </ac:picMkLst>
-        </pc:picChg>
-        <pc:picChg chg="add del mod">
-          <ac:chgData name="Read, Zoe" userId="b08cd0fd-26d2-470b-8ec0-c6e6cb2a79bd" providerId="ADAL" clId="{5AEB2719-95A5-4ED2-9E0E-ED462BB10526}" dt="2026-03-16T11:28:46.704" v="6548" actId="478"/>
-          <ac:picMkLst>
-            <pc:docMk/>
-            <pc:sldMk cId="2005456116" sldId="257"/>
-            <ac:picMk id="8" creationId="{5CF41111-8529-1268-9415-CABE9AC20ADC}"/>
-          </ac:picMkLst>
-        </pc:picChg>
-        <pc:picChg chg="add del mod">
-          <ac:chgData name="Read, Zoe" userId="b08cd0fd-26d2-470b-8ec0-c6e6cb2a79bd" providerId="ADAL" clId="{5AEB2719-95A5-4ED2-9E0E-ED462BB10526}" dt="2026-03-16T11:32:18.188" v="6634" actId="478"/>
-          <ac:picMkLst>
-            <pc:docMk/>
-            <pc:sldMk cId="2005456116" sldId="257"/>
-            <ac:picMk id="9" creationId="{85DA710A-FE9C-9F98-B2EB-359901B6FE67}"/>
-          </ac:picMkLst>
-        </pc:picChg>
         <pc:picChg chg="add mod ord">
           <ac:chgData name="Read, Zoe" userId="b08cd0fd-26d2-470b-8ec0-c6e6cb2a79bd" providerId="ADAL" clId="{5AEB2719-95A5-4ED2-9E0E-ED462BB10526}" dt="2026-03-16T11:28:57.449" v="6551" actId="1076"/>
           <ac:picMkLst>
@@ -364,28 +340,12 @@
             <ac:picMk id="11" creationId="{DA28F95C-2111-E10A-4CC1-C069E3C51045}"/>
           </ac:picMkLst>
         </pc:picChg>
-        <pc:picChg chg="add del mod">
-          <ac:chgData name="Read, Zoe" userId="b08cd0fd-26d2-470b-8ec0-c6e6cb2a79bd" providerId="ADAL" clId="{5AEB2719-95A5-4ED2-9E0E-ED462BB10526}" dt="2026-03-16T11:35:39.896" v="6650" actId="478"/>
-          <ac:picMkLst>
-            <pc:docMk/>
-            <pc:sldMk cId="2005456116" sldId="257"/>
-            <ac:picMk id="15" creationId="{D5EFE006-592F-3411-CBFD-F9BC7ECA928A}"/>
-          </ac:picMkLst>
-        </pc:picChg>
         <pc:picChg chg="add mod">
           <ac:chgData name="Read, Zoe" userId="b08cd0fd-26d2-470b-8ec0-c6e6cb2a79bd" providerId="ADAL" clId="{5AEB2719-95A5-4ED2-9E0E-ED462BB10526}" dt="2026-03-16T11:34:11.066" v="6642" actId="1076"/>
           <ac:picMkLst>
             <pc:docMk/>
             <pc:sldMk cId="2005456116" sldId="257"/>
             <ac:picMk id="22" creationId="{00462A3D-D24C-025E-9B9B-C8F9481AB05B}"/>
-          </ac:picMkLst>
-        </pc:picChg>
-        <pc:picChg chg="add del mod">
-          <ac:chgData name="Read, Zoe" userId="b08cd0fd-26d2-470b-8ec0-c6e6cb2a79bd" providerId="ADAL" clId="{5AEB2719-95A5-4ED2-9E0E-ED462BB10526}" dt="2026-03-16T11:34:01.951" v="6640" actId="478"/>
-          <ac:picMkLst>
-            <pc:docMk/>
-            <pc:sldMk cId="2005456116" sldId="257"/>
-            <ac:picMk id="1085" creationId="{9E2D53CD-2078-3011-EB8F-F1979C9B3B22}"/>
           </ac:picMkLst>
         </pc:picChg>
         <pc:picChg chg="add mod">
@@ -453,7 +413,7 @@
           </ac:cxnSpMkLst>
         </pc:cxnChg>
         <pc:cxnChg chg="add mod">
-          <ac:chgData name="Read, Zoe" userId="b08cd0fd-26d2-470b-8ec0-c6e6cb2a79bd" providerId="ADAL" clId="{5AEB2719-95A5-4ED2-9E0E-ED462BB10526}" dt="2026-03-13T20:07:33.645" v="6439" actId="1038"/>
+          <ac:chgData name="Read, Zoe" userId="b08cd0fd-26d2-470b-8ec0-c6e6cb2a79bd" providerId="ADAL" clId="{5AEB2719-95A5-4ED2-9E0E-ED462BB10526}" dt="2026-03-23T13:20:54.859" v="6756" actId="1038"/>
           <ac:cxnSpMkLst>
             <pc:docMk/>
             <pc:sldMk cId="2005456116" sldId="257"/>
@@ -461,7 +421,7 @@
           </ac:cxnSpMkLst>
         </pc:cxnChg>
         <pc:cxnChg chg="add mod">
-          <ac:chgData name="Read, Zoe" userId="b08cd0fd-26d2-470b-8ec0-c6e6cb2a79bd" providerId="ADAL" clId="{5AEB2719-95A5-4ED2-9E0E-ED462BB10526}" dt="2026-03-13T20:07:33.645" v="6439" actId="1038"/>
+          <ac:chgData name="Read, Zoe" userId="b08cd0fd-26d2-470b-8ec0-c6e6cb2a79bd" providerId="ADAL" clId="{5AEB2719-95A5-4ED2-9E0E-ED462BB10526}" dt="2026-03-23T13:20:56.054" v="6757" actId="1038"/>
           <ac:cxnSpMkLst>
             <pc:docMk/>
             <pc:sldMk cId="2005456116" sldId="257"/>
@@ -469,7 +429,7 @@
           </ac:cxnSpMkLst>
         </pc:cxnChg>
         <pc:cxnChg chg="add mod">
-          <ac:chgData name="Read, Zoe" userId="b08cd0fd-26d2-470b-8ec0-c6e6cb2a79bd" providerId="ADAL" clId="{5AEB2719-95A5-4ED2-9E0E-ED462BB10526}" dt="2026-03-13T20:07:33.645" v="6439" actId="1038"/>
+          <ac:chgData name="Read, Zoe" userId="b08cd0fd-26d2-470b-8ec0-c6e6cb2a79bd" providerId="ADAL" clId="{5AEB2719-95A5-4ED2-9E0E-ED462BB10526}" dt="2026-03-23T13:20:24.923" v="6751" actId="1076"/>
           <ac:cxnSpMkLst>
             <pc:docMk/>
             <pc:sldMk cId="2005456116" sldId="257"/>
@@ -477,7 +437,7 @@
           </ac:cxnSpMkLst>
         </pc:cxnChg>
         <pc:cxnChg chg="add mod">
-          <ac:chgData name="Read, Zoe" userId="b08cd0fd-26d2-470b-8ec0-c6e6cb2a79bd" providerId="ADAL" clId="{5AEB2719-95A5-4ED2-9E0E-ED462BB10526}" dt="2026-03-13T20:07:33.645" v="6439" actId="1038"/>
+          <ac:chgData name="Read, Zoe" userId="b08cd0fd-26d2-470b-8ec0-c6e6cb2a79bd" providerId="ADAL" clId="{5AEB2719-95A5-4ED2-9E0E-ED462BB10526}" dt="2026-03-23T13:20:21.804" v="6750" actId="1076"/>
           <ac:cxnSpMkLst>
             <pc:docMk/>
             <pc:sldMk cId="2005456116" sldId="257"/>
@@ -485,7 +445,7 @@
           </ac:cxnSpMkLst>
         </pc:cxnChg>
         <pc:cxnChg chg="add mod">
-          <ac:chgData name="Read, Zoe" userId="b08cd0fd-26d2-470b-8ec0-c6e6cb2a79bd" providerId="ADAL" clId="{5AEB2719-95A5-4ED2-9E0E-ED462BB10526}" dt="2026-03-13T19:36:41.872" v="6375" actId="1076"/>
+          <ac:chgData name="Read, Zoe" userId="b08cd0fd-26d2-470b-8ec0-c6e6cb2a79bd" providerId="ADAL" clId="{5AEB2719-95A5-4ED2-9E0E-ED462BB10526}" dt="2026-03-23T13:20:18.582" v="6748" actId="1076"/>
           <ac:cxnSpMkLst>
             <pc:docMk/>
             <pc:sldMk cId="2005456116" sldId="257"/>
@@ -493,7 +453,7 @@
           </ac:cxnSpMkLst>
         </pc:cxnChg>
         <pc:cxnChg chg="add mod">
-          <ac:chgData name="Read, Zoe" userId="b08cd0fd-26d2-470b-8ec0-c6e6cb2a79bd" providerId="ADAL" clId="{5AEB2719-95A5-4ED2-9E0E-ED462BB10526}" dt="2026-03-13T20:07:33.645" v="6439" actId="1038"/>
+          <ac:chgData name="Read, Zoe" userId="b08cd0fd-26d2-470b-8ec0-c6e6cb2a79bd" providerId="ADAL" clId="{5AEB2719-95A5-4ED2-9E0E-ED462BB10526}" dt="2026-03-23T13:21:00.940" v="6761" actId="1037"/>
           <ac:cxnSpMkLst>
             <pc:docMk/>
             <pc:sldMk cId="2005456116" sldId="257"/>
@@ -501,7 +461,7 @@
           </ac:cxnSpMkLst>
         </pc:cxnChg>
         <pc:cxnChg chg="add mod">
-          <ac:chgData name="Read, Zoe" userId="b08cd0fd-26d2-470b-8ec0-c6e6cb2a79bd" providerId="ADAL" clId="{5AEB2719-95A5-4ED2-9E0E-ED462BB10526}" dt="2026-03-13T20:07:33.645" v="6439" actId="1038"/>
+          <ac:chgData name="Read, Zoe" userId="b08cd0fd-26d2-470b-8ec0-c6e6cb2a79bd" providerId="ADAL" clId="{5AEB2719-95A5-4ED2-9E0E-ED462BB10526}" dt="2026-03-23T13:21:01.835" v="6762" actId="1037"/>
           <ac:cxnSpMkLst>
             <pc:docMk/>
             <pc:sldMk cId="2005456116" sldId="257"/>
@@ -509,7 +469,7 @@
           </ac:cxnSpMkLst>
         </pc:cxnChg>
         <pc:cxnChg chg="add mod">
-          <ac:chgData name="Read, Zoe" userId="b08cd0fd-26d2-470b-8ec0-c6e6cb2a79bd" providerId="ADAL" clId="{5AEB2719-95A5-4ED2-9E0E-ED462BB10526}" dt="2026-03-16T11:24:24.947" v="6504" actId="1076"/>
+          <ac:chgData name="Read, Zoe" userId="b08cd0fd-26d2-470b-8ec0-c6e6cb2a79bd" providerId="ADAL" clId="{5AEB2719-95A5-4ED2-9E0E-ED462BB10526}" dt="2026-03-23T13:21:08.722" v="6765" actId="1037"/>
           <ac:cxnSpMkLst>
             <pc:docMk/>
             <pc:sldMk cId="2005456116" sldId="257"/>
@@ -517,7 +477,7 @@
           </ac:cxnSpMkLst>
         </pc:cxnChg>
         <pc:cxnChg chg="add mod">
-          <ac:chgData name="Read, Zoe" userId="b08cd0fd-26d2-470b-8ec0-c6e6cb2a79bd" providerId="ADAL" clId="{5AEB2719-95A5-4ED2-9E0E-ED462BB10526}" dt="2026-03-13T20:07:33.645" v="6439" actId="1038"/>
+          <ac:chgData name="Read, Zoe" userId="b08cd0fd-26d2-470b-8ec0-c6e6cb2a79bd" providerId="ADAL" clId="{5AEB2719-95A5-4ED2-9E0E-ED462BB10526}" dt="2026-03-23T13:20:50.027" v="6755" actId="1038"/>
           <ac:cxnSpMkLst>
             <pc:docMk/>
             <pc:sldMk cId="2005456116" sldId="257"/>
@@ -525,7 +485,7 @@
           </ac:cxnSpMkLst>
         </pc:cxnChg>
         <pc:cxnChg chg="add mod">
-          <ac:chgData name="Read, Zoe" userId="b08cd0fd-26d2-470b-8ec0-c6e6cb2a79bd" providerId="ADAL" clId="{5AEB2719-95A5-4ED2-9E0E-ED462BB10526}" dt="2026-03-13T19:36:41.872" v="6375" actId="1076"/>
+          <ac:chgData name="Read, Zoe" userId="b08cd0fd-26d2-470b-8ec0-c6e6cb2a79bd" providerId="ADAL" clId="{5AEB2719-95A5-4ED2-9E0E-ED462BB10526}" dt="2026-03-23T13:20:43.012" v="6752" actId="1076"/>
           <ac:cxnSpMkLst>
             <pc:docMk/>
             <pc:sldMk cId="2005456116" sldId="257"/>
@@ -533,7 +493,7 @@
           </ac:cxnSpMkLst>
         </pc:cxnChg>
         <pc:cxnChg chg="add mod">
-          <ac:chgData name="Read, Zoe" userId="b08cd0fd-26d2-470b-8ec0-c6e6cb2a79bd" providerId="ADAL" clId="{5AEB2719-95A5-4ED2-9E0E-ED462BB10526}" dt="2026-03-13T20:07:33.645" v="6439" actId="1038"/>
+          <ac:chgData name="Read, Zoe" userId="b08cd0fd-26d2-470b-8ec0-c6e6cb2a79bd" providerId="ADAL" clId="{5AEB2719-95A5-4ED2-9E0E-ED462BB10526}" dt="2026-03-23T13:20:47.109" v="6754" actId="1037"/>
           <ac:cxnSpMkLst>
             <pc:docMk/>
             <pc:sldMk cId="2005456116" sldId="257"/>
@@ -595,32 +555,6 @@
     </pc:docChg>
   </pc:docChgLst>
 </pc:chgInfo>
-</file>
-
-<file path=ppt/comments/modernComment_101_7788D4F4.xml><?xml version="1.0" encoding="utf-8"?>
-<p188:cmLst xmlns:a="http://schemas.openxmlformats.org/drawingml/2006/main" xmlns:r="http://schemas.openxmlformats.org/officeDocument/2006/relationships" xmlns:p188="http://schemas.microsoft.com/office/powerpoint/2018/8/main">
-  <p188:cm id="{597E5C60-A8AD-485E-8A84-796A7E2CF6A3}" authorId="{231D7B86-FC17-2341-A59E-74856DBD8393}" status="resolved" created="2026-03-13T21:58:16.626" complete="100000">
-    <ac:txMkLst xmlns:ac="http://schemas.microsoft.com/office/drawing/2013/main/command">
-      <pc:docMk xmlns:pc="http://schemas.microsoft.com/office/powerpoint/2013/main/command"/>
-      <pc:sldMk xmlns:pc="http://schemas.microsoft.com/office/powerpoint/2013/main/command" cId="2005456116" sldId="257"/>
-      <ac:spMk id="1046" creationId="{3D22E29A-542C-2707-EE87-D32E923FD26A}"/>
-      <ac:txMk cp="339" len="10">
-        <ac:context len="445" hash="2235153434"/>
-      </ac:txMk>
-    </ac:txMkLst>
-    <p188:pos x="13446686" y="1916171"/>
-    <p188:txBody>
-      <a:bodyPr/>
-      <a:lstStyle/>
-      <a:p>
-        <a:r>
-          <a:rPr lang="en-US"/>
-          <a:t>Not necessary for now, but we might plot this same graph of the 0cm  /SW samples and see if they follow the same pattern - it might be that the surface water salinity drives the sulfate concentrations? </a:t>
-        </a:r>
-      </a:p>
-    </p188:txBody>
-  </p188:cm>
-</p188:cmLst>
 </file>
 
 <file path=ppt/notesMasters/notesMaster1.xml><?xml version="1.0" encoding="utf-8"?>
@@ -705,7 +639,7 @@
           <a:p>
             <a:fld id="{0407BD97-90D8-3541-9414-B17D17D02539}" type="datetimeFigureOut">
               <a:rPr lang="en-US" smtClean="0"/>
-              <a:t>3/16/2026</a:t>
+              <a:t>3/23/2026</a:t>
             </a:fld>
             <a:endParaRPr lang="en-US"/>
           </a:p>
@@ -1025,10 +959,7 @@
               <a:buFontTx/>
               <a:buChar char="-"/>
             </a:pPr>
-            <a:r>
-              <a:rPr lang="en-US" baseline="0" dirty="0"/>
-              <a:t>- If have time, could try adding stacked x-axis with month and year below it </a:t>
-            </a:r>
+            <a:endParaRPr lang="en-US" baseline="0" dirty="0"/>
           </a:p>
         </p:txBody>
       </p:sp>
@@ -2286,7 +2217,7 @@
           <p:nvPr/>
         </p:nvPicPr>
         <p:blipFill>
-          <a:blip r:embed="rId4">
+          <a:blip r:embed="rId3">
             <a:extLst>
               <a:ext uri="{28A0092B-C50C-407E-A947-70E740481C1C}">
                 <a14:useLocalDpi xmlns:a14="http://schemas.microsoft.com/office/drawing/2010/main" val="0"/>
@@ -2322,7 +2253,7 @@
           <p:nvPr/>
         </p:nvPicPr>
         <p:blipFill>
-          <a:blip r:embed="rId5">
+          <a:blip r:embed="rId4">
             <a:extLst>
               <a:ext uri="{28A0092B-C50C-407E-A947-70E740481C1C}">
                 <a14:useLocalDpi xmlns:a14="http://schemas.microsoft.com/office/drawing/2010/main" val="0"/>
@@ -2449,11 +2380,67 @@
           <a:p>
             <a:r>
               <a:rPr lang="en-US" sz="3600" b="1" dirty="0"/>
-              <a:t>Zoe Read, </a:t>
+              <a:t>Zoe Read</a:t>
+            </a:r>
+            <a:r>
+              <a:rPr lang="en-US" sz="3600" baseline="30000" dirty="0"/>
+              <a:t>1</a:t>
+            </a:r>
+            <a:r>
+              <a:rPr lang="en-US" sz="3600" b="1" dirty="0"/>
+              <a:t>, </a:t>
             </a:r>
             <a:r>
               <a:rPr lang="en-US" sz="3600" dirty="0"/>
-              <a:t>Stephanie J. Wilson, Alice Stearns, Evan Phillips, Nathan Chin, Pat Megonigal, Ben Bond-Lamberty, and the COMPASS team </a:t>
+              <a:t>Stephanie J. Wilson</a:t>
+            </a:r>
+            <a:r>
+              <a:rPr lang="en-US" sz="3600" baseline="30000" dirty="0"/>
+              <a:t>1</a:t>
+            </a:r>
+            <a:r>
+              <a:rPr lang="en-US" sz="3600" dirty="0"/>
+              <a:t>, Alice Stearns</a:t>
+            </a:r>
+            <a:r>
+              <a:rPr lang="en-US" sz="3600" baseline="30000" dirty="0"/>
+              <a:t>1</a:t>
+            </a:r>
+            <a:r>
+              <a:rPr lang="en-US" sz="3600" dirty="0"/>
+              <a:t>, Evan Phillips</a:t>
+            </a:r>
+            <a:r>
+              <a:rPr lang="en-US" sz="3600" baseline="30000" dirty="0"/>
+              <a:t>1</a:t>
+            </a:r>
+            <a:r>
+              <a:rPr lang="en-US" sz="3600" dirty="0"/>
+              <a:t>, Nathan Chin</a:t>
+            </a:r>
+            <a:r>
+              <a:rPr lang="en-US" sz="3600" baseline="30000" dirty="0"/>
+              <a:t>1</a:t>
+            </a:r>
+            <a:r>
+              <a:rPr lang="en-US" sz="3600" dirty="0"/>
+              <a:t>, Pat Megonigal</a:t>
+            </a:r>
+            <a:r>
+              <a:rPr lang="en-US" sz="3600" baseline="30000" dirty="0"/>
+              <a:t>1</a:t>
+            </a:r>
+            <a:r>
+              <a:rPr lang="en-US" sz="3600" dirty="0"/>
+              <a:t>, Ben Bond-Lamberty</a:t>
+            </a:r>
+            <a:r>
+              <a:rPr lang="en-US" sz="3600" baseline="30000" dirty="0"/>
+              <a:t>2</a:t>
+            </a:r>
+            <a:r>
+              <a:rPr lang="en-US" sz="3600" dirty="0"/>
+              <a:t>, and the COMPASS team </a:t>
             </a:r>
           </a:p>
           <a:p>
@@ -2659,7 +2646,7 @@
             </a:pPr>
             <a:r>
               <a:rPr lang="en-US" sz="2800" dirty="0"/>
-              <a:t>We monitor transects including upland coastal forest, forest transitioning to wetland, and wetlands </a:t>
+              <a:t>Monitoring transects include upland coastal forest, forest transitioning to wetland, and wetlands </a:t>
             </a:r>
             <a:r>
               <a:rPr lang="en-US" sz="2800" dirty="0">
@@ -2677,7 +2664,21 @@
                 <a:latin typeface="Arial" panose="020B0604020202020204" pitchFamily="34" charset="0"/>
                 <a:cs typeface="Arial" panose="020B0604020202020204" pitchFamily="34" charset="0"/>
               </a:rPr>
-              <a:t>that are oligohaline, mesohaline, and polyhaline </a:t>
+              <a:t>that are oligohaline, mesohaline, and </a:t>
+            </a:r>
+            <a:r>
+              <a:rPr lang="en-US" sz="2800" dirty="0" err="1">
+                <a:latin typeface="Arial" panose="020B0604020202020204" pitchFamily="34" charset="0"/>
+                <a:cs typeface="Arial" panose="020B0604020202020204" pitchFamily="34" charset="0"/>
+              </a:rPr>
+              <a:t>polyhaline</a:t>
+            </a:r>
+            <a:r>
+              <a:rPr lang="en-US" sz="2800" dirty="0">
+                <a:latin typeface="Arial" panose="020B0604020202020204" pitchFamily="34" charset="0"/>
+                <a:cs typeface="Arial" panose="020B0604020202020204" pitchFamily="34" charset="0"/>
+              </a:rPr>
+              <a:t>. </a:t>
             </a:r>
           </a:p>
           <a:p>
@@ -2690,7 +2691,7 @@
                 <a:latin typeface="Arial" panose="020B0604020202020204" pitchFamily="34" charset="0"/>
                 <a:cs typeface="Arial" panose="020B0604020202020204" pitchFamily="34" charset="0"/>
               </a:rPr>
-              <a:t>Porewater sampling from 2022-2025 </a:t>
+              <a:t>Porewater sampled from 2022-2025 </a:t>
             </a:r>
             <a:r>
               <a:rPr lang="en-US" sz="2800" dirty="0">
@@ -2698,14 +2699,20 @@
                 <a:cs typeface="Arial" panose="020B0604020202020204" pitchFamily="34" charset="0"/>
                 <a:sym typeface="Wingdings" panose="05000000000000000000" pitchFamily="2" charset="2"/>
               </a:rPr>
-              <a:t> </a:t>
+              <a:t>was </a:t>
+            </a:r>
+            <a:r>
+              <a:rPr lang="en-US" sz="2800" dirty="0">
+                <a:sym typeface="Wingdings" panose="05000000000000000000" pitchFamily="2" charset="2"/>
+              </a:rPr>
+              <a:t>a</a:t>
             </a:r>
             <a:r>
               <a:rPr lang="en-US" sz="2800" dirty="0">
                 <a:latin typeface="Arial" panose="020B0604020202020204" pitchFamily="34" charset="0"/>
                 <a:cs typeface="Arial" panose="020B0604020202020204" pitchFamily="34" charset="0"/>
               </a:rPr>
-              <a:t>Analyzed for DIC, DOC, Total Alkalinity, CDOM, H</a:t>
+              <a:t>nalyzed for DIC, DOC, Total Alkalinity, CDOM, H</a:t>
             </a:r>
             <a:r>
               <a:rPr lang="en-US" sz="2800" baseline="-25000" dirty="0">
@@ -2736,26 +2743,28 @@
               <a:t>, Nutrients, and </a:t>
             </a:r>
             <a:r>
-              <a:rPr lang="en-US" sz="2800" b="1" dirty="0">
+              <a:rPr lang="en-US" sz="2800" b="1" dirty="0"/>
+              <a:t>SO</a:t>
+            </a:r>
+            <a:r>
+              <a:rPr lang="en-US" sz="2800" b="1" baseline="-25000" dirty="0"/>
+              <a:t>4</a:t>
+            </a:r>
+            <a:r>
+              <a:rPr lang="en-US" sz="2800" b="1" baseline="30000" dirty="0"/>
+              <a:t>2-</a:t>
+            </a:r>
+            <a:r>
+              <a:rPr lang="en-US" sz="2800" dirty="0">
                 <a:latin typeface="Arial" panose="020B0604020202020204" pitchFamily="34" charset="0"/>
                 <a:cs typeface="Arial" panose="020B0604020202020204" pitchFamily="34" charset="0"/>
               </a:rPr>
-              <a:t>SO</a:t>
-            </a:r>
-            <a:r>
-              <a:rPr lang="en-US" sz="2800" b="1" baseline="-25000" dirty="0">
-                <a:latin typeface="Arial" panose="020B0604020202020204" pitchFamily="34" charset="0"/>
-                <a:cs typeface="Arial" panose="020B0604020202020204" pitchFamily="34" charset="0"/>
-              </a:rPr>
-              <a:t>4</a:t>
-            </a:r>
-            <a:r>
-              <a:rPr lang="en-US" sz="2800" b="1" baseline="30000" dirty="0">
-                <a:latin typeface="Arial" panose="020B0604020202020204" pitchFamily="34" charset="0"/>
-                <a:cs typeface="Arial" panose="020B0604020202020204" pitchFamily="34" charset="0"/>
-              </a:rPr>
-              <a:t>2-</a:t>
-            </a:r>
+              <a:t>.</a:t>
+            </a:r>
+            <a:endParaRPr lang="en-US" sz="2800" b="1" baseline="30000" dirty="0">
+              <a:latin typeface="Arial" panose="020B0604020202020204" pitchFamily="34" charset="0"/>
+              <a:cs typeface="Arial" panose="020B0604020202020204" pitchFamily="34" charset="0"/>
+            </a:endParaRPr>
           </a:p>
           <a:p>
             <a:pPr marL="457200" indent="-457200">
@@ -2768,7 +2777,7 @@
             </a:r>
             <a:r>
               <a:rPr lang="en-US" sz="2800" dirty="0"/>
-              <a:t> AQ600 sensors deployed in the field, collecting continuous ground and soil water and salinity values</a:t>
+              <a:t> AQ600 sensors are deployed in the field, collecting continuous ground and soil water and salinity values. </a:t>
             </a:r>
           </a:p>
           <a:p>
@@ -3144,15 +3153,7 @@
             </a:r>
             <a:r>
               <a:rPr lang="en-US" sz="2800" dirty="0"/>
-              <a:t> tends to increase throughout each year, especially in the fall, and decrease at the start of a new year. This could be because sulfate-reducing microbes are less active as temperatures decrease at the end of each year, or this could be related to changes in precipitation or </a:t>
-            </a:r>
-            <a:r>
-              <a:rPr lang="en-US" sz="2800" dirty="0" err="1"/>
-              <a:t>surfacewater</a:t>
-            </a:r>
-            <a:r>
-              <a:rPr lang="en-US" sz="2800" dirty="0"/>
-              <a:t> salinities throughout the year. </a:t>
+              <a:t> tends to increase throughout each year, especially in the fall, and decrease at the start of a new year. This could be because sulfate-reducing microbes are less active as temperatures decrease at the end of each year, or this could be related to changes in precipitation or surface water salinities throughout the year. </a:t>
             </a:r>
           </a:p>
           <a:p>
@@ -3162,7 +3163,7 @@
             </a:pPr>
             <a:r>
               <a:rPr lang="en-US" sz="2800" dirty="0"/>
-              <a:t>SO</a:t>
+              <a:t>Peak annual SO</a:t>
             </a:r>
             <a:r>
               <a:rPr lang="en-US" sz="2800" baseline="-25000" dirty="0"/>
@@ -3590,7 +3591,7 @@
               <p:nvPr>
                 <p:extLst>
                   <p:ext uri="{D42A27DB-BD31-4B8C-83A1-F6EECF244321}">
-                    <p14:modId xmlns:p14="http://schemas.microsoft.com/office/powerpoint/2010/main" val="4074627904"/>
+                    <p14:modId xmlns:p14="http://schemas.microsoft.com/office/powerpoint/2010/main" val="132753171"/>
                   </p:ext>
                 </p:extLst>
               </p:nvPr>
@@ -3796,14 +3797,14 @@
                             <a:rPr lang="en-US" sz="2400" dirty="0">
                               <a:latin typeface="+mj-lt"/>
                             </a:rPr>
-                            <a:t>Sweethall</a:t>
+                            <a:t>Sweet Hall</a:t>
                           </a:r>
                           <a:endParaRPr sz="2400" dirty="0">
                             <a:latin typeface="+mj-lt"/>
                           </a:endParaRPr>
                         </a:p>
                       </a:txBody>
-                      <a:tcPr marL="91450" marR="91450" marT="45725" marB="45725">
+                      <a:tcPr marL="91450" marR="91450" marT="45725" marB="45725" anchor="ctr">
                         <a:lnL w="9525" cap="flat" cmpd="sng">
                           <a:solidFill>
                             <a:srgbClr val="242424"/>
@@ -3873,7 +3874,7 @@
                           </a:endParaRPr>
                         </a:p>
                       </a:txBody>
-                      <a:tcPr marL="91450" marR="91450" marT="45725" marB="45725">
+                      <a:tcPr marL="91450" marR="91450" marT="45725" marB="45725" anchor="ctr">
                         <a:lnL w="9525" cap="flat" cmpd="sng">
                           <a:solidFill>
                             <a:srgbClr val="242424"/>
@@ -3950,7 +3951,7 @@
                           </a:endParaRPr>
                         </a:p>
                       </a:txBody>
-                      <a:tcPr marL="91450" marR="91450" marT="45725" marB="45725">
+                      <a:tcPr marL="91450" marR="91450" marT="45725" marB="45725" anchor="ctr">
                         <a:lnL w="9525" cap="flat" cmpd="sng">
                           <a:solidFill>
                             <a:srgbClr val="242424"/>
@@ -4020,7 +4021,7 @@
                           </a:endParaRPr>
                         </a:p>
                       </a:txBody>
-                      <a:tcPr marL="91450" marR="91450" marT="45725" marB="45725">
+                      <a:tcPr marL="91450" marR="91450" marT="45725" marB="45725" anchor="ctr">
                         <a:lnL w="9525" cap="flat" cmpd="sng">
                           <a:solidFill>
                             <a:srgbClr val="242424"/>
@@ -4096,14 +4097,14 @@
                             <a:rPr lang="en-US" sz="2400" dirty="0">
                               <a:latin typeface="+mj-lt"/>
                             </a:rPr>
-                            <a:t>oneyStump</a:t>
+                            <a:t>oney Stump</a:t>
                           </a:r>
                           <a:endParaRPr sz="2400" dirty="0">
                             <a:latin typeface="+mj-lt"/>
                           </a:endParaRPr>
                         </a:p>
                       </a:txBody>
-                      <a:tcPr marL="91450" marR="91450" marT="45725" marB="45725">
+                      <a:tcPr marL="91450" marR="91450" marT="45725" marB="45725" anchor="ctr">
                         <a:lnL w="9525" cap="flat" cmpd="sng">
                           <a:solidFill>
                             <a:srgbClr val="242424"/>
@@ -4160,7 +4161,7 @@
                             <a:buNone/>
                           </a:pPr>
                           <a:r>
-                            <a:rPr lang="en-US" sz="2400" u="none" strike="noStrike" cap="none">
+                            <a:rPr lang="en-US" sz="2400" u="none" strike="noStrike" cap="none" dirty="0">
                               <a:solidFill>
                                 <a:srgbClr val="000000"/>
                               </a:solidFill>
@@ -4168,12 +4169,12 @@
                             </a:rPr>
                             <a:t>8-10</a:t>
                           </a:r>
-                          <a:endParaRPr sz="2400">
+                          <a:endParaRPr sz="2400" dirty="0">
                             <a:latin typeface="+mj-lt"/>
                           </a:endParaRPr>
                         </a:p>
                       </a:txBody>
-                      <a:tcPr marL="91450" marR="91450" marT="45725" marB="45725">
+                      <a:tcPr marL="91450" marR="91450" marT="45725" marB="45725" anchor="ctr">
                         <a:lnL w="9525" cap="flat" cmpd="sng">
                           <a:solidFill>
                             <a:srgbClr val="242424"/>
@@ -4256,7 +4257,7 @@
                           </a:endParaRPr>
                         </a:p>
                       </a:txBody>
-                      <a:tcPr marL="91450" marR="91450" marT="45725" marB="45725">
+                      <a:tcPr marL="91450" marR="91450" marT="45725" marB="45725" anchor="ctr">
                         <a:lnL w="9525" cap="flat" cmpd="sng">
                           <a:solidFill>
                             <a:srgbClr val="242424"/>
@@ -4326,7 +4327,7 @@
                           </a:endParaRPr>
                         </a:p>
                       </a:txBody>
-                      <a:tcPr marL="91450" marR="91450" marT="45725" marB="45725">
+                      <a:tcPr marL="91450" marR="91450" marT="45725" marB="45725" anchor="ctr">
                         <a:lnL w="9525" cap="flat" cmpd="sng">
                           <a:solidFill>
                             <a:srgbClr val="242424"/>
@@ -4582,7 +4583,7 @@
                   <p:nvPr/>
                 </p:nvPicPr>
                 <p:blipFill rotWithShape="1">
-                  <a:blip r:embed="rId6">
+                  <a:blip r:embed="rId5">
                     <a:extLst>
                       <a:ext uri="{28A0092B-C50C-407E-A947-70E740481C1C}">
                         <a14:useLocalDpi xmlns:a14="http://schemas.microsoft.com/office/drawing/2010/main" val="0"/>
@@ -4632,7 +4633,7 @@
                   <p:nvPr/>
                 </p:nvPicPr>
                 <p:blipFill rotWithShape="1">
-                  <a:blip r:embed="rId7" cstate="print">
+                  <a:blip r:embed="rId6" cstate="print">
                     <a:extLst>
                       <a:ext uri="{28A0092B-C50C-407E-A947-70E740481C1C}">
                         <a14:useLocalDpi xmlns:a14="http://schemas.microsoft.com/office/drawing/2010/main" val="0"/>
@@ -5047,8 +5048,8 @@
                 </p:nvSpPr>
                 <p:spPr>
                   <a:xfrm>
-                    <a:off x="1014980" y="9118251"/>
-                    <a:ext cx="1750958" cy="253253"/>
+                    <a:off x="998527" y="9183860"/>
+                    <a:ext cx="1750958" cy="260031"/>
                   </a:xfrm>
                   <a:prstGeom prst="rect">
                     <a:avLst/>
@@ -5063,7 +5064,7 @@
                   <a:p>
                     <a:r>
                       <a:rPr lang="en-US" sz="1800" dirty="0"/>
-                      <a:t>Sweethall</a:t>
+                      <a:t>Sweet Hall</a:t>
                     </a:r>
                   </a:p>
                 </p:txBody>
@@ -5311,7 +5312,7 @@
             </a:r>
             <a:r>
               <a:rPr lang="en-US" sz="2800" dirty="0"/>
-              <a:t> – depth relationship and surface water SO</a:t>
+              <a:t> - depth relationship and surface water SO</a:t>
             </a:r>
             <a:r>
               <a:rPr lang="en-US" sz="2800" baseline="-25000" dirty="0"/>
@@ -5323,7 +5324,7 @@
             </a:r>
             <a:r>
               <a:rPr lang="en-US" sz="2800" dirty="0"/>
-              <a:t> patterns to determine if there are patterns that explain its variability across sites and zones. </a:t>
+              <a:t> patterns to determine if there are trends that explain the variability across sites and zones. </a:t>
             </a:r>
           </a:p>
         </p:txBody>
@@ -5522,12 +5523,9 @@
             </a:r>
             <a:r>
               <a:rPr lang="en-US" sz="2800" dirty="0"/>
-              <a:t>, n=2,293) </a:t>
-            </a:r>
-            <a:r>
-              <a:rPr lang="en-US" sz="2800" strike="sngStrike" dirty="0"/>
-              <a:t>in 2,293 samples</a:t>
-            </a:r>
+              <a:t>, n = 2,293). </a:t>
+            </a:r>
+            <a:endParaRPr lang="en-US" sz="2800" strike="sngStrike" dirty="0"/>
           </a:p>
           <a:p>
             <a:pPr marL="457200" indent="-457200">
@@ -5548,7 +5546,7 @@
             </a:r>
             <a:r>
               <a:rPr lang="en-US" sz="2800" dirty="0"/>
-              <a:t> increased from upland forest through transition zones to the wetland </a:t>
+              <a:t> increased from upland forest through transition zones to the wetland. </a:t>
             </a:r>
           </a:p>
           <a:p>
@@ -5806,7 +5804,7 @@
             </a:r>
             <a:r>
               <a:rPr lang="en-US" sz="2800" dirty="0"/>
-              <a:t> increases with increasing groundwater salinity, groundwater water level, soil electrical conductivity, and soil volumetric water content. </a:t>
+              <a:t> increases with increasing groundwater salinity, groundwater level, soil electrical conductivity, and soil volumetric water content. </a:t>
             </a:r>
           </a:p>
           <a:p>
@@ -6007,7 +6005,7 @@
                 <a:latin typeface="Arial" panose="020B0604020202020204" pitchFamily="34" charset="0"/>
                 <a:cs typeface="Arial" panose="020B0604020202020204" pitchFamily="34" charset="0"/>
               </a:rPr>
-              <a:t>Porewater was sampled at three soil depths: 10, 20, and 45 cm</a:t>
+              <a:t>Porewater was sampled at three soil depths: 10, 20, and 45 cm. </a:t>
             </a:r>
           </a:p>
           <a:p>
@@ -6016,15 +6014,24 @@
               <a:buChar char="•"/>
             </a:pPr>
             <a:r>
-              <a:rPr lang="en-US" sz="2800" dirty="0"/>
+              <a:rPr lang="en-US" sz="2800" dirty="0">
+                <a:latin typeface="Arial" panose="020B0604020202020204" pitchFamily="34" charset="0"/>
+                <a:cs typeface="Arial" panose="020B0604020202020204" pitchFamily="34" charset="0"/>
+              </a:rPr>
               <a:t>SO</a:t>
             </a:r>
             <a:r>
-              <a:rPr lang="en-US" sz="2800" baseline="-25000" dirty="0"/>
+              <a:rPr lang="en-US" sz="2800" baseline="-25000" dirty="0">
+                <a:latin typeface="Arial" panose="020B0604020202020204" pitchFamily="34" charset="0"/>
+                <a:cs typeface="Arial" panose="020B0604020202020204" pitchFamily="34" charset="0"/>
+              </a:rPr>
               <a:t>4</a:t>
             </a:r>
             <a:r>
-              <a:rPr lang="en-US" sz="2800" baseline="30000" dirty="0"/>
+              <a:rPr lang="en-US" sz="2800" baseline="30000" dirty="0">
+                <a:latin typeface="Arial" panose="020B0604020202020204" pitchFamily="34" charset="0"/>
+                <a:cs typeface="Arial" panose="020B0604020202020204" pitchFamily="34" charset="0"/>
+              </a:rPr>
               <a:t>2-</a:t>
             </a:r>
             <a:r>
@@ -6097,7 +6104,7 @@
         </p:nvCxnSpPr>
         <p:spPr>
           <a:xfrm>
-            <a:off x="21400102" y="20296787"/>
+            <a:off x="21488400" y="20296787"/>
             <a:ext cx="0" cy="3161485"/>
           </a:xfrm>
           <a:prstGeom prst="line">
@@ -6141,7 +6148,7 @@
         </p:nvCxnSpPr>
         <p:spPr>
           <a:xfrm>
-            <a:off x="24600502" y="20337022"/>
+            <a:off x="24688800" y="20337022"/>
             <a:ext cx="0" cy="3161485"/>
           </a:xfrm>
           <a:prstGeom prst="line">
@@ -6185,7 +6192,7 @@
         </p:nvCxnSpPr>
         <p:spPr>
           <a:xfrm>
-            <a:off x="28715302" y="20337021"/>
+            <a:off x="28791502" y="20337020"/>
             <a:ext cx="0" cy="3161485"/>
           </a:xfrm>
           <a:prstGeom prst="line">
@@ -6229,7 +6236,7 @@
         </p:nvCxnSpPr>
         <p:spPr>
           <a:xfrm>
-            <a:off x="31306102" y="20337020"/>
+            <a:off x="31394400" y="20337020"/>
             <a:ext cx="0" cy="3161485"/>
           </a:xfrm>
           <a:prstGeom prst="line">
@@ -6273,7 +6280,7 @@
         </p:nvCxnSpPr>
         <p:spPr>
           <a:xfrm>
-            <a:off x="32982502" y="20337020"/>
+            <a:off x="33070800" y="20337020"/>
             <a:ext cx="0" cy="3161485"/>
           </a:xfrm>
           <a:prstGeom prst="line">
@@ -6317,7 +6324,7 @@
         </p:nvCxnSpPr>
         <p:spPr>
           <a:xfrm>
-            <a:off x="20714302" y="24906072"/>
+            <a:off x="20726400" y="24906072"/>
             <a:ext cx="0" cy="3200400"/>
           </a:xfrm>
           <a:prstGeom prst="line">
@@ -6361,7 +6368,7 @@
         </p:nvCxnSpPr>
         <p:spPr>
           <a:xfrm>
-            <a:off x="23457502" y="24906071"/>
+            <a:off x="23469600" y="24906071"/>
             <a:ext cx="0" cy="3200401"/>
           </a:xfrm>
           <a:prstGeom prst="line">
@@ -6405,7 +6412,7 @@
         </p:nvCxnSpPr>
         <p:spPr>
           <a:xfrm>
-            <a:off x="24829102" y="24906071"/>
+            <a:off x="24841200" y="24906071"/>
             <a:ext cx="0" cy="3200401"/>
           </a:xfrm>
           <a:prstGeom prst="line">
@@ -6449,7 +6456,7 @@
         </p:nvCxnSpPr>
         <p:spPr>
           <a:xfrm>
-            <a:off x="28791502" y="24906071"/>
+            <a:off x="28879800" y="24906071"/>
             <a:ext cx="0" cy="3200401"/>
           </a:xfrm>
           <a:prstGeom prst="line">
@@ -6493,7 +6500,7 @@
         </p:nvCxnSpPr>
         <p:spPr>
           <a:xfrm>
-            <a:off x="31534702" y="24906071"/>
+            <a:off x="31623000" y="24906071"/>
             <a:ext cx="0" cy="3200401"/>
           </a:xfrm>
           <a:prstGeom prst="line">
@@ -6537,7 +6544,7 @@
         </p:nvCxnSpPr>
         <p:spPr>
           <a:xfrm>
-            <a:off x="32906302" y="24906071"/>
+            <a:off x="32994600" y="24906071"/>
             <a:ext cx="0" cy="3200401"/>
           </a:xfrm>
           <a:prstGeom prst="line">
@@ -6580,7 +6587,7 @@
           <p:nvPr/>
         </p:nvPicPr>
         <p:blipFill>
-          <a:blip r:embed="rId8">
+          <a:blip r:embed="rId7">
             <a:extLst>
               <a:ext uri="{28A0092B-C50C-407E-A947-70E740481C1C}">
                 <a14:useLocalDpi xmlns:a14="http://schemas.microsoft.com/office/drawing/2010/main" val="0"/>
@@ -6616,7 +6623,7 @@
           <p:nvPr/>
         </p:nvPicPr>
         <p:blipFill>
-          <a:blip r:embed="rId9">
+          <a:blip r:embed="rId8">
             <a:extLst>
               <a:ext uri="{28A0092B-C50C-407E-A947-70E740481C1C}">
                 <a14:useLocalDpi xmlns:a14="http://schemas.microsoft.com/office/drawing/2010/main" val="0"/>
@@ -6647,11 +6654,6 @@
   <p:clrMapOvr>
     <a:masterClrMapping/>
   </p:clrMapOvr>
-  <p:extLst>
-    <p:ext uri="{6950BFC3-D8DA-4A85-94F7-54DA5524770B}">
-      <p188:commentRel xmlns:p188="http://schemas.microsoft.com/office/powerpoint/2018/8/main" r:id="rId3"/>
-    </p:ext>
-  </p:extLst>
 </p:sld>
 </file>
 

</xml_diff>